<commit_message>
thesis: Ch7 convergent-evidence + review episode; fix episode dates; refresh defense deck
- 07_conclusion: RQ3 answer now cites the 80-case bilingual golden-set
  convergent evidence (97.5% sentiment / 86.3% urgency, exact-tag lift
  p=0.001, limits disclosed) and the §5A.8 external-review episode —
  closes the consistency reviewer's report-only omission
- 04/05A.8/App D: correct episode dates (PRs and 17/17 verification all
  17 July; window 16–17 July — '19 July' predated the events)
- defense deck: repo-relative paths (old Thesis_writing tree retired),
  published 17-Jul run numbers (n=80, 97.5/86.3, tag F1 80.2 vs 55.5
  exact, hallucination 2.5% EN-scope), n=80 significance story in
  slide-8/10 notes, rebuilt defense_deck.pptx

Co-Authored-By: Claude Fable 5 <noreply@anthropic.com>
Claude-Session: https://claude.ai/code/session_01XGWpb7K6Gote54C32yAbzD
</commit_message>
<xml_diff>
--- a/thesis/defense/defense_deck.pptx
+++ b/thesis/defense/defense_deck.pptx
@@ -4,9 +4,6 @@
   <p:sldMasterIdLst>
     <p:sldMasterId id="2147483648" r:id="rId1"/>
   </p:sldMasterIdLst>
-  <p:notesMasterIdLst>
-    <p:notesMasterId r:id="rId15"/>
-  </p:notesMasterIdLst>
   <p:sldIdLst>
     <p:sldId id="256" r:id="rId2"/>
     <p:sldId id="257" r:id="rId3"/>
@@ -22,6 +19,9 @@
     <p:sldId id="267" r:id="rId13"/>
     <p:sldId id="268" r:id="rId14"/>
   </p:sldIdLst>
+  <p:notesMasterIdLst>
+    <p:notesMasterId r:id="rId15"/>
+  </p:notesMasterIdLst>
   <p:sldSz cx="12192000" cy="6858000"/>
   <p:notesSz cx="6858000" cy="12192000"/>
   <p:defaultTextStyle>
@@ -116,11 +116,6 @@
       </a:defRPr>
     </a:lvl9pPr>
   </p:defaultTextStyle>
-  <p:extLst>
-    <p:ext uri="{EFAFB233-063F-42B5-8137-9DF3F51BA10A}">
-      <p15:sldGuideLst xmlns:p15="http://schemas.microsoft.com/office/powerpoint/2012/main"/>
-    </p:ext>
-  </p:extLst>
 </p:presentation>
 </file>
 
@@ -146,10 +141,234 @@
           <a:chExt cx="0" cy="0"/>
         </a:xfrm>
       </p:grpSpPr>
+      <p:sp>
+        <p:nvSpPr>
+          <p:cNvPr id="2" name="Header Placeholder 1"/>
+          <p:cNvSpPr>
+            <a:spLocks noGrp="1"/>
+          </p:cNvSpPr>
+          <p:nvPr>
+            <p:ph type="hdr" sz="quarter"/>
+          </p:nvPr>
+        </p:nvSpPr>
+        <p:spPr>
+          <a:xfrm>
+            <a:off x="0" y="0"/>
+            <a:ext cx="2971800" cy="458788"/>
+          </a:xfrm>
+          <a:prstGeom prst="rect">
+            <a:avLst/>
+          </a:prstGeom>
+        </p:spPr>
+        <p:txBody>
+          <a:bodyPr vert="horz" lIns="91440" tIns="45720" rIns="91440" bIns="45720" rtlCol="0"/>
+          <a:lstStyle>
+            <a:lvl1pPr algn="l">
+              <a:defRPr sz="1200"/>
+            </a:lvl1pPr>
+          </a:lstStyle>
+          <a:p>
+            <a:endParaRPr lang="en-US"/>
+          </a:p>
+        </p:txBody>
+      </p:sp>
+      <p:sp>
+        <p:nvSpPr>
+          <p:cNvPr id="3" name="Date Placeholder 2"/>
+          <p:cNvSpPr>
+            <a:spLocks noGrp="1"/>
+          </p:cNvSpPr>
+          <p:nvPr>
+            <p:ph type="dt" idx="1"/>
+          </p:nvPr>
+        </p:nvSpPr>
+        <p:spPr>
+          <a:xfrm>
+            <a:off x="3884613" y="0"/>
+            <a:ext cx="2971800" cy="458788"/>
+          </a:xfrm>
+          <a:prstGeom prst="rect">
+            <a:avLst/>
+          </a:prstGeom>
+        </p:spPr>
+        <p:txBody>
+          <a:bodyPr vert="horz" lIns="91440" tIns="45720" rIns="91440" bIns="45720" rtlCol="0"/>
+          <a:lstStyle>
+            <a:lvl1pPr algn="r">
+              <a:defRPr sz="1200"/>
+            </a:lvl1pPr>
+          </a:lstStyle>
+          <a:p>
+            <a:fld id="{5282F153-3F37-0F45-9E97-73ACFA13230C}" type="datetimeFigureOut">
+              <a:rPr lang="en-US"/>
+              <a:t>7/23/19</a:t>
+            </a:fld>
+            <a:endParaRPr lang="en-US"/>
+          </a:p>
+        </p:txBody>
+      </p:sp>
+      <p:sp>
+        <p:nvSpPr>
+          <p:cNvPr id="4" name="Slide Image Placeholder 3"/>
+          <p:cNvSpPr>
+            <a:spLocks noGrp="1" noRot="1" noChangeAspect="1"/>
+          </p:cNvSpPr>
+          <p:nvPr>
+            <p:ph type="sldImg" idx="2"/>
+          </p:nvPr>
+        </p:nvSpPr>
+        <p:spPr>
+          <a:xfrm>
+            <a:off x="685800" y="1143000"/>
+            <a:ext cx="5486400" cy="3086100"/>
+          </a:xfrm>
+          <a:prstGeom prst="rect">
+            <a:avLst/>
+          </a:prstGeom>
+          <a:noFill/>
+          <a:ln w="12700">
+            <a:solidFill>
+              <a:prstClr val="black"/>
+            </a:solidFill>
+          </a:ln>
+        </p:spPr>
+        <p:txBody>
+          <a:bodyPr vert="horz" lIns="91440" tIns="45720" rIns="91440" bIns="45720" rtlCol="0" anchor="ctr"/>
+          <a:lstStyle/>
+          <a:p>
+            <a:endParaRPr lang="en-US"/>
+          </a:p>
+        </p:txBody>
+      </p:sp>
+      <p:sp>
+        <p:nvSpPr>
+          <p:cNvPr id="5" name="Notes Placeholder 4"/>
+          <p:cNvSpPr>
+            <a:spLocks noGrp="1"/>
+          </p:cNvSpPr>
+          <p:nvPr>
+            <p:ph type="body" sz="quarter" idx="3"/>
+          </p:nvPr>
+        </p:nvSpPr>
+        <p:spPr>
+          <a:xfrm>
+            <a:off x="685800" y="4400550"/>
+            <a:ext cx="5486400" cy="3600450"/>
+          </a:xfrm>
+          <a:prstGeom prst="rect">
+            <a:avLst/>
+          </a:prstGeom>
+        </p:spPr>
+        <p:txBody>
+          <a:bodyPr vert="horz" lIns="91440" tIns="45720" rIns="91440" bIns="45720" rtlCol="0"/>
+          <a:lstStyle/>
+          <a:p>
+            <a:pPr lvl="0"/>
+            <a:r>
+              <a:rPr lang="en-US"/>
+              <a:t>Click to edit Master text styles</a:t>
+            </a:r>
+          </a:p>
+          <a:p>
+            <a:pPr lvl="1"/>
+            <a:r>
+              <a:rPr lang="en-US"/>
+              <a:t>Second level</a:t>
+            </a:r>
+          </a:p>
+          <a:p>
+            <a:pPr lvl="2"/>
+            <a:r>
+              <a:rPr lang="en-US"/>
+              <a:t>Third level</a:t>
+            </a:r>
+          </a:p>
+          <a:p>
+            <a:pPr lvl="3"/>
+            <a:r>
+              <a:rPr lang="en-US"/>
+              <a:t>Fourth level</a:t>
+            </a:r>
+          </a:p>
+          <a:p>
+            <a:pPr lvl="4"/>
+            <a:r>
+              <a:rPr lang="en-US"/>
+              <a:t>Fifth level</a:t>
+            </a:r>
+          </a:p>
+        </p:txBody>
+      </p:sp>
+      <p:sp>
+        <p:nvSpPr>
+          <p:cNvPr id="6" name="Footer Placeholder 5"/>
+          <p:cNvSpPr>
+            <a:spLocks noGrp="1"/>
+          </p:cNvSpPr>
+          <p:nvPr>
+            <p:ph type="ftr" sz="quarter" idx="4"/>
+          </p:nvPr>
+        </p:nvSpPr>
+        <p:spPr>
+          <a:xfrm>
+            <a:off x="0" y="8685213"/>
+            <a:ext cx="2971800" cy="458787"/>
+          </a:xfrm>
+          <a:prstGeom prst="rect">
+            <a:avLst/>
+          </a:prstGeom>
+        </p:spPr>
+        <p:txBody>
+          <a:bodyPr vert="horz" lIns="91440" tIns="45720" rIns="91440" bIns="45720" rtlCol="0" anchor="b"/>
+          <a:lstStyle>
+            <a:lvl1pPr algn="l">
+              <a:defRPr sz="1200"/>
+            </a:lvl1pPr>
+          </a:lstStyle>
+          <a:p>
+            <a:endParaRPr lang="en-US"/>
+          </a:p>
+        </p:txBody>
+      </p:sp>
+      <p:sp>
+        <p:nvSpPr>
+          <p:cNvPr id="7" name="Slide Number Placeholder 6"/>
+          <p:cNvSpPr>
+            <a:spLocks noGrp="1"/>
+          </p:cNvSpPr>
+          <p:nvPr>
+            <p:ph type="sldNum" sz="quarter" idx="5"/>
+          </p:nvPr>
+        </p:nvSpPr>
+        <p:spPr>
+          <a:xfrm>
+            <a:off x="3884613" y="8685213"/>
+            <a:ext cx="2971800" cy="458787"/>
+          </a:xfrm>
+          <a:prstGeom prst="rect">
+            <a:avLst/>
+          </a:prstGeom>
+        </p:spPr>
+        <p:txBody>
+          <a:bodyPr vert="horz" lIns="91440" tIns="45720" rIns="91440" bIns="45720" rtlCol="0" anchor="b"/>
+          <a:lstStyle>
+            <a:lvl1pPr algn="r">
+              <a:defRPr sz="1200"/>
+            </a:lvl1pPr>
+          </a:lstStyle>
+          <a:p>
+            <a:fld id="{CE5E9CC1-C706-0F49-92D6-E571CC5EEA8F}" type="slidenum">
+              <a:rPr lang="en-US"/>
+              <a:t>‹#›</a:t>
+            </a:fld>
+            <a:endParaRPr lang="en-US"/>
+          </a:p>
+        </p:txBody>
+      </p:sp>
     </p:spTree>
     <p:extLst>
       <p:ext uri="{BB962C8B-B14F-4D97-AF65-F5344CB8AC3E}">
-        <p14:creationId xmlns:p14="http://schemas.microsoft.com/office/powerpoint/2010/main" val="2119406421"/>
+        <p14:creationId xmlns:p14="http://schemas.microsoft.com/office/powerpoint/2010/main" val="1024086991"/>
       </p:ext>
     </p:extLst>
   </p:cSld>
@@ -297,6 +516,7 @@
               <a:rPr lang="en-US" dirty="0"/>
               <a:t>60–90s. Frame in one breath: organisations collect more feedback than ever, yet fewer than a third systematically close the loop. This thesis designs, builds and evaluates a platform where the loop is not just closed but GOVERNED and MEASURED — and where what worked becomes organisational memory. One system, studied through Design Science Research.</a:t>
             </a:r>
+            <a:endParaRPr lang="en-US" dirty="0"/>
           </a:p>
         </p:txBody>
       </p:sp>
@@ -382,8 +602,9 @@
           <a:p>
             <a:r>
               <a:rPr lang="en-US" dirty="0"/>
-              <a:t>90s. Pre-empt the researcher-as-founder question here: externally-labelled gold sets, standardised instruments, reproducible harness, and this matrix. Conflict of interest is declared in the front matter and managed by method, not denial.</a:t>
-            </a:r>
+              <a:t>90s. Pre-empt the researcher-as-founder question here: externally-labelled gold sets, standardised instruments, reproducible harness, and this matrix. Conflict of interest is declared in the front matter and managed by method, not denial. If asked about the July external reviews (§5A.8): two independent LLM strategic reviews, 45 claims adversarially verified (27 confirmed / 13 partial / 2 refuted), 20 hardening PRs, 17/17 live production checks — and the refuted claims are themselves a finding: unsurfaced capability reads as absent.</a:t>
+            </a:r>
+            <a:endParaRPr lang="en-US" dirty="0"/>
           </a:p>
         </p:txBody>
       </p:sp>
@@ -471,6 +692,7 @@
               <a:rPr lang="en-US" dirty="0"/>
               <a:t>90s. Category has moved TOWARD the thesis: analysts declared the insight half commoditised. Each rival owns a fragment; nobody verifiably holds the combination — and we apply the same verification standard to ourselves (previous slide).</a:t>
             </a:r>
+            <a:endParaRPr lang="en-US" dirty="0"/>
           </a:p>
         </p:txBody>
       </p:sp>
@@ -558,6 +780,7 @@
               <a:rPr lang="en-US" dirty="0"/>
               <a:t>90s. Say number ① slowly: the single most important next artifact — a real action, a real metric, a contract, a window, a verdict. The method is already specified (ITS, then SDID). Everything else is engineering.</a:t>
             </a:r>
+            <a:endParaRPr lang="en-US" dirty="0"/>
           </a:p>
         </p:txBody>
       </p:sp>
@@ -645,6 +868,7 @@
               <a:rPr lang="en-US" dirty="0"/>
               <a:t>60s. Read the four contributions crisply, end on the one-liner, invite questions. Likely probes: novelty vs MemoryBank (answered on slide 5), founder COI (slide 10), simulated outcomes (slide 9), why not RCTs (slide 12 — ITS/SDID).</a:t>
             </a:r>
+            <a:endParaRPr lang="en-US" dirty="0"/>
           </a:p>
         </p:txBody>
       </p:sp>
@@ -732,6 +956,7 @@
               <a:rPr lang="en-US" dirty="0"/>
               <a:t>90s. Anchor the gap in Bone et al., then the Uber experiment — the strongest evidence that acting without measuring can make things worse. End on the central claim; everything after is those two primitives.</a:t>
             </a:r>
+            <a:endParaRPr lang="en-US" dirty="0"/>
           </a:p>
         </p:txBody>
       </p:sp>
@@ -819,6 +1044,7 @@
               <a:rPr lang="en-US" dirty="0"/>
               <a:t>90s. Say why DSR: the question is 'what works by design', not 'what is'. Note H1–H8 map under these four RQs. Flag honestly that RQ4 data collection is in progress — protocol and instruments are complete and in the appendix.</a:t>
             </a:r>
+            <a:endParaRPr lang="en-US" dirty="0"/>
           </a:p>
         </p:txBody>
       </p:sp>
@@ -906,6 +1132,7 @@
               <a:rPr lang="en-US" dirty="0"/>
               <a:t>2 min. Walk the diagram left to right: sources → ingestion → enrich → synthesize → rules → the approval diamond → execute → measure → learn, with governance cross-cutting. Emphasise the architectural principle: bounded model, deterministic loop. Mention it exists in two builds; the evaluated build is CLARA (FastAPI + LangGraph).</a:t>
             </a:r>
+            <a:endParaRPr lang="en-US" dirty="0"/>
           </a:p>
         </p:txBody>
       </p:sp>
@@ -993,6 +1220,7 @@
               <a:rPr lang="en-US" dirty="0"/>
               <a:t>2 min. One sentence each; slow down on decay (the novelty boundary vs MemoryBank — examiners may probe novelty; we cite the prior art ourselves and position precisely) and on industry profiles (adaptation without retraining, demonstrated on three real sectors).</a:t>
             </a:r>
+            <a:endParaRPr lang="en-US" dirty="0"/>
           </a:p>
         </p:txBody>
       </p:sp>
@@ -1080,6 +1308,7 @@
               <a:rPr lang="en-US" dirty="0"/>
               <a:t>2 min. This is the RAI thesis heart. Two lines matter most: (1) the gate deliberately EXCEEDS Art 14 because awareness alone doesn't de-bias overseers; (2) the code review found declared-but-unenforced controls — and the governance instrumentation is what made that visible. Honesty as methodology.</a:t>
             </a:r>
+            <a:endParaRPr lang="en-US" dirty="0"/>
           </a:p>
         </p:txBody>
       </p:sp>
@@ -1167,6 +1396,7 @@
               <a:rPr lang="en-US" dirty="0"/>
               <a:t>90s. Stress the honesty features: real data only (synthetic excluded), star ratings as a NON-CIRCULAR sentiment gold, seed labels external to the artifact, every number written by a reproducible harness — no hand-typed metrics.</a:t>
             </a:r>
+            <a:endParaRPr lang="en-US" dirty="0"/>
           </a:p>
         </p:txBody>
       </p:sp>
@@ -1252,8 +1482,9 @@
           <a:p>
             <a:r>
               <a:rPr lang="en-US" dirty="0"/>
-              <a:t>2 min. The three-rung story. Be precise about gold standards: the 0.37/0.78 rows are the thesis harness (188 seed-labelled signals); the LLM numbers are the artifact's committed in-repo eval on a DIFFERENT 60-case golden set — convergent evidence, not the same table. If probed: exemplar A/B lift was NOT significant at n=60 (McNemar p≈1.0) — we report that ourselves.</a:t>
-            </a:r>
+              <a:t>2 min. The three-rung story. Be precise about gold standards: the 0.37/0.78 rows are the thesis harness (188 seed-labelled signals); the LLM numbers are the artifact's committed in-repo eval on a DIFFERENT 80-case bilingual golden set (20 authored German cases — disclosed) — convergent evidence, not the same table. If probed on exemplars: at n=60 the A/B was not significant (p≈1.0); at n=80, after adding German exemplars, the exact-tag-set lift IS significant (8.75%→28.75% per item, in-run paired McNemar p=0.001) while urgency stays underpowered (81.25%→86.25%, p=0.219) — we report both ourselves. The in-run paired A/B is the designed inference; the model is non-deterministic even at temperature 0.</a:t>
+            </a:r>
+            <a:endParaRPr lang="en-US" dirty="0"/>
           </a:p>
         </p:txBody>
       </p:sp>
@@ -1341,6 +1572,7 @@
               <a:rPr lang="en-US" dirty="0"/>
               <a:t>90s. This slide wins or loses trust. Lead with the number, land on the boundary: mechanism measured, benefit pending. Examiners reward the distinction — it's also written into the traceability matrix (next slide).</a:t>
             </a:r>
+            <a:endParaRPr lang="en-US" dirty="0"/>
           </a:p>
         </p:txBody>
       </p:sp>
@@ -1413,11 +1645,6 @@
 <file path=ppt/slideMasters/slideMaster1.xml><?xml version="1.0" encoding="utf-8"?>
 <p:sldMaster xmlns:a="http://schemas.openxmlformats.org/drawingml/2006/main" xmlns:r="http://schemas.openxmlformats.org/officeDocument/2006/relationships" xmlns:p="http://schemas.openxmlformats.org/presentationml/2006/main">
   <p:cSld>
-    <p:bg>
-      <p:bgRef idx="1001">
-        <a:schemeClr val="bg1"/>
-      </p:bgRef>
-    </p:bg>
     <p:spTree>
       <p:nvGrpSpPr>
         <p:cNvPr id="1" name=""/>
@@ -1700,7 +1927,6 @@
         <a:solidFill>
           <a:srgbClr val="1E2761"/>
         </a:solidFill>
-        <a:effectLst/>
       </p:bgPr>
     </p:bg>
     <p:spTree>
@@ -1738,7 +1964,7 @@
           <a:bodyPr wrap="square" rtlCol="0" anchor="ctr"/>
           <a:lstStyle/>
           <a:p>
-            <a:pPr marL="0" indent="0">
+            <a:pPr indent="0" marL="0">
               <a:buNone/>
             </a:pPr>
             <a:r>
@@ -1777,7 +2003,7 @@
           <a:bodyPr wrap="square" rtlCol="0" anchor="ctr"/>
           <a:lstStyle/>
           <a:p>
-            <a:pPr marL="0" indent="0">
+            <a:pPr indent="0" marL="0">
               <a:buNone/>
             </a:pPr>
             <a:r>
@@ -1794,7 +2020,7 @@
             <a:endParaRPr lang="en-US" sz="2000" dirty="0"/>
           </a:p>
           <a:p>
-            <a:pPr marL="0" indent="0">
+            <a:pPr indent="0" marL="0">
               <a:buNone/>
             </a:pPr>
             <a:r>
@@ -1831,13 +2057,6 @@
           </a:solidFill>
           <a:ln/>
         </p:spPr>
-        <p:txBody>
-          <a:bodyPr/>
-          <a:lstStyle/>
-          <a:p>
-            <a:endParaRPr lang="en-DE"/>
-          </a:p>
-        </p:txBody>
       </p:sp>
       <p:sp>
         <p:nvSpPr>
@@ -1860,7 +2079,7 @@
           <a:bodyPr wrap="square" lIns="0" tIns="0" rIns="0" bIns="0" rtlCol="0" anchor="ctr"/>
           <a:lstStyle/>
           <a:p>
-            <a:pPr marL="0" indent="0" algn="ctr">
+            <a:pPr algn="ctr" indent="0" marL="0">
               <a:buNone/>
             </a:pPr>
             <a:r>
@@ -1899,7 +2118,7 @@
           <a:bodyPr wrap="square" lIns="0" tIns="0" rIns="0" bIns="0" rtlCol="0" anchor="ctr"/>
           <a:lstStyle/>
           <a:p>
-            <a:pPr marL="0" indent="0">
+            <a:pPr indent="0" marL="0">
               <a:buNone/>
             </a:pPr>
             <a:r>
@@ -1938,7 +2157,7 @@
           <a:bodyPr wrap="square" lIns="0" tIns="0" rIns="0" bIns="0" rtlCol="0" anchor="ctr"/>
           <a:lstStyle/>
           <a:p>
-            <a:pPr marL="0" indent="0">
+            <a:pPr indent="0" marL="0">
               <a:buNone/>
             </a:pPr>
             <a:r>
@@ -1975,13 +2194,6 @@
           </a:solidFill>
           <a:ln/>
         </p:spPr>
-        <p:txBody>
-          <a:bodyPr/>
-          <a:lstStyle/>
-          <a:p>
-            <a:endParaRPr lang="en-DE"/>
-          </a:p>
-        </p:txBody>
       </p:sp>
       <p:sp>
         <p:nvSpPr>
@@ -2004,7 +2216,7 @@
           <a:bodyPr wrap="square" lIns="0" tIns="0" rIns="0" bIns="0" rtlCol="0" anchor="ctr"/>
           <a:lstStyle/>
           <a:p>
-            <a:pPr marL="0" indent="0" algn="ctr">
+            <a:pPr algn="ctr" indent="0" marL="0">
               <a:buNone/>
             </a:pPr>
             <a:r>
@@ -2043,7 +2255,7 @@
           <a:bodyPr wrap="square" lIns="0" tIns="0" rIns="0" bIns="0" rtlCol="0" anchor="ctr"/>
           <a:lstStyle/>
           <a:p>
-            <a:pPr marL="0" indent="0">
+            <a:pPr indent="0" marL="0">
               <a:buNone/>
             </a:pPr>
             <a:r>
@@ -2082,7 +2294,7 @@
           <a:bodyPr wrap="square" lIns="0" tIns="0" rIns="0" bIns="0" rtlCol="0" anchor="ctr"/>
           <a:lstStyle/>
           <a:p>
-            <a:pPr marL="0" indent="0">
+            <a:pPr indent="0" marL="0">
               <a:buNone/>
             </a:pPr>
             <a:r>
@@ -2119,13 +2331,6 @@
           </a:solidFill>
           <a:ln/>
         </p:spPr>
-        <p:txBody>
-          <a:bodyPr/>
-          <a:lstStyle/>
-          <a:p>
-            <a:endParaRPr lang="en-DE"/>
-          </a:p>
-        </p:txBody>
       </p:sp>
       <p:sp>
         <p:nvSpPr>
@@ -2148,7 +2353,7 @@
           <a:bodyPr wrap="square" lIns="0" tIns="0" rIns="0" bIns="0" rtlCol="0" anchor="ctr"/>
           <a:lstStyle/>
           <a:p>
-            <a:pPr marL="0" indent="0" algn="ctr">
+            <a:pPr algn="ctr" indent="0" marL="0">
               <a:buNone/>
             </a:pPr>
             <a:r>
@@ -2187,7 +2392,7 @@
           <a:bodyPr wrap="square" lIns="0" tIns="0" rIns="0" bIns="0" rtlCol="0" anchor="ctr"/>
           <a:lstStyle/>
           <a:p>
-            <a:pPr marL="0" indent="0">
+            <a:pPr indent="0" marL="0">
               <a:buNone/>
             </a:pPr>
             <a:r>
@@ -2226,7 +2431,7 @@
           <a:bodyPr wrap="square" lIns="0" tIns="0" rIns="0" bIns="0" rtlCol="0" anchor="ctr"/>
           <a:lstStyle/>
           <a:p>
-            <a:pPr marL="0" indent="0">
+            <a:pPr indent="0" marL="0">
               <a:buNone/>
             </a:pPr>
             <a:r>
@@ -2263,13 +2468,6 @@
           </a:solidFill>
           <a:ln/>
         </p:spPr>
-        <p:txBody>
-          <a:bodyPr/>
-          <a:lstStyle/>
-          <a:p>
-            <a:endParaRPr lang="en-DE"/>
-          </a:p>
-        </p:txBody>
       </p:sp>
       <p:sp>
         <p:nvSpPr>
@@ -2292,7 +2490,7 @@
           <a:bodyPr wrap="square" lIns="0" tIns="0" rIns="0" bIns="0" rtlCol="0" anchor="ctr"/>
           <a:lstStyle/>
           <a:p>
-            <a:pPr marL="0" indent="0" algn="ctr">
+            <a:pPr algn="ctr" indent="0" marL="0">
               <a:buNone/>
             </a:pPr>
             <a:r>
@@ -2331,7 +2529,7 @@
           <a:bodyPr wrap="square" lIns="0" tIns="0" rIns="0" bIns="0" rtlCol="0" anchor="ctr"/>
           <a:lstStyle/>
           <a:p>
-            <a:pPr marL="0" indent="0">
+            <a:pPr indent="0" marL="0">
               <a:buNone/>
             </a:pPr>
             <a:r>
@@ -2370,7 +2568,7 @@
           <a:bodyPr wrap="square" rtlCol="0" anchor="ctr"/>
           <a:lstStyle/>
           <a:p>
-            <a:pPr marL="0" indent="0">
+            <a:pPr indent="0" marL="0">
               <a:buNone/>
             </a:pPr>
             <a:r>
@@ -2434,7 +2632,7 @@
           <a:bodyPr wrap="square" rtlCol="0" anchor="ctr"/>
           <a:lstStyle/>
           <a:p>
-            <a:pPr marL="0" indent="0">
+            <a:pPr indent="0" marL="0">
               <a:buNone/>
             </a:pPr>
             <a:r>
@@ -2473,7 +2671,7 @@
           <a:bodyPr wrap="square" rtlCol="0" anchor="ctr"/>
           <a:lstStyle/>
           <a:p>
-            <a:pPr marL="0" indent="0">
+            <a:pPr indent="0" marL="0">
               <a:buNone/>
             </a:pPr>
             <a:r>
@@ -2510,13 +2708,6 @@
           </a:solidFill>
           <a:ln/>
         </p:spPr>
-        <p:txBody>
-          <a:bodyPr/>
-          <a:lstStyle/>
-          <a:p>
-            <a:endParaRPr lang="en-DE"/>
-          </a:p>
-        </p:txBody>
       </p:sp>
       <p:sp>
         <p:nvSpPr>
@@ -2539,7 +2730,7 @@
           <a:bodyPr wrap="square" lIns="0" tIns="0" rIns="0" bIns="0" rtlCol="0" anchor="ctr"/>
           <a:lstStyle/>
           <a:p>
-            <a:pPr marL="0" indent="0" algn="ctr">
+            <a:pPr algn="ctr" indent="0" marL="0">
               <a:buNone/>
             </a:pPr>
             <a:r>
@@ -2576,13 +2767,6 @@
           </a:solidFill>
           <a:ln/>
         </p:spPr>
-        <p:txBody>
-          <a:bodyPr/>
-          <a:lstStyle/>
-          <a:p>
-            <a:endParaRPr lang="en-DE"/>
-          </a:p>
-        </p:txBody>
       </p:sp>
       <p:sp>
         <p:nvSpPr>
@@ -2605,7 +2789,7 @@
           <a:bodyPr wrap="square" lIns="0" tIns="0" rIns="0" bIns="0" rtlCol="0" anchor="ctr"/>
           <a:lstStyle/>
           <a:p>
-            <a:pPr marL="0" indent="0" algn="ctr">
+            <a:pPr algn="ctr" indent="0" marL="0">
               <a:buNone/>
             </a:pPr>
             <a:r>
@@ -2642,13 +2826,6 @@
           </a:solidFill>
           <a:ln/>
         </p:spPr>
-        <p:txBody>
-          <a:bodyPr/>
-          <a:lstStyle/>
-          <a:p>
-            <a:endParaRPr lang="en-DE"/>
-          </a:p>
-        </p:txBody>
       </p:sp>
       <p:sp>
         <p:nvSpPr>
@@ -2671,7 +2848,7 @@
           <a:bodyPr wrap="square" lIns="0" tIns="0" rIns="0" bIns="0" rtlCol="0" anchor="ctr"/>
           <a:lstStyle/>
           <a:p>
-            <a:pPr marL="0" indent="0" algn="ctr">
+            <a:pPr algn="ctr" indent="0" marL="0">
               <a:buNone/>
             </a:pPr>
             <a:r>
@@ -2708,13 +2885,6 @@
           </a:solidFill>
           <a:ln/>
         </p:spPr>
-        <p:txBody>
-          <a:bodyPr/>
-          <a:lstStyle/>
-          <a:p>
-            <a:endParaRPr lang="en-DE"/>
-          </a:p>
-        </p:txBody>
       </p:sp>
       <p:sp>
         <p:nvSpPr>
@@ -2737,7 +2907,7 @@
           <a:bodyPr wrap="square" lIns="0" tIns="0" rIns="0" bIns="0" rtlCol="0" anchor="ctr"/>
           <a:lstStyle/>
           <a:p>
-            <a:pPr marL="0" indent="0" algn="ctr">
+            <a:pPr algn="ctr" indent="0" marL="0">
               <a:buNone/>
             </a:pPr>
             <a:r>
@@ -2757,7 +2927,7 @@
       </p:sp>
       <p:graphicFrame>
         <p:nvGraphicFramePr>
-          <p:cNvPr id="12" name="Table 0"/>
+          <p:cNvPr id="11" name="Table 0"/>
           <p:cNvGraphicFramePr>
             <a:graphicFrameLocks noGrp="1"/>
           </p:cNvGraphicFramePr>
@@ -2771,34 +2941,16 @@
         </p:nvGraphicFramePr>
         <p:xfrm>
           <a:off x="548640" y="1645920"/>
-          <a:ext cx="11064240" cy="3017520"/>
+          <a:ext cx="11064240" cy="914400"/>
         </p:xfrm>
         <a:graphic>
           <a:graphicData uri="http://schemas.openxmlformats.org/drawingml/2006/table">
             <a:tbl>
               <a:tblPr/>
               <a:tblGrid>
-                <a:gridCol w="4023360">
-                  <a:extLst>
-                    <a:ext uri="{9D8B030D-6E8A-4147-A177-3AD203B41FA5}">
-                      <a16:colId xmlns:a16="http://schemas.microsoft.com/office/drawing/2014/main" val="20000"/>
-                    </a:ext>
-                  </a:extLst>
-                </a:gridCol>
-                <a:gridCol w="2560320">
-                  <a:extLst>
-                    <a:ext uri="{9D8B030D-6E8A-4147-A177-3AD203B41FA5}">
-                      <a16:colId xmlns:a16="http://schemas.microsoft.com/office/drawing/2014/main" val="20001"/>
-                    </a:ext>
-                  </a:extLst>
-                </a:gridCol>
-                <a:gridCol w="4480560">
-                  <a:extLst>
-                    <a:ext uri="{9D8B030D-6E8A-4147-A177-3AD203B41FA5}">
-                      <a16:colId xmlns:a16="http://schemas.microsoft.com/office/drawing/2014/main" val="20002"/>
-                    </a:ext>
-                  </a:extLst>
-                </a:gridCol>
+                <a:gridCol w="4023360"/>
+                <a:gridCol w="2560320"/>
+                <a:gridCol w="4480560"/>
               </a:tblGrid>
               <a:tr h="502920">
                 <a:tc>
@@ -2806,7 +2958,7 @@
                     <a:bodyPr/>
                     <a:lstStyle/>
                     <a:p>
-                      <a:pPr marL="0" indent="0">
+                      <a:pPr indent="0" marL="0">
                         <a:buNone/>
                       </a:pPr>
                       <a:r>
@@ -2827,7 +2979,7 @@
                       </a:endParaRPr>
                     </a:p>
                   </a:txBody>
-                  <a:tcPr anchor="ctr">
+                  <a:tcPr marL="91440" marR="91440" marT="45720" marB="45720" anchor="ctr">
                     <a:lnL w="12700" cap="flat" cmpd="sng" algn="ctr">
                       <a:solidFill>
                         <a:srgbClr val="CADCFC"/>
@@ -2874,7 +3026,7 @@
                     <a:bodyPr/>
                     <a:lstStyle/>
                     <a:p>
-                      <a:pPr marL="0" indent="0">
+                      <a:pPr indent="0" marL="0">
                         <a:buNone/>
                       </a:pPr>
                       <a:r>
@@ -2895,7 +3047,7 @@
                       </a:endParaRPr>
                     </a:p>
                   </a:txBody>
-                  <a:tcPr anchor="ctr">
+                  <a:tcPr marL="91440" marR="91440" marT="45720" marB="45720" anchor="ctr">
                     <a:lnL w="12700" cap="flat" cmpd="sng" algn="ctr">
                       <a:solidFill>
                         <a:srgbClr val="CADCFC"/>
@@ -2942,7 +3094,7 @@
                     <a:bodyPr/>
                     <a:lstStyle/>
                     <a:p>
-                      <a:pPr marL="0" indent="0">
+                      <a:pPr indent="0" marL="0">
                         <a:buNone/>
                       </a:pPr>
                       <a:r>
@@ -2963,7 +3115,7 @@
                       </a:endParaRPr>
                     </a:p>
                   </a:txBody>
-                  <a:tcPr anchor="ctr">
+                  <a:tcPr marL="91440" marR="91440" marT="45720" marB="45720" anchor="ctr">
                     <a:lnL w="12700" cap="flat" cmpd="sng" algn="ctr">
                       <a:solidFill>
                         <a:srgbClr val="CADCFC"/>
@@ -3005,11 +3157,6 @@
                     </a:solidFill>
                   </a:tcPr>
                 </a:tc>
-                <a:extLst>
-                  <a:ext uri="{0D108BD9-81ED-4DB2-BD59-A6C34878D82A}">
-                    <a16:rowId xmlns:a16="http://schemas.microsoft.com/office/drawing/2014/main" val="10000"/>
-                  </a:ext>
-                </a:extLst>
               </a:tr>
               <a:tr h="502920">
                 <a:tc>
@@ -3017,7 +3164,7 @@
                     <a:bodyPr/>
                     <a:lstStyle/>
                     <a:p>
-                      <a:pPr marL="0" indent="0">
+                      <a:pPr indent="0" marL="0">
                         <a:buNone/>
                       </a:pPr>
                       <a:r>
@@ -3038,7 +3185,7 @@
                       </a:endParaRPr>
                     </a:p>
                   </a:txBody>
-                  <a:tcPr anchor="ctr">
+                  <a:tcPr marL="91440" marR="91440" marT="45720" marB="45720" anchor="ctr">
                     <a:lnL w="12700" cap="flat" cmpd="sng" algn="ctr">
                       <a:solidFill>
                         <a:srgbClr val="CADCFC"/>
@@ -3082,7 +3229,7 @@
                     <a:bodyPr/>
                     <a:lstStyle/>
                     <a:p>
-                      <a:pPr marL="0" indent="0">
+                      <a:pPr indent="0" marL="0">
                         <a:buNone/>
                       </a:pPr>
                       <a:r>
@@ -3103,7 +3250,7 @@
                       </a:endParaRPr>
                     </a:p>
                   </a:txBody>
-                  <a:tcPr anchor="ctr">
+                  <a:tcPr marL="91440" marR="91440" marT="45720" marB="45720" anchor="ctr">
                     <a:lnL w="12700" cap="flat" cmpd="sng" algn="ctr">
                       <a:solidFill>
                         <a:srgbClr val="CADCFC"/>
@@ -3147,7 +3294,7 @@
                     <a:bodyPr/>
                     <a:lstStyle/>
                     <a:p>
-                      <a:pPr marL="0" indent="0">
+                      <a:pPr indent="0" marL="0">
                         <a:buNone/>
                       </a:pPr>
                       <a:r>
@@ -3168,7 +3315,7 @@
                       </a:endParaRPr>
                     </a:p>
                   </a:txBody>
-                  <a:tcPr anchor="ctr">
+                  <a:tcPr marL="91440" marR="91440" marT="45720" marB="45720" anchor="ctr">
                     <a:lnL w="12700" cap="flat" cmpd="sng" algn="ctr">
                       <a:solidFill>
                         <a:srgbClr val="CADCFC"/>
@@ -3207,11 +3354,6 @@
                     </a:lnB>
                   </a:tcPr>
                 </a:tc>
-                <a:extLst>
-                  <a:ext uri="{0D108BD9-81ED-4DB2-BD59-A6C34878D82A}">
-                    <a16:rowId xmlns:a16="http://schemas.microsoft.com/office/drawing/2014/main" val="10001"/>
-                  </a:ext>
-                </a:extLst>
               </a:tr>
               <a:tr h="502920">
                 <a:tc>
@@ -3219,7 +3361,7 @@
                     <a:bodyPr/>
                     <a:lstStyle/>
                     <a:p>
-                      <a:pPr marL="0" indent="0">
+                      <a:pPr indent="0" marL="0">
                         <a:buNone/>
                       </a:pPr>
                       <a:r>
@@ -3240,7 +3382,7 @@
                       </a:endParaRPr>
                     </a:p>
                   </a:txBody>
-                  <a:tcPr anchor="ctr">
+                  <a:tcPr marL="91440" marR="91440" marT="45720" marB="45720" anchor="ctr">
                     <a:lnL w="12700" cap="flat" cmpd="sng" algn="ctr">
                       <a:solidFill>
                         <a:srgbClr val="CADCFC"/>
@@ -3284,7 +3426,7 @@
                     <a:bodyPr/>
                     <a:lstStyle/>
                     <a:p>
-                      <a:pPr marL="0" indent="0">
+                      <a:pPr indent="0" marL="0">
                         <a:buNone/>
                       </a:pPr>
                       <a:r>
@@ -3305,7 +3447,7 @@
                       </a:endParaRPr>
                     </a:p>
                   </a:txBody>
-                  <a:tcPr anchor="ctr">
+                  <a:tcPr marL="91440" marR="91440" marT="45720" marB="45720" anchor="ctr">
                     <a:lnL w="12700" cap="flat" cmpd="sng" algn="ctr">
                       <a:solidFill>
                         <a:srgbClr val="CADCFC"/>
@@ -3349,7 +3491,7 @@
                     <a:bodyPr/>
                     <a:lstStyle/>
                     <a:p>
-                      <a:pPr marL="0" indent="0">
+                      <a:pPr indent="0" marL="0">
                         <a:buNone/>
                       </a:pPr>
                       <a:r>
@@ -3370,7 +3512,7 @@
                       </a:endParaRPr>
                     </a:p>
                   </a:txBody>
-                  <a:tcPr anchor="ctr">
+                  <a:tcPr marL="91440" marR="91440" marT="45720" marB="45720" anchor="ctr">
                     <a:lnL w="12700" cap="flat" cmpd="sng" algn="ctr">
                       <a:solidFill>
                         <a:srgbClr val="CADCFC"/>
@@ -3409,11 +3551,6 @@
                     </a:lnB>
                   </a:tcPr>
                 </a:tc>
-                <a:extLst>
-                  <a:ext uri="{0D108BD9-81ED-4DB2-BD59-A6C34878D82A}">
-                    <a16:rowId xmlns:a16="http://schemas.microsoft.com/office/drawing/2014/main" val="10002"/>
-                  </a:ext>
-                </a:extLst>
               </a:tr>
               <a:tr h="502920">
                 <a:tc>
@@ -3421,7 +3558,7 @@
                     <a:bodyPr/>
                     <a:lstStyle/>
                     <a:p>
-                      <a:pPr marL="0" indent="0">
+                      <a:pPr indent="0" marL="0">
                         <a:buNone/>
                       </a:pPr>
                       <a:r>
@@ -3442,7 +3579,7 @@
                       </a:endParaRPr>
                     </a:p>
                   </a:txBody>
-                  <a:tcPr anchor="ctr">
+                  <a:tcPr marL="91440" marR="91440" marT="45720" marB="45720" anchor="ctr">
                     <a:lnL w="12700" cap="flat" cmpd="sng" algn="ctr">
                       <a:solidFill>
                         <a:srgbClr val="CADCFC"/>
@@ -3486,7 +3623,7 @@
                     <a:bodyPr/>
                     <a:lstStyle/>
                     <a:p>
-                      <a:pPr marL="0" indent="0">
+                      <a:pPr indent="0" marL="0">
                         <a:buNone/>
                       </a:pPr>
                       <a:r>
@@ -3507,7 +3644,7 @@
                       </a:endParaRPr>
                     </a:p>
                   </a:txBody>
-                  <a:tcPr anchor="ctr">
+                  <a:tcPr marL="91440" marR="91440" marT="45720" marB="45720" anchor="ctr">
                     <a:lnL w="12700" cap="flat" cmpd="sng" algn="ctr">
                       <a:solidFill>
                         <a:srgbClr val="CADCFC"/>
@@ -3551,7 +3688,7 @@
                     <a:bodyPr/>
                     <a:lstStyle/>
                     <a:p>
-                      <a:pPr marL="0" indent="0">
+                      <a:pPr indent="0" marL="0">
                         <a:buNone/>
                       </a:pPr>
                       <a:r>
@@ -3572,7 +3709,7 @@
                       </a:endParaRPr>
                     </a:p>
                   </a:txBody>
-                  <a:tcPr anchor="ctr">
+                  <a:tcPr marL="91440" marR="91440" marT="45720" marB="45720" anchor="ctr">
                     <a:lnL w="12700" cap="flat" cmpd="sng" algn="ctr">
                       <a:solidFill>
                         <a:srgbClr val="CADCFC"/>
@@ -3611,11 +3748,6 @@
                     </a:lnB>
                   </a:tcPr>
                 </a:tc>
-                <a:extLst>
-                  <a:ext uri="{0D108BD9-81ED-4DB2-BD59-A6C34878D82A}">
-                    <a16:rowId xmlns:a16="http://schemas.microsoft.com/office/drawing/2014/main" val="10003"/>
-                  </a:ext>
-                </a:extLst>
               </a:tr>
               <a:tr h="502920">
                 <a:tc>
@@ -3623,7 +3755,7 @@
                     <a:bodyPr/>
                     <a:lstStyle/>
                     <a:p>
-                      <a:pPr marL="0" indent="0">
+                      <a:pPr indent="0" marL="0">
                         <a:buNone/>
                       </a:pPr>
                       <a:r>
@@ -3644,7 +3776,7 @@
                       </a:endParaRPr>
                     </a:p>
                   </a:txBody>
-                  <a:tcPr anchor="ctr">
+                  <a:tcPr marL="91440" marR="91440" marT="45720" marB="45720" anchor="ctr">
                     <a:lnL w="12700" cap="flat" cmpd="sng" algn="ctr">
                       <a:solidFill>
                         <a:srgbClr val="CADCFC"/>
@@ -3688,7 +3820,7 @@
                     <a:bodyPr/>
                     <a:lstStyle/>
                     <a:p>
-                      <a:pPr marL="0" indent="0">
+                      <a:pPr indent="0" marL="0">
                         <a:buNone/>
                       </a:pPr>
                       <a:r>
@@ -3709,7 +3841,7 @@
                       </a:endParaRPr>
                     </a:p>
                   </a:txBody>
-                  <a:tcPr anchor="ctr">
+                  <a:tcPr marL="91440" marR="91440" marT="45720" marB="45720" anchor="ctr">
                     <a:lnL w="12700" cap="flat" cmpd="sng" algn="ctr">
                       <a:solidFill>
                         <a:srgbClr val="CADCFC"/>
@@ -3753,7 +3885,7 @@
                     <a:bodyPr/>
                     <a:lstStyle/>
                     <a:p>
-                      <a:pPr marL="0" indent="0">
+                      <a:pPr indent="0" marL="0">
                         <a:buNone/>
                       </a:pPr>
                       <a:r>
@@ -3774,7 +3906,7 @@
                       </a:endParaRPr>
                     </a:p>
                   </a:txBody>
-                  <a:tcPr anchor="ctr">
+                  <a:tcPr marL="91440" marR="91440" marT="45720" marB="45720" anchor="ctr">
                     <a:lnL w="12700" cap="flat" cmpd="sng" algn="ctr">
                       <a:solidFill>
                         <a:srgbClr val="CADCFC"/>
@@ -3813,11 +3945,6 @@
                     </a:lnB>
                   </a:tcPr>
                 </a:tc>
-                <a:extLst>
-                  <a:ext uri="{0D108BD9-81ED-4DB2-BD59-A6C34878D82A}">
-                    <a16:rowId xmlns:a16="http://schemas.microsoft.com/office/drawing/2014/main" val="10004"/>
-                  </a:ext>
-                </a:extLst>
               </a:tr>
               <a:tr h="502920">
                 <a:tc>
@@ -3825,7 +3952,7 @@
                     <a:bodyPr/>
                     <a:lstStyle/>
                     <a:p>
-                      <a:pPr marL="0" indent="0">
+                      <a:pPr indent="0" marL="0">
                         <a:buNone/>
                       </a:pPr>
                       <a:r>
@@ -3846,7 +3973,7 @@
                       </a:endParaRPr>
                     </a:p>
                   </a:txBody>
-                  <a:tcPr anchor="ctr">
+                  <a:tcPr marL="91440" marR="91440" marT="45720" marB="45720" anchor="ctr">
                     <a:lnL w="12700" cap="flat" cmpd="sng" algn="ctr">
                       <a:solidFill>
                         <a:srgbClr val="CADCFC"/>
@@ -3890,7 +4017,7 @@
                     <a:bodyPr/>
                     <a:lstStyle/>
                     <a:p>
-                      <a:pPr marL="0" indent="0">
+                      <a:pPr indent="0" marL="0">
                         <a:buNone/>
                       </a:pPr>
                       <a:r>
@@ -3911,7 +4038,7 @@
                       </a:endParaRPr>
                     </a:p>
                   </a:txBody>
-                  <a:tcPr anchor="ctr">
+                  <a:tcPr marL="91440" marR="91440" marT="45720" marB="45720" anchor="ctr">
                     <a:lnL w="12700" cap="flat" cmpd="sng" algn="ctr">
                       <a:solidFill>
                         <a:srgbClr val="CADCFC"/>
@@ -3955,7 +4082,7 @@
                     <a:bodyPr/>
                     <a:lstStyle/>
                     <a:p>
-                      <a:pPr marL="0" indent="0">
+                      <a:pPr indent="0" marL="0">
                         <a:buNone/>
                       </a:pPr>
                       <a:r>
@@ -3976,7 +4103,7 @@
                       </a:endParaRPr>
                     </a:p>
                   </a:txBody>
-                  <a:tcPr anchor="ctr">
+                  <a:tcPr marL="91440" marR="91440" marT="45720" marB="45720" anchor="ctr">
                     <a:lnL w="12700" cap="flat" cmpd="sng" algn="ctr">
                       <a:solidFill>
                         <a:srgbClr val="CADCFC"/>
@@ -4015,11 +4142,6 @@
                     </a:lnB>
                   </a:tcPr>
                 </a:tc>
-                <a:extLst>
-                  <a:ext uri="{0D108BD9-81ED-4DB2-BD59-A6C34878D82A}">
-                    <a16:rowId xmlns:a16="http://schemas.microsoft.com/office/drawing/2014/main" val="10005"/>
-                  </a:ext>
-                </a:extLst>
               </a:tr>
             </a:tbl>
           </a:graphicData>
@@ -4046,7 +4168,7 @@
           <a:bodyPr wrap="square" rtlCol="0" anchor="ctr"/>
           <a:lstStyle/>
           <a:p>
-            <a:pPr marL="0" indent="0">
+            <a:pPr indent="0" marL="0">
               <a:buNone/>
             </a:pPr>
             <a:r>
@@ -4110,7 +4232,7 @@
           <a:bodyPr wrap="square" rtlCol="0" anchor="ctr"/>
           <a:lstStyle/>
           <a:p>
-            <a:pPr marL="0" indent="0">
+            <a:pPr indent="0" marL="0">
               <a:buNone/>
             </a:pPr>
             <a:r>
@@ -4149,7 +4271,7 @@
           <a:bodyPr wrap="square" rtlCol="0" anchor="ctr"/>
           <a:lstStyle/>
           <a:p>
-            <a:pPr marL="0" indent="0">
+            <a:pPr indent="0" marL="0">
               <a:buNone/>
             </a:pPr>
             <a:r>
@@ -4186,13 +4308,6 @@
           </a:solidFill>
           <a:ln/>
         </p:spPr>
-        <p:txBody>
-          <a:bodyPr/>
-          <a:lstStyle/>
-          <a:p>
-            <a:endParaRPr lang="en-DE"/>
-          </a:p>
-        </p:txBody>
       </p:sp>
       <p:sp>
         <p:nvSpPr>
@@ -4215,7 +4330,7 @@
           <a:bodyPr wrap="square" lIns="0" tIns="0" rIns="0" bIns="0" rtlCol="0" anchor="ctr"/>
           <a:lstStyle/>
           <a:p>
-            <a:pPr marL="0" indent="0" algn="ctr">
+            <a:pPr algn="ctr" indent="0" marL="0">
               <a:buNone/>
             </a:pPr>
             <a:r>
@@ -4252,13 +4367,6 @@
           </a:solidFill>
           <a:ln/>
         </p:spPr>
-        <p:txBody>
-          <a:bodyPr/>
-          <a:lstStyle/>
-          <a:p>
-            <a:endParaRPr lang="en-DE"/>
-          </a:p>
-        </p:txBody>
       </p:sp>
       <p:sp>
         <p:nvSpPr>
@@ -4281,7 +4389,7 @@
           <a:bodyPr wrap="square" lIns="0" tIns="0" rIns="0" bIns="0" rtlCol="0" anchor="ctr"/>
           <a:lstStyle/>
           <a:p>
-            <a:pPr marL="0" indent="0" algn="ctr">
+            <a:pPr algn="ctr" indent="0" marL="0">
               <a:buNone/>
             </a:pPr>
             <a:r>
@@ -4318,13 +4426,6 @@
           </a:solidFill>
           <a:ln/>
         </p:spPr>
-        <p:txBody>
-          <a:bodyPr/>
-          <a:lstStyle/>
-          <a:p>
-            <a:endParaRPr lang="en-DE"/>
-          </a:p>
-        </p:txBody>
       </p:sp>
       <p:sp>
         <p:nvSpPr>
@@ -4347,7 +4448,7 @@
           <a:bodyPr wrap="square" lIns="0" tIns="0" rIns="0" bIns="0" rtlCol="0" anchor="ctr"/>
           <a:lstStyle/>
           <a:p>
-            <a:pPr marL="0" indent="0" algn="ctr">
+            <a:pPr algn="ctr" indent="0" marL="0">
               <a:buNone/>
             </a:pPr>
             <a:r>
@@ -4384,13 +4485,6 @@
           </a:solidFill>
           <a:ln/>
         </p:spPr>
-        <p:txBody>
-          <a:bodyPr/>
-          <a:lstStyle/>
-          <a:p>
-            <a:endParaRPr lang="en-DE"/>
-          </a:p>
-        </p:txBody>
       </p:sp>
       <p:sp>
         <p:nvSpPr>
@@ -4413,7 +4507,7 @@
           <a:bodyPr wrap="square" lIns="0" tIns="0" rIns="0" bIns="0" rtlCol="0" anchor="ctr"/>
           <a:lstStyle/>
           <a:p>
-            <a:pPr marL="0" indent="0" algn="ctr">
+            <a:pPr algn="ctr" indent="0" marL="0">
               <a:buNone/>
             </a:pPr>
             <a:r>
@@ -4457,13 +4551,6 @@
             <a:prstDash val="solid"/>
           </a:ln>
         </p:spPr>
-        <p:txBody>
-          <a:bodyPr/>
-          <a:lstStyle/>
-          <a:p>
-            <a:endParaRPr lang="en-DE"/>
-          </a:p>
-        </p:txBody>
       </p:sp>
       <p:sp>
         <p:nvSpPr>
@@ -4486,7 +4573,7 @@
           <a:bodyPr wrap="square" lIns="0" tIns="0" rIns="0" bIns="0" rtlCol="0" anchor="ctr"/>
           <a:lstStyle/>
           <a:p>
-            <a:pPr marL="0" indent="0">
+            <a:pPr indent="0" marL="0">
               <a:buNone/>
             </a:pPr>
             <a:r>
@@ -4525,7 +4612,7 @@
           <a:bodyPr wrap="square" lIns="0" tIns="0" rIns="0" bIns="0" rtlCol="0" anchor="ctr"/>
           <a:lstStyle/>
           <a:p>
-            <a:pPr marL="0" indent="0">
+            <a:pPr indent="0" marL="0">
               <a:buNone/>
             </a:pPr>
             <a:r>
@@ -4569,13 +4656,6 @@
             <a:prstDash val="solid"/>
           </a:ln>
         </p:spPr>
-        <p:txBody>
-          <a:bodyPr/>
-          <a:lstStyle/>
-          <a:p>
-            <a:endParaRPr lang="en-DE"/>
-          </a:p>
-        </p:txBody>
       </p:sp>
       <p:sp>
         <p:nvSpPr>
@@ -4598,7 +4678,7 @@
           <a:bodyPr wrap="square" lIns="0" tIns="0" rIns="0" bIns="0" rtlCol="0" anchor="ctr"/>
           <a:lstStyle/>
           <a:p>
-            <a:pPr marL="0" indent="0">
+            <a:pPr indent="0" marL="0">
               <a:buNone/>
             </a:pPr>
             <a:r>
@@ -4637,7 +4717,7 @@
           <a:bodyPr wrap="square" lIns="0" tIns="0" rIns="0" bIns="0" rtlCol="0" anchor="ctr"/>
           <a:lstStyle/>
           <a:p>
-            <a:pPr marL="0" indent="0">
+            <a:pPr indent="0" marL="0">
               <a:buNone/>
             </a:pPr>
             <a:r>
@@ -4681,13 +4761,6 @@
             <a:prstDash val="solid"/>
           </a:ln>
         </p:spPr>
-        <p:txBody>
-          <a:bodyPr/>
-          <a:lstStyle/>
-          <a:p>
-            <a:endParaRPr lang="en-DE"/>
-          </a:p>
-        </p:txBody>
       </p:sp>
       <p:sp>
         <p:nvSpPr>
@@ -4710,7 +4783,7 @@
           <a:bodyPr wrap="square" lIns="0" tIns="0" rIns="0" bIns="0" rtlCol="0" anchor="ctr"/>
           <a:lstStyle/>
           <a:p>
-            <a:pPr marL="0" indent="0">
+            <a:pPr indent="0" marL="0">
               <a:buNone/>
             </a:pPr>
             <a:r>
@@ -4749,7 +4822,7 @@
           <a:bodyPr wrap="square" lIns="0" tIns="0" rIns="0" bIns="0" rtlCol="0" anchor="ctr"/>
           <a:lstStyle/>
           <a:p>
-            <a:pPr marL="0" indent="0">
+            <a:pPr indent="0" marL="0">
               <a:buNone/>
             </a:pPr>
             <a:r>
@@ -4793,13 +4866,6 @@
             <a:prstDash val="solid"/>
           </a:ln>
         </p:spPr>
-        <p:txBody>
-          <a:bodyPr/>
-          <a:lstStyle/>
-          <a:p>
-            <a:endParaRPr lang="en-DE"/>
-          </a:p>
-        </p:txBody>
       </p:sp>
       <p:sp>
         <p:nvSpPr>
@@ -4822,7 +4888,7 @@
           <a:bodyPr wrap="square" lIns="0" tIns="0" rIns="0" bIns="0" rtlCol="0" anchor="ctr"/>
           <a:lstStyle/>
           <a:p>
-            <a:pPr marL="0" indent="0">
+            <a:pPr indent="0" marL="0">
               <a:buNone/>
             </a:pPr>
             <a:r>
@@ -4861,7 +4927,7 @@
           <a:bodyPr wrap="square" lIns="0" tIns="0" rIns="0" bIns="0" rtlCol="0" anchor="ctr"/>
           <a:lstStyle/>
           <a:p>
-            <a:pPr marL="0" indent="0">
+            <a:pPr indent="0" marL="0">
               <a:buNone/>
             </a:pPr>
             <a:r>
@@ -4900,13 +4966,6 @@
           </a:solidFill>
           <a:ln/>
         </p:spPr>
-        <p:txBody>
-          <a:bodyPr/>
-          <a:lstStyle/>
-          <a:p>
-            <a:endParaRPr lang="en-DE"/>
-          </a:p>
-        </p:txBody>
       </p:sp>
       <p:sp>
         <p:nvSpPr>
@@ -4929,7 +4988,7 @@
           <a:bodyPr wrap="square" lIns="0" tIns="0" rIns="0" bIns="0" rtlCol="0" anchor="ctr"/>
           <a:lstStyle/>
           <a:p>
-            <a:pPr marL="0" indent="0">
+            <a:pPr indent="0" marL="0">
               <a:buNone/>
             </a:pPr>
             <a:r>
@@ -4968,7 +5027,7 @@
           <a:bodyPr wrap="square" lIns="0" tIns="0" rIns="0" bIns="0" rtlCol="0" anchor="ctr"/>
           <a:lstStyle/>
           <a:p>
-            <a:pPr marL="0" indent="0">
+            <a:pPr indent="0" marL="0">
               <a:buNone/>
             </a:pPr>
             <a:r>
@@ -4985,7 +5044,7 @@
             <a:endParaRPr lang="en-US" sz="1450" dirty="0"/>
           </a:p>
           <a:p>
-            <a:pPr marL="0" indent="0">
+            <a:pPr indent="0" marL="0">
               <a:buNone/>
             </a:pPr>
             <a:r>
@@ -5002,7 +5061,7 @@
             <a:endParaRPr lang="en-US" sz="1450" dirty="0"/>
           </a:p>
           <a:p>
-            <a:pPr marL="0" indent="0">
+            <a:pPr indent="0" marL="0">
               <a:buNone/>
             </a:pPr>
             <a:r>
@@ -5019,7 +5078,7 @@
             <a:endParaRPr lang="en-US" sz="1450" dirty="0"/>
           </a:p>
           <a:p>
-            <a:pPr marL="0" indent="0">
+            <a:pPr indent="0" marL="0">
               <a:buNone/>
             </a:pPr>
             <a:r>
@@ -5036,7 +5095,7 @@
             <a:endParaRPr lang="en-US" sz="1450" dirty="0"/>
           </a:p>
           <a:p>
-            <a:pPr marL="0" indent="0">
+            <a:pPr indent="0" marL="0">
               <a:buNone/>
             </a:pPr>
             <a:r>
@@ -5080,13 +5139,6 @@
             <a:prstDash val="solid"/>
           </a:ln>
         </p:spPr>
-        <p:txBody>
-          <a:bodyPr/>
-          <a:lstStyle/>
-          <a:p>
-            <a:endParaRPr lang="en-DE"/>
-          </a:p>
-        </p:txBody>
       </p:sp>
       <p:sp>
         <p:nvSpPr>
@@ -5109,7 +5161,7 @@
           <a:bodyPr wrap="square" lIns="0" tIns="0" rIns="0" bIns="0" rtlCol="0" anchor="ctr"/>
           <a:lstStyle/>
           <a:p>
-            <a:pPr marL="0" indent="0">
+            <a:pPr indent="0" marL="0">
               <a:buNone/>
             </a:pPr>
             <a:r>
@@ -5148,7 +5200,7 @@
           <a:bodyPr wrap="square" rtlCol="0" anchor="ctr"/>
           <a:lstStyle/>
           <a:p>
-            <a:pPr marL="0" indent="0">
+            <a:pPr indent="0" marL="0">
               <a:buNone/>
             </a:pPr>
             <a:r>
@@ -5212,7 +5264,7 @@
           <a:bodyPr wrap="square" rtlCol="0" anchor="ctr"/>
           <a:lstStyle/>
           <a:p>
-            <a:pPr marL="0" indent="0">
+            <a:pPr indent="0" marL="0">
               <a:buNone/>
             </a:pPr>
             <a:r>
@@ -5251,7 +5303,7 @@
           <a:bodyPr wrap="square" rtlCol="0" anchor="ctr"/>
           <a:lstStyle/>
           <a:p>
-            <a:pPr marL="0" indent="0">
+            <a:pPr indent="0" marL="0">
               <a:buNone/>
             </a:pPr>
             <a:r>
@@ -5288,13 +5340,6 @@
           </a:solidFill>
           <a:ln/>
         </p:spPr>
-        <p:txBody>
-          <a:bodyPr/>
-          <a:lstStyle/>
-          <a:p>
-            <a:endParaRPr lang="en-DE"/>
-          </a:p>
-        </p:txBody>
       </p:sp>
       <p:sp>
         <p:nvSpPr>
@@ -5317,7 +5362,7 @@
           <a:bodyPr wrap="square" lIns="0" tIns="0" rIns="0" bIns="0" rtlCol="0" anchor="ctr"/>
           <a:lstStyle/>
           <a:p>
-            <a:pPr marL="0" indent="0" algn="ctr">
+            <a:pPr algn="ctr" indent="0" marL="0">
               <a:buNone/>
             </a:pPr>
             <a:r>
@@ -5354,13 +5399,6 @@
           </a:solidFill>
           <a:ln/>
         </p:spPr>
-        <p:txBody>
-          <a:bodyPr/>
-          <a:lstStyle/>
-          <a:p>
-            <a:endParaRPr lang="en-DE"/>
-          </a:p>
-        </p:txBody>
       </p:sp>
       <p:sp>
         <p:nvSpPr>
@@ -5383,7 +5421,7 @@
           <a:bodyPr wrap="square" lIns="0" tIns="0" rIns="0" bIns="0" rtlCol="0" anchor="ctr"/>
           <a:lstStyle/>
           <a:p>
-            <a:pPr marL="0" indent="0" algn="ctr">
+            <a:pPr algn="ctr" indent="0" marL="0">
               <a:buNone/>
             </a:pPr>
             <a:r>
@@ -5420,13 +5458,6 @@
           </a:solidFill>
           <a:ln/>
         </p:spPr>
-        <p:txBody>
-          <a:bodyPr/>
-          <a:lstStyle/>
-          <a:p>
-            <a:endParaRPr lang="en-DE"/>
-          </a:p>
-        </p:txBody>
       </p:sp>
       <p:sp>
         <p:nvSpPr>
@@ -5449,7 +5480,7 @@
           <a:bodyPr wrap="square" lIns="0" tIns="0" rIns="0" bIns="0" rtlCol="0" anchor="ctr"/>
           <a:lstStyle/>
           <a:p>
-            <a:pPr marL="0" indent="0" algn="ctr">
+            <a:pPr algn="ctr" indent="0" marL="0">
               <a:buNone/>
             </a:pPr>
             <a:r>
@@ -5486,13 +5517,6 @@
           </a:solidFill>
           <a:ln/>
         </p:spPr>
-        <p:txBody>
-          <a:bodyPr/>
-          <a:lstStyle/>
-          <a:p>
-            <a:endParaRPr lang="en-DE"/>
-          </a:p>
-        </p:txBody>
       </p:sp>
       <p:sp>
         <p:nvSpPr>
@@ -5515,7 +5539,7 @@
           <a:bodyPr wrap="square" lIns="0" tIns="0" rIns="0" bIns="0" rtlCol="0" anchor="ctr"/>
           <a:lstStyle/>
           <a:p>
-            <a:pPr marL="0" indent="0" algn="ctr">
+            <a:pPr algn="ctr" indent="0" marL="0">
               <a:buNone/>
             </a:pPr>
             <a:r>
@@ -5554,7 +5578,7 @@
           <a:bodyPr wrap="square" rtlCol="0" anchor="ctr"/>
           <a:lstStyle/>
           <a:p>
-            <a:pPr marL="0" indent="0">
+            <a:pPr indent="0" marL="0">
               <a:buNone/>
             </a:pPr>
             <a:r>
@@ -5720,7 +5744,7 @@
           <a:bodyPr wrap="square" rtlCol="0" anchor="ctr"/>
           <a:lstStyle/>
           <a:p>
-            <a:pPr marL="0" indent="0">
+            <a:pPr indent="0" marL="0">
               <a:buNone/>
             </a:pPr>
             <a:r>
@@ -5796,7 +5820,7 @@
                 <a:ea typeface="Calibri" pitchFamily="34" charset="-122"/>
                 <a:cs typeface="Calibri" pitchFamily="34" charset="-120"/>
               </a:rPr>
-              <a:t>② Unify the two LLM evidence streams on one gold standard; grow the golden set past significance</a:t>
+              <a:t>② Unify the two LLM evidence streams on one gold standard; golden set grown 60→80 bilingual (exact-tag lift now significant, p=0.001) — grow further for urgency power</a:t>
             </a:r>
             <a:endParaRPr lang="en-US" sz="1300" dirty="0"/>
           </a:p>
@@ -5860,7 +5884,6 @@
         <a:solidFill>
           <a:srgbClr val="1E2761"/>
         </a:solidFill>
-        <a:effectLst/>
       </p:bgPr>
     </p:bg>
     <p:spTree>
@@ -5898,7 +5921,7 @@
           <a:bodyPr wrap="square" rtlCol="0" anchor="ctr"/>
           <a:lstStyle/>
           <a:p>
-            <a:pPr marL="0" indent="0">
+            <a:pPr indent="0" marL="0">
               <a:buNone/>
             </a:pPr>
             <a:r>
@@ -5937,13 +5960,6 @@
           </a:solidFill>
           <a:ln/>
         </p:spPr>
-        <p:txBody>
-          <a:bodyPr/>
-          <a:lstStyle/>
-          <a:p>
-            <a:endParaRPr lang="en-DE"/>
-          </a:p>
-        </p:txBody>
       </p:sp>
       <p:sp>
         <p:nvSpPr>
@@ -5966,7 +5982,7 @@
           <a:bodyPr wrap="square" lIns="0" tIns="0" rIns="0" bIns="0" rtlCol="0" anchor="ctr"/>
           <a:lstStyle/>
           <a:p>
-            <a:pPr marL="0" indent="0">
+            <a:pPr indent="0" marL="0">
               <a:buNone/>
             </a:pPr>
             <a:r>
@@ -6005,7 +6021,7 @@
           <a:bodyPr wrap="square" lIns="0" tIns="0" rIns="0" bIns="0" rtlCol="0" anchor="ctr"/>
           <a:lstStyle/>
           <a:p>
-            <a:pPr marL="0" indent="0">
+            <a:pPr indent="0" marL="0">
               <a:buNone/>
             </a:pPr>
             <a:r>
@@ -6044,13 +6060,6 @@
           </a:solidFill>
           <a:ln/>
         </p:spPr>
-        <p:txBody>
-          <a:bodyPr/>
-          <a:lstStyle/>
-          <a:p>
-            <a:endParaRPr lang="en-DE"/>
-          </a:p>
-        </p:txBody>
       </p:sp>
       <p:sp>
         <p:nvSpPr>
@@ -6073,7 +6082,7 @@
           <a:bodyPr wrap="square" lIns="0" tIns="0" rIns="0" bIns="0" rtlCol="0" anchor="ctr"/>
           <a:lstStyle/>
           <a:p>
-            <a:pPr marL="0" indent="0">
+            <a:pPr indent="0" marL="0">
               <a:buNone/>
             </a:pPr>
             <a:r>
@@ -6112,7 +6121,7 @@
           <a:bodyPr wrap="square" lIns="0" tIns="0" rIns="0" bIns="0" rtlCol="0" anchor="ctr"/>
           <a:lstStyle/>
           <a:p>
-            <a:pPr marL="0" indent="0">
+            <a:pPr indent="0" marL="0">
               <a:buNone/>
             </a:pPr>
             <a:r>
@@ -6151,13 +6160,6 @@
           </a:solidFill>
           <a:ln/>
         </p:spPr>
-        <p:txBody>
-          <a:bodyPr/>
-          <a:lstStyle/>
-          <a:p>
-            <a:endParaRPr lang="en-DE"/>
-          </a:p>
-        </p:txBody>
       </p:sp>
       <p:sp>
         <p:nvSpPr>
@@ -6180,7 +6182,7 @@
           <a:bodyPr wrap="square" lIns="0" tIns="0" rIns="0" bIns="0" rtlCol="0" anchor="ctr"/>
           <a:lstStyle/>
           <a:p>
-            <a:pPr marL="0" indent="0">
+            <a:pPr indent="0" marL="0">
               <a:buNone/>
             </a:pPr>
             <a:r>
@@ -6219,7 +6221,7 @@
           <a:bodyPr wrap="square" lIns="0" tIns="0" rIns="0" bIns="0" rtlCol="0" anchor="ctr"/>
           <a:lstStyle/>
           <a:p>
-            <a:pPr marL="0" indent="0">
+            <a:pPr indent="0" marL="0">
               <a:buNone/>
             </a:pPr>
             <a:r>
@@ -6258,13 +6260,6 @@
           </a:solidFill>
           <a:ln/>
         </p:spPr>
-        <p:txBody>
-          <a:bodyPr/>
-          <a:lstStyle/>
-          <a:p>
-            <a:endParaRPr lang="en-DE"/>
-          </a:p>
-        </p:txBody>
       </p:sp>
       <p:sp>
         <p:nvSpPr>
@@ -6287,7 +6282,7 @@
           <a:bodyPr wrap="square" lIns="0" tIns="0" rIns="0" bIns="0" rtlCol="0" anchor="ctr"/>
           <a:lstStyle/>
           <a:p>
-            <a:pPr marL="0" indent="0">
+            <a:pPr indent="0" marL="0">
               <a:buNone/>
             </a:pPr>
             <a:r>
@@ -6326,7 +6321,7 @@
           <a:bodyPr wrap="square" lIns="0" tIns="0" rIns="0" bIns="0" rtlCol="0" anchor="ctr"/>
           <a:lstStyle/>
           <a:p>
-            <a:pPr marL="0" indent="0">
+            <a:pPr indent="0" marL="0">
               <a:buNone/>
             </a:pPr>
             <a:r>
@@ -6365,7 +6360,7 @@
           <a:bodyPr wrap="square" rtlCol="0" anchor="ctr"/>
           <a:lstStyle/>
           <a:p>
-            <a:pPr marL="0" indent="0">
+            <a:pPr indent="0" marL="0">
               <a:buNone/>
             </a:pPr>
             <a:r>
@@ -6404,7 +6399,7 @@
           <a:bodyPr wrap="square" rtlCol="0" anchor="ctr"/>
           <a:lstStyle/>
           <a:p>
-            <a:pPr marL="0" indent="0">
+            <a:pPr indent="0" marL="0">
               <a:buNone/>
             </a:pPr>
             <a:r>
@@ -6468,7 +6463,7 @@
           <a:bodyPr wrap="square" rtlCol="0" anchor="ctr"/>
           <a:lstStyle/>
           <a:p>
-            <a:pPr marL="0" indent="0">
+            <a:pPr indent="0" marL="0">
               <a:buNone/>
             </a:pPr>
             <a:r>
@@ -6507,7 +6502,7 @@
           <a:bodyPr wrap="square" rtlCol="0" anchor="ctr"/>
           <a:lstStyle/>
           <a:p>
-            <a:pPr marL="0" indent="0">
+            <a:pPr indent="0" marL="0">
               <a:buNone/>
             </a:pPr>
             <a:r>
@@ -6544,13 +6539,6 @@
           </a:solidFill>
           <a:ln/>
         </p:spPr>
-        <p:txBody>
-          <a:bodyPr/>
-          <a:lstStyle/>
-          <a:p>
-            <a:endParaRPr lang="en-DE"/>
-          </a:p>
-        </p:txBody>
       </p:sp>
       <p:sp>
         <p:nvSpPr>
@@ -6573,7 +6561,7 @@
           <a:bodyPr wrap="square" lIns="0" tIns="0" rIns="0" bIns="0" rtlCol="0" anchor="ctr"/>
           <a:lstStyle/>
           <a:p>
-            <a:pPr marL="0" indent="0" algn="ctr">
+            <a:pPr algn="ctr" indent="0" marL="0">
               <a:buNone/>
             </a:pPr>
             <a:r>
@@ -6610,13 +6598,6 @@
           </a:solidFill>
           <a:ln/>
         </p:spPr>
-        <p:txBody>
-          <a:bodyPr/>
-          <a:lstStyle/>
-          <a:p>
-            <a:endParaRPr lang="en-DE"/>
-          </a:p>
-        </p:txBody>
       </p:sp>
       <p:sp>
         <p:nvSpPr>
@@ -6639,7 +6620,7 @@
           <a:bodyPr wrap="square" lIns="0" tIns="0" rIns="0" bIns="0" rtlCol="0" anchor="ctr"/>
           <a:lstStyle/>
           <a:p>
-            <a:pPr marL="0" indent="0" algn="ctr">
+            <a:pPr algn="ctr" indent="0" marL="0">
               <a:buNone/>
             </a:pPr>
             <a:r>
@@ -6676,13 +6657,6 @@
           </a:solidFill>
           <a:ln/>
         </p:spPr>
-        <p:txBody>
-          <a:bodyPr/>
-          <a:lstStyle/>
-          <a:p>
-            <a:endParaRPr lang="en-DE"/>
-          </a:p>
-        </p:txBody>
       </p:sp>
       <p:sp>
         <p:nvSpPr>
@@ -6705,7 +6679,7 @@
           <a:bodyPr wrap="square" lIns="0" tIns="0" rIns="0" bIns="0" rtlCol="0" anchor="ctr"/>
           <a:lstStyle/>
           <a:p>
-            <a:pPr marL="0" indent="0" algn="ctr">
+            <a:pPr algn="ctr" indent="0" marL="0">
               <a:buNone/>
             </a:pPr>
             <a:r>
@@ -6742,13 +6716,6 @@
           </a:solidFill>
           <a:ln/>
         </p:spPr>
-        <p:txBody>
-          <a:bodyPr/>
-          <a:lstStyle/>
-          <a:p>
-            <a:endParaRPr lang="en-DE"/>
-          </a:p>
-        </p:txBody>
       </p:sp>
       <p:sp>
         <p:nvSpPr>
@@ -6771,7 +6738,7 @@
           <a:bodyPr wrap="square" lIns="0" tIns="0" rIns="0" bIns="0" rtlCol="0" anchor="ctr"/>
           <a:lstStyle/>
           <a:p>
-            <a:pPr marL="0" indent="0" algn="ctr">
+            <a:pPr algn="ctr" indent="0" marL="0">
               <a:buNone/>
             </a:pPr>
             <a:r>
@@ -6815,13 +6782,6 @@
             <a:prstDash val="solid"/>
           </a:ln>
         </p:spPr>
-        <p:txBody>
-          <a:bodyPr/>
-          <a:lstStyle/>
-          <a:p>
-            <a:endParaRPr lang="en-DE"/>
-          </a:p>
-        </p:txBody>
       </p:sp>
       <p:sp>
         <p:nvSpPr>
@@ -6844,7 +6804,7 @@
           <a:bodyPr wrap="square" lIns="0" tIns="0" rIns="0" bIns="0" rtlCol="0" anchor="ctr"/>
           <a:lstStyle/>
           <a:p>
-            <a:pPr marL="0" indent="0">
+            <a:pPr indent="0" marL="0">
               <a:buNone/>
             </a:pPr>
             <a:r>
@@ -6883,7 +6843,7 @@
           <a:bodyPr wrap="square" lIns="0" tIns="0" rIns="0" bIns="0" rtlCol="0" anchor="ctr"/>
           <a:lstStyle/>
           <a:p>
-            <a:pPr marL="0" indent="0">
+            <a:pPr indent="0" marL="0">
               <a:buNone/>
             </a:pPr>
             <a:r>
@@ -6927,13 +6887,6 @@
             <a:prstDash val="solid"/>
           </a:ln>
         </p:spPr>
-        <p:txBody>
-          <a:bodyPr/>
-          <a:lstStyle/>
-          <a:p>
-            <a:endParaRPr lang="en-DE"/>
-          </a:p>
-        </p:txBody>
       </p:sp>
       <p:sp>
         <p:nvSpPr>
@@ -6956,7 +6909,7 @@
           <a:bodyPr wrap="square" lIns="0" tIns="0" rIns="0" bIns="0" rtlCol="0" anchor="ctr"/>
           <a:lstStyle/>
           <a:p>
-            <a:pPr marL="0" indent="0">
+            <a:pPr indent="0" marL="0">
               <a:buNone/>
             </a:pPr>
             <a:r>
@@ -6995,7 +6948,7 @@
           <a:bodyPr wrap="square" lIns="0" tIns="0" rIns="0" bIns="0" rtlCol="0" anchor="ctr"/>
           <a:lstStyle/>
           <a:p>
-            <a:pPr marL="0" indent="0">
+            <a:pPr indent="0" marL="0">
               <a:buNone/>
             </a:pPr>
             <a:r>
@@ -7039,13 +6992,6 @@
             <a:prstDash val="solid"/>
           </a:ln>
         </p:spPr>
-        <p:txBody>
-          <a:bodyPr/>
-          <a:lstStyle/>
-          <a:p>
-            <a:endParaRPr lang="en-DE"/>
-          </a:p>
-        </p:txBody>
       </p:sp>
       <p:sp>
         <p:nvSpPr>
@@ -7068,7 +7014,7 @@
           <a:bodyPr wrap="square" lIns="0" tIns="0" rIns="0" bIns="0" rtlCol="0" anchor="ctr"/>
           <a:lstStyle/>
           <a:p>
-            <a:pPr marL="0" indent="0">
+            <a:pPr indent="0" marL="0">
               <a:buNone/>
             </a:pPr>
             <a:r>
@@ -7107,7 +7053,7 @@
           <a:bodyPr wrap="square" lIns="0" tIns="0" rIns="0" bIns="0" rtlCol="0" anchor="ctr"/>
           <a:lstStyle/>
           <a:p>
-            <a:pPr marL="0" indent="0">
+            <a:pPr indent="0" marL="0">
               <a:buNone/>
             </a:pPr>
             <a:r>
@@ -7146,7 +7092,7 @@
           <a:bodyPr wrap="square" rtlCol="0" anchor="ctr"/>
           <a:lstStyle/>
           <a:p>
-            <a:pPr marL="0" indent="0">
+            <a:pPr indent="0" marL="0">
               <a:buNone/>
             </a:pPr>
             <a:r>
@@ -7291,13 +7237,6 @@
           </a:solidFill>
           <a:ln/>
         </p:spPr>
-        <p:txBody>
-          <a:bodyPr/>
-          <a:lstStyle/>
-          <a:p>
-            <a:endParaRPr lang="en-DE"/>
-          </a:p>
-        </p:txBody>
       </p:sp>
       <p:sp>
         <p:nvSpPr>
@@ -7320,7 +7259,7 @@
           <a:bodyPr wrap="square" lIns="0" tIns="0" rIns="0" bIns="0" rtlCol="0" anchor="ctr"/>
           <a:lstStyle/>
           <a:p>
-            <a:pPr marL="0" indent="0">
+            <a:pPr indent="0" marL="0">
               <a:buNone/>
             </a:pPr>
             <a:r>
@@ -7359,7 +7298,7 @@
           <a:bodyPr wrap="square" lIns="0" tIns="0" rIns="0" bIns="0" rtlCol="0" anchor="ctr"/>
           <a:lstStyle/>
           <a:p>
-            <a:pPr marL="0" indent="0">
+            <a:pPr indent="0" marL="0">
               <a:buNone/>
             </a:pPr>
             <a:r>
@@ -7423,7 +7362,7 @@
           <a:bodyPr wrap="square" rtlCol="0" anchor="ctr"/>
           <a:lstStyle/>
           <a:p>
-            <a:pPr marL="0" indent="0">
+            <a:pPr indent="0" marL="0">
               <a:buNone/>
             </a:pPr>
             <a:r>
@@ -7462,7 +7401,7 @@
           <a:bodyPr wrap="square" rtlCol="0" anchor="ctr"/>
           <a:lstStyle/>
           <a:p>
-            <a:pPr marL="0" indent="0">
+            <a:pPr indent="0" marL="0">
               <a:buNone/>
             </a:pPr>
             <a:r>
@@ -7499,13 +7438,6 @@
           </a:solidFill>
           <a:ln/>
         </p:spPr>
-        <p:txBody>
-          <a:bodyPr/>
-          <a:lstStyle/>
-          <a:p>
-            <a:endParaRPr lang="en-DE"/>
-          </a:p>
-        </p:txBody>
       </p:sp>
       <p:sp>
         <p:nvSpPr>
@@ -7528,7 +7460,7 @@
           <a:bodyPr wrap="square" lIns="0" tIns="0" rIns="0" bIns="0" rtlCol="0" anchor="ctr"/>
           <a:lstStyle/>
           <a:p>
-            <a:pPr marL="0" indent="0" algn="ctr">
+            <a:pPr algn="ctr" indent="0" marL="0">
               <a:buNone/>
             </a:pPr>
             <a:r>
@@ -7565,13 +7497,6 @@
           </a:solidFill>
           <a:ln/>
         </p:spPr>
-        <p:txBody>
-          <a:bodyPr/>
-          <a:lstStyle/>
-          <a:p>
-            <a:endParaRPr lang="en-DE"/>
-          </a:p>
-        </p:txBody>
       </p:sp>
       <p:sp>
         <p:nvSpPr>
@@ -7594,7 +7519,7 @@
           <a:bodyPr wrap="square" lIns="0" tIns="0" rIns="0" bIns="0" rtlCol="0" anchor="ctr"/>
           <a:lstStyle/>
           <a:p>
-            <a:pPr marL="0" indent="0" algn="ctr">
+            <a:pPr algn="ctr" indent="0" marL="0">
               <a:buNone/>
             </a:pPr>
             <a:r>
@@ -7631,13 +7556,6 @@
           </a:solidFill>
           <a:ln/>
         </p:spPr>
-        <p:txBody>
-          <a:bodyPr/>
-          <a:lstStyle/>
-          <a:p>
-            <a:endParaRPr lang="en-DE"/>
-          </a:p>
-        </p:txBody>
       </p:sp>
       <p:sp>
         <p:nvSpPr>
@@ -7660,7 +7578,7 @@
           <a:bodyPr wrap="square" lIns="0" tIns="0" rIns="0" bIns="0" rtlCol="0" anchor="ctr"/>
           <a:lstStyle/>
           <a:p>
-            <a:pPr marL="0" indent="0" algn="ctr">
+            <a:pPr algn="ctr" indent="0" marL="0">
               <a:buNone/>
             </a:pPr>
             <a:r>
@@ -7697,13 +7615,6 @@
           </a:solidFill>
           <a:ln/>
         </p:spPr>
-        <p:txBody>
-          <a:bodyPr/>
-          <a:lstStyle/>
-          <a:p>
-            <a:endParaRPr lang="en-DE"/>
-          </a:p>
-        </p:txBody>
       </p:sp>
       <p:sp>
         <p:nvSpPr>
@@ -7726,7 +7637,7 @@
           <a:bodyPr wrap="square" lIns="0" tIns="0" rIns="0" bIns="0" rtlCol="0" anchor="ctr"/>
           <a:lstStyle/>
           <a:p>
-            <a:pPr marL="0" indent="0" algn="ctr">
+            <a:pPr algn="ctr" indent="0" marL="0">
               <a:buNone/>
             </a:pPr>
             <a:r>
@@ -7770,13 +7681,6 @@
             <a:prstDash val="solid"/>
           </a:ln>
         </p:spPr>
-        <p:txBody>
-          <a:bodyPr/>
-          <a:lstStyle/>
-          <a:p>
-            <a:endParaRPr lang="en-DE"/>
-          </a:p>
-        </p:txBody>
       </p:sp>
       <p:sp>
         <p:nvSpPr>
@@ -7799,7 +7703,7 @@
           <a:bodyPr wrap="square" lIns="0" tIns="0" rIns="0" bIns="0" rtlCol="0" anchor="ctr"/>
           <a:lstStyle/>
           <a:p>
-            <a:pPr marL="0" indent="0">
+            <a:pPr indent="0" marL="0">
               <a:buNone/>
             </a:pPr>
             <a:r>
@@ -7838,7 +7742,7 @@
           <a:bodyPr wrap="square" lIns="0" tIns="0" rIns="0" bIns="0" rtlCol="0" anchor="ctr"/>
           <a:lstStyle/>
           <a:p>
-            <a:pPr marL="0" indent="0">
+            <a:pPr indent="0" marL="0">
               <a:buNone/>
             </a:pPr>
             <a:r>
@@ -7882,13 +7786,6 @@
             <a:prstDash val="solid"/>
           </a:ln>
         </p:spPr>
-        <p:txBody>
-          <a:bodyPr/>
-          <a:lstStyle/>
-          <a:p>
-            <a:endParaRPr lang="en-DE"/>
-          </a:p>
-        </p:txBody>
       </p:sp>
       <p:sp>
         <p:nvSpPr>
@@ -7911,7 +7808,7 @@
           <a:bodyPr wrap="square" lIns="0" tIns="0" rIns="0" bIns="0" rtlCol="0" anchor="ctr"/>
           <a:lstStyle/>
           <a:p>
-            <a:pPr marL="0" indent="0">
+            <a:pPr indent="0" marL="0">
               <a:buNone/>
             </a:pPr>
             <a:r>
@@ -7950,7 +7847,7 @@
           <a:bodyPr wrap="square" lIns="0" tIns="0" rIns="0" bIns="0" rtlCol="0" anchor="ctr"/>
           <a:lstStyle/>
           <a:p>
-            <a:pPr marL="0" indent="0">
+            <a:pPr indent="0" marL="0">
               <a:buNone/>
             </a:pPr>
             <a:r>
@@ -7994,13 +7891,6 @@
             <a:prstDash val="solid"/>
           </a:ln>
         </p:spPr>
-        <p:txBody>
-          <a:bodyPr/>
-          <a:lstStyle/>
-          <a:p>
-            <a:endParaRPr lang="en-DE"/>
-          </a:p>
-        </p:txBody>
       </p:sp>
       <p:sp>
         <p:nvSpPr>
@@ -8023,7 +7913,7 @@
           <a:bodyPr wrap="square" lIns="0" tIns="0" rIns="0" bIns="0" rtlCol="0" anchor="ctr"/>
           <a:lstStyle/>
           <a:p>
-            <a:pPr marL="0" indent="0">
+            <a:pPr indent="0" marL="0">
               <a:buNone/>
             </a:pPr>
             <a:r>
@@ -8062,7 +7952,7 @@
           <a:bodyPr wrap="square" lIns="0" tIns="0" rIns="0" bIns="0" rtlCol="0" anchor="ctr"/>
           <a:lstStyle/>
           <a:p>
-            <a:pPr marL="0" indent="0">
+            <a:pPr indent="0" marL="0">
               <a:buNone/>
             </a:pPr>
             <a:r>
@@ -8106,13 +7996,6 @@
             <a:prstDash val="solid"/>
           </a:ln>
         </p:spPr>
-        <p:txBody>
-          <a:bodyPr/>
-          <a:lstStyle/>
-          <a:p>
-            <a:endParaRPr lang="en-DE"/>
-          </a:p>
-        </p:txBody>
       </p:sp>
       <p:sp>
         <p:nvSpPr>
@@ -8135,7 +8018,7 @@
           <a:bodyPr wrap="square" lIns="0" tIns="0" rIns="0" bIns="0" rtlCol="0" anchor="ctr"/>
           <a:lstStyle/>
           <a:p>
-            <a:pPr marL="0" indent="0">
+            <a:pPr indent="0" marL="0">
               <a:buNone/>
             </a:pPr>
             <a:r>
@@ -8174,7 +8057,7 @@
           <a:bodyPr wrap="square" lIns="0" tIns="0" rIns="0" bIns="0" rtlCol="0" anchor="ctr"/>
           <a:lstStyle/>
           <a:p>
-            <a:pPr marL="0" indent="0">
+            <a:pPr indent="0" marL="0">
               <a:buNone/>
             </a:pPr>
             <a:r>
@@ -8218,13 +8101,6 @@
             <a:prstDash val="solid"/>
           </a:ln>
         </p:spPr>
-        <p:txBody>
-          <a:bodyPr/>
-          <a:lstStyle/>
-          <a:p>
-            <a:endParaRPr lang="en-DE"/>
-          </a:p>
-        </p:txBody>
       </p:sp>
       <p:sp>
         <p:nvSpPr>
@@ -8247,7 +8123,7 @@
           <a:bodyPr wrap="square" lIns="0" tIns="0" rIns="0" bIns="0" rtlCol="0" anchor="ctr"/>
           <a:lstStyle/>
           <a:p>
-            <a:pPr marL="0" indent="0">
+            <a:pPr indent="0" marL="0">
               <a:buNone/>
             </a:pPr>
             <a:r>
@@ -8311,7 +8187,7 @@
           <a:bodyPr wrap="square" rtlCol="0" anchor="ctr"/>
           <a:lstStyle/>
           <a:p>
-            <a:pPr marL="0" indent="0">
+            <a:pPr indent="0" marL="0">
               <a:buNone/>
             </a:pPr>
             <a:r>
@@ -8350,7 +8226,7 @@
           <a:bodyPr wrap="square" rtlCol="0" anchor="ctr"/>
           <a:lstStyle/>
           <a:p>
-            <a:pPr marL="0" indent="0">
+            <a:pPr indent="0" marL="0">
               <a:buNone/>
             </a:pPr>
             <a:r>
@@ -8362,7 +8238,7 @@
                 <a:ea typeface="Calibri" pitchFamily="34" charset="-122"/>
                 <a:cs typeface="Calibri" pitchFamily="34" charset="-120"/>
               </a:rPr>
-              <a:t>CLARA — Capture, Listen, Analyze, Respond, Adapt (parallel build: Odradek)</a:t>
+              <a:t>CLARA — Capture, Listen, Analyze, Respond, Adapt</a:t>
             </a:r>
             <a:endParaRPr lang="en-US" sz="1400" dirty="0"/>
           </a:p>
@@ -8387,13 +8263,6 @@
           </a:solidFill>
           <a:ln/>
         </p:spPr>
-        <p:txBody>
-          <a:bodyPr/>
-          <a:lstStyle/>
-          <a:p>
-            <a:endParaRPr lang="en-DE"/>
-          </a:p>
-        </p:txBody>
       </p:sp>
       <p:sp>
         <p:nvSpPr>
@@ -8416,7 +8285,7 @@
           <a:bodyPr wrap="square" lIns="0" tIns="0" rIns="0" bIns="0" rtlCol="0" anchor="ctr"/>
           <a:lstStyle/>
           <a:p>
-            <a:pPr marL="0" indent="0" algn="ctr">
+            <a:pPr algn="ctr" indent="0" marL="0">
               <a:buNone/>
             </a:pPr>
             <a:r>
@@ -8453,13 +8322,6 @@
           </a:solidFill>
           <a:ln/>
         </p:spPr>
-        <p:txBody>
-          <a:bodyPr/>
-          <a:lstStyle/>
-          <a:p>
-            <a:endParaRPr lang="en-DE"/>
-          </a:p>
-        </p:txBody>
       </p:sp>
       <p:sp>
         <p:nvSpPr>
@@ -8482,7 +8344,7 @@
           <a:bodyPr wrap="square" lIns="0" tIns="0" rIns="0" bIns="0" rtlCol="0" anchor="ctr"/>
           <a:lstStyle/>
           <a:p>
-            <a:pPr marL="0" indent="0" algn="ctr">
+            <a:pPr algn="ctr" indent="0" marL="0">
               <a:buNone/>
             </a:pPr>
             <a:r>
@@ -8519,13 +8381,6 @@
           </a:solidFill>
           <a:ln/>
         </p:spPr>
-        <p:txBody>
-          <a:bodyPr/>
-          <a:lstStyle/>
-          <a:p>
-            <a:endParaRPr lang="en-DE"/>
-          </a:p>
-        </p:txBody>
       </p:sp>
       <p:sp>
         <p:nvSpPr>
@@ -8548,7 +8403,7 @@
           <a:bodyPr wrap="square" lIns="0" tIns="0" rIns="0" bIns="0" rtlCol="0" anchor="ctr"/>
           <a:lstStyle/>
           <a:p>
-            <a:pPr marL="0" indent="0" algn="ctr">
+            <a:pPr algn="ctr" indent="0" marL="0">
               <a:buNone/>
             </a:pPr>
             <a:r>
@@ -8585,13 +8440,6 @@
           </a:solidFill>
           <a:ln/>
         </p:spPr>
-        <p:txBody>
-          <a:bodyPr/>
-          <a:lstStyle/>
-          <a:p>
-            <a:endParaRPr lang="en-DE"/>
-          </a:p>
-        </p:txBody>
       </p:sp>
       <p:sp>
         <p:nvSpPr>
@@ -8614,7 +8462,7 @@
           <a:bodyPr wrap="square" lIns="0" tIns="0" rIns="0" bIns="0" rtlCol="0" anchor="ctr"/>
           <a:lstStyle/>
           <a:p>
-            <a:pPr marL="0" indent="0" algn="ctr">
+            <a:pPr algn="ctr" indent="0" marL="0">
               <a:buNone/>
             </a:pPr>
             <a:r>
@@ -8634,14 +8482,14 @@
       </p:sp>
       <p:pic>
         <p:nvPicPr>
-          <p:cNvPr id="12" name="Image 0" descr="/Users/olamakri/Documents/Thesis_writing/diagrams/rendered/01_architecture_logical.png"/>
+          <p:cNvPr id="12" name="Image 0" descr="/Users/olamakri/Documents/CLARA/.claude/worktrees/review-phase-a/thesis/diagrams/rendered/01_architecture_logical.png">    </p:cNvPr>
           <p:cNvPicPr>
             <a:picLocks noChangeAspect="1"/>
           </p:cNvPicPr>
           <p:nvPr/>
         </p:nvPicPr>
         <p:blipFill>
-          <a:blip r:embed="rId3"/>
+          <a:blip r:embed="rId1"/>
           <a:stretch>
             <a:fillRect/>
           </a:stretch>
@@ -8677,7 +8525,7 @@
           <a:bodyPr wrap="square" rtlCol="0" anchor="ctr"/>
           <a:lstStyle/>
           <a:p>
-            <a:pPr marL="0" indent="0">
+            <a:pPr indent="0" marL="0">
               <a:buNone/>
             </a:pPr>
             <a:r>
@@ -8741,7 +8589,7 @@
           <a:bodyPr wrap="square" rtlCol="0" anchor="ctr"/>
           <a:lstStyle/>
           <a:p>
-            <a:pPr marL="0" indent="0">
+            <a:pPr indent="0" marL="0">
               <a:buNone/>
             </a:pPr>
             <a:r>
@@ -8780,7 +8628,7 @@
           <a:bodyPr wrap="square" rtlCol="0" anchor="ctr"/>
           <a:lstStyle/>
           <a:p>
-            <a:pPr marL="0" indent="0">
+            <a:pPr indent="0" marL="0">
               <a:buNone/>
             </a:pPr>
             <a:r>
@@ -8817,13 +8665,6 @@
           </a:solidFill>
           <a:ln/>
         </p:spPr>
-        <p:txBody>
-          <a:bodyPr/>
-          <a:lstStyle/>
-          <a:p>
-            <a:endParaRPr lang="en-DE"/>
-          </a:p>
-        </p:txBody>
       </p:sp>
       <p:sp>
         <p:nvSpPr>
@@ -8846,7 +8687,7 @@
           <a:bodyPr wrap="square" lIns="0" tIns="0" rIns="0" bIns="0" rtlCol="0" anchor="ctr"/>
           <a:lstStyle/>
           <a:p>
-            <a:pPr marL="0" indent="0" algn="ctr">
+            <a:pPr algn="ctr" indent="0" marL="0">
               <a:buNone/>
             </a:pPr>
             <a:r>
@@ -8883,13 +8724,6 @@
           </a:solidFill>
           <a:ln/>
         </p:spPr>
-        <p:txBody>
-          <a:bodyPr/>
-          <a:lstStyle/>
-          <a:p>
-            <a:endParaRPr lang="en-DE"/>
-          </a:p>
-        </p:txBody>
       </p:sp>
       <p:sp>
         <p:nvSpPr>
@@ -8912,7 +8746,7 @@
           <a:bodyPr wrap="square" lIns="0" tIns="0" rIns="0" bIns="0" rtlCol="0" anchor="ctr"/>
           <a:lstStyle/>
           <a:p>
-            <a:pPr marL="0" indent="0" algn="ctr">
+            <a:pPr algn="ctr" indent="0" marL="0">
               <a:buNone/>
             </a:pPr>
             <a:r>
@@ -8949,13 +8783,6 @@
           </a:solidFill>
           <a:ln/>
         </p:spPr>
-        <p:txBody>
-          <a:bodyPr/>
-          <a:lstStyle/>
-          <a:p>
-            <a:endParaRPr lang="en-DE"/>
-          </a:p>
-        </p:txBody>
       </p:sp>
       <p:sp>
         <p:nvSpPr>
@@ -8978,7 +8805,7 @@
           <a:bodyPr wrap="square" lIns="0" tIns="0" rIns="0" bIns="0" rtlCol="0" anchor="ctr"/>
           <a:lstStyle/>
           <a:p>
-            <a:pPr marL="0" indent="0" algn="ctr">
+            <a:pPr algn="ctr" indent="0" marL="0">
               <a:buNone/>
             </a:pPr>
             <a:r>
@@ -9015,13 +8842,6 @@
           </a:solidFill>
           <a:ln/>
         </p:spPr>
-        <p:txBody>
-          <a:bodyPr/>
-          <a:lstStyle/>
-          <a:p>
-            <a:endParaRPr lang="en-DE"/>
-          </a:p>
-        </p:txBody>
       </p:sp>
       <p:sp>
         <p:nvSpPr>
@@ -9044,7 +8864,7 @@
           <a:bodyPr wrap="square" lIns="0" tIns="0" rIns="0" bIns="0" rtlCol="0" anchor="ctr"/>
           <a:lstStyle/>
           <a:p>
-            <a:pPr marL="0" indent="0" algn="ctr">
+            <a:pPr algn="ctr" indent="0" marL="0">
               <a:buNone/>
             </a:pPr>
             <a:r>
@@ -9088,13 +8908,6 @@
             <a:prstDash val="solid"/>
           </a:ln>
         </p:spPr>
-        <p:txBody>
-          <a:bodyPr/>
-          <a:lstStyle/>
-          <a:p>
-            <a:endParaRPr lang="en-DE"/>
-          </a:p>
-        </p:txBody>
       </p:sp>
       <p:sp>
         <p:nvSpPr>
@@ -9117,7 +8930,7 @@
           <a:bodyPr wrap="square" lIns="0" tIns="0" rIns="0" bIns="0" rtlCol="0" anchor="ctr"/>
           <a:lstStyle/>
           <a:p>
-            <a:pPr marL="0" indent="0">
+            <a:pPr indent="0" marL="0">
               <a:buNone/>
             </a:pPr>
             <a:r>
@@ -9156,7 +8969,7 @@
           <a:bodyPr wrap="square" lIns="0" tIns="0" rIns="0" bIns="0" rtlCol="0" anchor="ctr"/>
           <a:lstStyle/>
           <a:p>
-            <a:pPr marL="0" indent="0">
+            <a:pPr indent="0" marL="0">
               <a:buNone/>
             </a:pPr>
             <a:r>
@@ -9200,13 +9013,6 @@
             <a:prstDash val="solid"/>
           </a:ln>
         </p:spPr>
-        <p:txBody>
-          <a:bodyPr/>
-          <a:lstStyle/>
-          <a:p>
-            <a:endParaRPr lang="en-DE"/>
-          </a:p>
-        </p:txBody>
       </p:sp>
       <p:sp>
         <p:nvSpPr>
@@ -9229,7 +9035,7 @@
           <a:bodyPr wrap="square" lIns="0" tIns="0" rIns="0" bIns="0" rtlCol="0" anchor="ctr"/>
           <a:lstStyle/>
           <a:p>
-            <a:pPr marL="0" indent="0">
+            <a:pPr indent="0" marL="0">
               <a:buNone/>
             </a:pPr>
             <a:r>
@@ -9268,7 +9074,7 @@
           <a:bodyPr wrap="square" lIns="0" tIns="0" rIns="0" bIns="0" rtlCol="0" anchor="ctr"/>
           <a:lstStyle/>
           <a:p>
-            <a:pPr marL="0" indent="0">
+            <a:pPr indent="0" marL="0">
               <a:buNone/>
             </a:pPr>
             <a:r>
@@ -9312,13 +9118,6 @@
             <a:prstDash val="solid"/>
           </a:ln>
         </p:spPr>
-        <p:txBody>
-          <a:bodyPr/>
-          <a:lstStyle/>
-          <a:p>
-            <a:endParaRPr lang="en-DE"/>
-          </a:p>
-        </p:txBody>
       </p:sp>
       <p:sp>
         <p:nvSpPr>
@@ -9341,7 +9140,7 @@
           <a:bodyPr wrap="square" lIns="0" tIns="0" rIns="0" bIns="0" rtlCol="0" anchor="ctr"/>
           <a:lstStyle/>
           <a:p>
-            <a:pPr marL="0" indent="0">
+            <a:pPr indent="0" marL="0">
               <a:buNone/>
             </a:pPr>
             <a:r>
@@ -9380,7 +9179,7 @@
           <a:bodyPr wrap="square" lIns="0" tIns="0" rIns="0" bIns="0" rtlCol="0" anchor="ctr"/>
           <a:lstStyle/>
           <a:p>
-            <a:pPr marL="0" indent="0">
+            <a:pPr indent="0" marL="0">
               <a:buNone/>
             </a:pPr>
             <a:r>
@@ -9424,13 +9223,6 @@
             <a:prstDash val="solid"/>
           </a:ln>
         </p:spPr>
-        <p:txBody>
-          <a:bodyPr/>
-          <a:lstStyle/>
-          <a:p>
-            <a:endParaRPr lang="en-DE"/>
-          </a:p>
-        </p:txBody>
       </p:sp>
       <p:sp>
         <p:nvSpPr>
@@ -9453,7 +9245,7 @@
           <a:bodyPr wrap="square" lIns="0" tIns="0" rIns="0" bIns="0" rtlCol="0" anchor="ctr"/>
           <a:lstStyle/>
           <a:p>
-            <a:pPr marL="0" indent="0">
+            <a:pPr indent="0" marL="0">
               <a:buNone/>
             </a:pPr>
             <a:r>
@@ -9492,7 +9284,7 @@
           <a:bodyPr wrap="square" lIns="0" tIns="0" rIns="0" bIns="0" rtlCol="0" anchor="ctr"/>
           <a:lstStyle/>
           <a:p>
-            <a:pPr marL="0" indent="0">
+            <a:pPr indent="0" marL="0">
               <a:buNone/>
             </a:pPr>
             <a:r>
@@ -9536,13 +9328,6 @@
             <a:prstDash val="solid"/>
           </a:ln>
         </p:spPr>
-        <p:txBody>
-          <a:bodyPr/>
-          <a:lstStyle/>
-          <a:p>
-            <a:endParaRPr lang="en-DE"/>
-          </a:p>
-        </p:txBody>
       </p:sp>
       <p:sp>
         <p:nvSpPr>
@@ -9565,7 +9350,7 @@
           <a:bodyPr wrap="square" lIns="0" tIns="0" rIns="0" bIns="0" rtlCol="0" anchor="ctr"/>
           <a:lstStyle/>
           <a:p>
-            <a:pPr marL="0" indent="0">
+            <a:pPr indent="0" marL="0">
               <a:buNone/>
             </a:pPr>
             <a:r>
@@ -9604,7 +9389,7 @@
           <a:bodyPr wrap="square" lIns="0" tIns="0" rIns="0" bIns="0" rtlCol="0" anchor="ctr"/>
           <a:lstStyle/>
           <a:p>
-            <a:pPr marL="0" indent="0">
+            <a:pPr indent="0" marL="0">
               <a:buNone/>
             </a:pPr>
             <a:r>
@@ -9643,13 +9428,6 @@
           </a:solidFill>
           <a:ln/>
         </p:spPr>
-        <p:txBody>
-          <a:bodyPr/>
-          <a:lstStyle/>
-          <a:p>
-            <a:endParaRPr lang="en-DE"/>
-          </a:p>
-        </p:txBody>
       </p:sp>
       <p:sp>
         <p:nvSpPr>
@@ -9672,7 +9450,7 @@
           <a:bodyPr wrap="square" lIns="0" tIns="0" rIns="0" bIns="0" rtlCol="0" anchor="ctr"/>
           <a:lstStyle/>
           <a:p>
-            <a:pPr marL="0" indent="0">
+            <a:pPr indent="0" marL="0">
               <a:buNone/>
             </a:pPr>
             <a:r>
@@ -9711,7 +9489,7 @@
           <a:bodyPr wrap="square" lIns="0" tIns="0" rIns="0" bIns="0" rtlCol="0" anchor="ctr"/>
           <a:lstStyle/>
           <a:p>
-            <a:pPr marL="0" indent="0">
+            <a:pPr indent="0" marL="0">
               <a:buNone/>
             </a:pPr>
             <a:r>
@@ -9775,7 +9553,7 @@
           <a:bodyPr wrap="square" rtlCol="0" anchor="ctr"/>
           <a:lstStyle/>
           <a:p>
-            <a:pPr marL="0" indent="0">
+            <a:pPr indent="0" marL="0">
               <a:buNone/>
             </a:pPr>
             <a:r>
@@ -9814,7 +9592,7 @@
           <a:bodyPr wrap="square" rtlCol="0" anchor="ctr"/>
           <a:lstStyle/>
           <a:p>
-            <a:pPr marL="0" indent="0">
+            <a:pPr indent="0" marL="0">
               <a:buNone/>
             </a:pPr>
             <a:r>
@@ -9851,13 +9629,6 @@
           </a:solidFill>
           <a:ln/>
         </p:spPr>
-        <p:txBody>
-          <a:bodyPr/>
-          <a:lstStyle/>
-          <a:p>
-            <a:endParaRPr lang="en-DE"/>
-          </a:p>
-        </p:txBody>
       </p:sp>
       <p:sp>
         <p:nvSpPr>
@@ -9880,7 +9651,7 @@
           <a:bodyPr wrap="square" lIns="0" tIns="0" rIns="0" bIns="0" rtlCol="0" anchor="ctr"/>
           <a:lstStyle/>
           <a:p>
-            <a:pPr marL="0" indent="0" algn="ctr">
+            <a:pPr algn="ctr" indent="0" marL="0">
               <a:buNone/>
             </a:pPr>
             <a:r>
@@ -9917,13 +9688,6 @@
           </a:solidFill>
           <a:ln/>
         </p:spPr>
-        <p:txBody>
-          <a:bodyPr/>
-          <a:lstStyle/>
-          <a:p>
-            <a:endParaRPr lang="en-DE"/>
-          </a:p>
-        </p:txBody>
       </p:sp>
       <p:sp>
         <p:nvSpPr>
@@ -9946,7 +9710,7 @@
           <a:bodyPr wrap="square" lIns="0" tIns="0" rIns="0" bIns="0" rtlCol="0" anchor="ctr"/>
           <a:lstStyle/>
           <a:p>
-            <a:pPr marL="0" indent="0" algn="ctr">
+            <a:pPr algn="ctr" indent="0" marL="0">
               <a:buNone/>
             </a:pPr>
             <a:r>
@@ -9983,13 +9747,6 @@
           </a:solidFill>
           <a:ln/>
         </p:spPr>
-        <p:txBody>
-          <a:bodyPr/>
-          <a:lstStyle/>
-          <a:p>
-            <a:endParaRPr lang="en-DE"/>
-          </a:p>
-        </p:txBody>
       </p:sp>
       <p:sp>
         <p:nvSpPr>
@@ -10012,7 +9769,7 @@
           <a:bodyPr wrap="square" lIns="0" tIns="0" rIns="0" bIns="0" rtlCol="0" anchor="ctr"/>
           <a:lstStyle/>
           <a:p>
-            <a:pPr marL="0" indent="0" algn="ctr">
+            <a:pPr algn="ctr" indent="0" marL="0">
               <a:buNone/>
             </a:pPr>
             <a:r>
@@ -10049,13 +9806,6 @@
           </a:solidFill>
           <a:ln/>
         </p:spPr>
-        <p:txBody>
-          <a:bodyPr/>
-          <a:lstStyle/>
-          <a:p>
-            <a:endParaRPr lang="en-DE"/>
-          </a:p>
-        </p:txBody>
       </p:sp>
       <p:sp>
         <p:nvSpPr>
@@ -10078,7 +9828,7 @@
           <a:bodyPr wrap="square" lIns="0" tIns="0" rIns="0" bIns="0" rtlCol="0" anchor="ctr"/>
           <a:lstStyle/>
           <a:p>
-            <a:pPr marL="0" indent="0" algn="ctr">
+            <a:pPr algn="ctr" indent="0" marL="0">
               <a:buNone/>
             </a:pPr>
             <a:r>
@@ -10122,13 +9872,6 @@
             <a:prstDash val="solid"/>
           </a:ln>
         </p:spPr>
-        <p:txBody>
-          <a:bodyPr/>
-          <a:lstStyle/>
-          <a:p>
-            <a:endParaRPr lang="en-DE"/>
-          </a:p>
-        </p:txBody>
       </p:sp>
       <p:sp>
         <p:nvSpPr>
@@ -10151,7 +9894,7 @@
           <a:bodyPr wrap="square" lIns="0" tIns="0" rIns="0" bIns="0" rtlCol="0" anchor="ctr"/>
           <a:lstStyle/>
           <a:p>
-            <a:pPr marL="0" indent="0">
+            <a:pPr indent="0" marL="0">
               <a:buNone/>
             </a:pPr>
             <a:r>
@@ -10190,7 +9933,7 @@
           <a:bodyPr wrap="square" lIns="0" tIns="0" rIns="0" bIns="0" rtlCol="0" anchor="ctr"/>
           <a:lstStyle/>
           <a:p>
-            <a:pPr marL="0" indent="0">
+            <a:pPr indent="0" marL="0">
               <a:buNone/>
             </a:pPr>
             <a:r>
@@ -10234,13 +9977,6 @@
             <a:prstDash val="solid"/>
           </a:ln>
         </p:spPr>
-        <p:txBody>
-          <a:bodyPr/>
-          <a:lstStyle/>
-          <a:p>
-            <a:endParaRPr lang="en-DE"/>
-          </a:p>
-        </p:txBody>
       </p:sp>
       <p:sp>
         <p:nvSpPr>
@@ -10263,7 +9999,7 @@
           <a:bodyPr wrap="square" lIns="0" tIns="0" rIns="0" bIns="0" rtlCol="0" anchor="ctr"/>
           <a:lstStyle/>
           <a:p>
-            <a:pPr marL="0" indent="0">
+            <a:pPr indent="0" marL="0">
               <a:buNone/>
             </a:pPr>
             <a:r>
@@ -10302,7 +10038,7 @@
           <a:bodyPr wrap="square" lIns="0" tIns="0" rIns="0" bIns="0" rtlCol="0" anchor="ctr"/>
           <a:lstStyle/>
           <a:p>
-            <a:pPr marL="0" indent="0">
+            <a:pPr indent="0" marL="0">
               <a:buNone/>
             </a:pPr>
             <a:r>
@@ -10346,13 +10082,6 @@
             <a:prstDash val="solid"/>
           </a:ln>
         </p:spPr>
-        <p:txBody>
-          <a:bodyPr/>
-          <a:lstStyle/>
-          <a:p>
-            <a:endParaRPr lang="en-DE"/>
-          </a:p>
-        </p:txBody>
       </p:sp>
       <p:sp>
         <p:nvSpPr>
@@ -10375,7 +10104,7 @@
           <a:bodyPr wrap="square" lIns="0" tIns="0" rIns="0" bIns="0" rtlCol="0" anchor="ctr"/>
           <a:lstStyle/>
           <a:p>
-            <a:pPr marL="0" indent="0">
+            <a:pPr indent="0" marL="0">
               <a:buNone/>
             </a:pPr>
             <a:r>
@@ -10414,7 +10143,7 @@
           <a:bodyPr wrap="square" lIns="0" tIns="0" rIns="0" bIns="0" rtlCol="0" anchor="ctr"/>
           <a:lstStyle/>
           <a:p>
-            <a:pPr marL="0" indent="0">
+            <a:pPr indent="0" marL="0">
               <a:buNone/>
             </a:pPr>
             <a:r>
@@ -10458,13 +10187,6 @@
             <a:prstDash val="solid"/>
           </a:ln>
         </p:spPr>
-        <p:txBody>
-          <a:bodyPr/>
-          <a:lstStyle/>
-          <a:p>
-            <a:endParaRPr lang="en-DE"/>
-          </a:p>
-        </p:txBody>
       </p:sp>
       <p:sp>
         <p:nvSpPr>
@@ -10487,7 +10209,7 @@
           <a:bodyPr wrap="square" lIns="0" tIns="0" rIns="0" bIns="0" rtlCol="0" anchor="ctr"/>
           <a:lstStyle/>
           <a:p>
-            <a:pPr marL="0" indent="0">
+            <a:pPr indent="0" marL="0">
               <a:buNone/>
             </a:pPr>
             <a:r>
@@ -10526,7 +10248,7 @@
           <a:bodyPr wrap="square" lIns="0" tIns="0" rIns="0" bIns="0" rtlCol="0" anchor="ctr"/>
           <a:lstStyle/>
           <a:p>
-            <a:pPr marL="0" indent="0">
+            <a:pPr indent="0" marL="0">
               <a:buNone/>
             </a:pPr>
             <a:r>
@@ -10565,7 +10287,7 @@
           <a:bodyPr wrap="square" rtlCol="0" anchor="ctr"/>
           <a:lstStyle/>
           <a:p>
-            <a:pPr marL="0" indent="0">
+            <a:pPr indent="0" marL="0">
               <a:buNone/>
             </a:pPr>
             <a:r>
@@ -10629,7 +10351,7 @@
           <a:bodyPr wrap="square" rtlCol="0" anchor="ctr"/>
           <a:lstStyle/>
           <a:p>
-            <a:pPr marL="0" indent="0">
+            <a:pPr indent="0" marL="0">
               <a:buNone/>
             </a:pPr>
             <a:r>
@@ -10668,7 +10390,7 @@
           <a:bodyPr wrap="square" rtlCol="0" anchor="ctr"/>
           <a:lstStyle/>
           <a:p>
-            <a:pPr marL="0" indent="0">
+            <a:pPr indent="0" marL="0">
               <a:buNone/>
             </a:pPr>
             <a:r>
@@ -10705,13 +10427,6 @@
           </a:solidFill>
           <a:ln/>
         </p:spPr>
-        <p:txBody>
-          <a:bodyPr/>
-          <a:lstStyle/>
-          <a:p>
-            <a:endParaRPr lang="en-DE"/>
-          </a:p>
-        </p:txBody>
       </p:sp>
       <p:sp>
         <p:nvSpPr>
@@ -10734,7 +10449,7 @@
           <a:bodyPr wrap="square" lIns="0" tIns="0" rIns="0" bIns="0" rtlCol="0" anchor="ctr"/>
           <a:lstStyle/>
           <a:p>
-            <a:pPr marL="0" indent="0" algn="ctr">
+            <a:pPr algn="ctr" indent="0" marL="0">
               <a:buNone/>
             </a:pPr>
             <a:r>
@@ -10771,13 +10486,6 @@
           </a:solidFill>
           <a:ln/>
         </p:spPr>
-        <p:txBody>
-          <a:bodyPr/>
-          <a:lstStyle/>
-          <a:p>
-            <a:endParaRPr lang="en-DE"/>
-          </a:p>
-        </p:txBody>
       </p:sp>
       <p:sp>
         <p:nvSpPr>
@@ -10800,7 +10508,7 @@
           <a:bodyPr wrap="square" lIns="0" tIns="0" rIns="0" bIns="0" rtlCol="0" anchor="ctr"/>
           <a:lstStyle/>
           <a:p>
-            <a:pPr marL="0" indent="0" algn="ctr">
+            <a:pPr algn="ctr" indent="0" marL="0">
               <a:buNone/>
             </a:pPr>
             <a:r>
@@ -10837,13 +10545,6 @@
           </a:solidFill>
           <a:ln/>
         </p:spPr>
-        <p:txBody>
-          <a:bodyPr/>
-          <a:lstStyle/>
-          <a:p>
-            <a:endParaRPr lang="en-DE"/>
-          </a:p>
-        </p:txBody>
       </p:sp>
       <p:sp>
         <p:nvSpPr>
@@ -10866,7 +10567,7 @@
           <a:bodyPr wrap="square" lIns="0" tIns="0" rIns="0" bIns="0" rtlCol="0" anchor="ctr"/>
           <a:lstStyle/>
           <a:p>
-            <a:pPr marL="0" indent="0" algn="ctr">
+            <a:pPr algn="ctr" indent="0" marL="0">
               <a:buNone/>
             </a:pPr>
             <a:r>
@@ -10903,13 +10604,6 @@
           </a:solidFill>
           <a:ln/>
         </p:spPr>
-        <p:txBody>
-          <a:bodyPr/>
-          <a:lstStyle/>
-          <a:p>
-            <a:endParaRPr lang="en-DE"/>
-          </a:p>
-        </p:txBody>
       </p:sp>
       <p:sp>
         <p:nvSpPr>
@@ -10932,7 +10626,7 @@
           <a:bodyPr wrap="square" lIns="0" tIns="0" rIns="0" bIns="0" rtlCol="0" anchor="ctr"/>
           <a:lstStyle/>
           <a:p>
-            <a:pPr marL="0" indent="0" algn="ctr">
+            <a:pPr algn="ctr" indent="0" marL="0">
               <a:buNone/>
             </a:pPr>
             <a:r>
@@ -10952,14 +10646,14 @@
       </p:sp>
       <p:pic>
         <p:nvPicPr>
-          <p:cNvPr id="12" name="Image 0" descr="/Users/olamakri/Documents/Thesis_writing/diagrams/rendered/07_evaluation_pipeline.png"/>
+          <p:cNvPr id="12" name="Image 0" descr="/Users/olamakri/Documents/CLARA/.claude/worktrees/review-phase-a/thesis/diagrams/rendered/07_evaluation_pipeline.png">    </p:cNvPr>
           <p:cNvPicPr>
             <a:picLocks noChangeAspect="1"/>
           </p:cNvPicPr>
           <p:nvPr/>
         </p:nvPicPr>
         <p:blipFill>
-          <a:blip r:embed="rId3"/>
+          <a:blip r:embed="rId1"/>
           <a:stretch>
             <a:fillRect/>
           </a:stretch>
@@ -10995,7 +10689,7 @@
           <a:bodyPr wrap="square" rtlCol="0" anchor="ctr"/>
           <a:lstStyle/>
           <a:p>
-            <a:pPr marL="0" indent="0">
+            <a:pPr indent="0" marL="0">
               <a:buNone/>
             </a:pPr>
             <a:r>
@@ -11007,7 +10701,7 @@
                 <a:ea typeface="Calibri" pitchFamily="34" charset="-122"/>
                 <a:cs typeface="Calibri" pitchFamily="34" charset="-120"/>
               </a:rPr>
-              <a:t>188 real, public, paraphrased signals · 3 sectors (fintech / food delivery / B2B industrial) · EN+DE · human seed labels, authored independently of the artifact. Plus: the artifact's own committed in-repo evaluation (60-case golden set, live LLM) as convergent evidence.</a:t>
+              <a:t>188 real, public, paraphrased signals · 3 sectors (fintech / food delivery / B2B industrial) · EN+DE · human seed labels, authored independently of the artifact. Plus: the artifact's own committed in-repo evaluation (80-case bilingual golden set — 60 EN / 20 DE, live LLM) as convergent evidence.</a:t>
             </a:r>
             <a:endParaRPr lang="en-US" sz="1350" dirty="0"/>
           </a:p>
@@ -11059,7 +10753,7 @@
           <a:bodyPr wrap="square" rtlCol="0" anchor="ctr"/>
           <a:lstStyle/>
           <a:p>
-            <a:pPr marL="0" indent="0">
+            <a:pPr indent="0" marL="0">
               <a:buNone/>
             </a:pPr>
             <a:r>
@@ -11098,7 +10792,7 @@
           <a:bodyPr wrap="square" rtlCol="0" anchor="ctr"/>
           <a:lstStyle/>
           <a:p>
-            <a:pPr marL="0" indent="0">
+            <a:pPr indent="0" marL="0">
               <a:buNone/>
             </a:pPr>
             <a:r>
@@ -11135,13 +10829,6 @@
           </a:solidFill>
           <a:ln/>
         </p:spPr>
-        <p:txBody>
-          <a:bodyPr/>
-          <a:lstStyle/>
-          <a:p>
-            <a:endParaRPr lang="en-DE"/>
-          </a:p>
-        </p:txBody>
       </p:sp>
       <p:sp>
         <p:nvSpPr>
@@ -11164,7 +10851,7 @@
           <a:bodyPr wrap="square" lIns="0" tIns="0" rIns="0" bIns="0" rtlCol="0" anchor="ctr"/>
           <a:lstStyle/>
           <a:p>
-            <a:pPr marL="0" indent="0" algn="ctr">
+            <a:pPr algn="ctr" indent="0" marL="0">
               <a:buNone/>
             </a:pPr>
             <a:r>
@@ -11201,13 +10888,6 @@
           </a:solidFill>
           <a:ln/>
         </p:spPr>
-        <p:txBody>
-          <a:bodyPr/>
-          <a:lstStyle/>
-          <a:p>
-            <a:endParaRPr lang="en-DE"/>
-          </a:p>
-        </p:txBody>
       </p:sp>
       <p:sp>
         <p:nvSpPr>
@@ -11230,7 +10910,7 @@
           <a:bodyPr wrap="square" lIns="0" tIns="0" rIns="0" bIns="0" rtlCol="0" anchor="ctr"/>
           <a:lstStyle/>
           <a:p>
-            <a:pPr marL="0" indent="0" algn="ctr">
+            <a:pPr algn="ctr" indent="0" marL="0">
               <a:buNone/>
             </a:pPr>
             <a:r>
@@ -11267,13 +10947,6 @@
           </a:solidFill>
           <a:ln/>
         </p:spPr>
-        <p:txBody>
-          <a:bodyPr/>
-          <a:lstStyle/>
-          <a:p>
-            <a:endParaRPr lang="en-DE"/>
-          </a:p>
-        </p:txBody>
       </p:sp>
       <p:sp>
         <p:nvSpPr>
@@ -11296,7 +10969,7 @@
           <a:bodyPr wrap="square" lIns="0" tIns="0" rIns="0" bIns="0" rtlCol="0" anchor="ctr"/>
           <a:lstStyle/>
           <a:p>
-            <a:pPr marL="0" indent="0" algn="ctr">
+            <a:pPr algn="ctr" indent="0" marL="0">
               <a:buNone/>
             </a:pPr>
             <a:r>
@@ -11333,13 +11006,6 @@
           </a:solidFill>
           <a:ln/>
         </p:spPr>
-        <p:txBody>
-          <a:bodyPr/>
-          <a:lstStyle/>
-          <a:p>
-            <a:endParaRPr lang="en-DE"/>
-          </a:p>
-        </p:txBody>
       </p:sp>
       <p:sp>
         <p:nvSpPr>
@@ -11362,7 +11028,7 @@
           <a:bodyPr wrap="square" lIns="0" tIns="0" rIns="0" bIns="0" rtlCol="0" anchor="ctr"/>
           <a:lstStyle/>
           <a:p>
-            <a:pPr marL="0" indent="0" algn="ctr">
+            <a:pPr algn="ctr" indent="0" marL="0">
               <a:buNone/>
             </a:pPr>
             <a:r>
@@ -11382,7 +11048,7 @@
       </p:sp>
       <p:graphicFrame>
         <p:nvGraphicFramePr>
-          <p:cNvPr id="12" name="Table 0"/>
+          <p:cNvPr id="9" name="Table 0"/>
           <p:cNvGraphicFramePr>
             <a:graphicFrameLocks noGrp="1"/>
           </p:cNvGraphicFramePr>
@@ -11396,34 +11062,16 @@
         </p:nvGraphicFramePr>
         <p:xfrm>
           <a:off x="548640" y="1645920"/>
-          <a:ext cx="6675120" cy="1828800"/>
+          <a:ext cx="6675120" cy="914400"/>
         </p:xfrm>
         <a:graphic>
           <a:graphicData uri="http://schemas.openxmlformats.org/drawingml/2006/table">
             <a:tbl>
               <a:tblPr/>
               <a:tblGrid>
-                <a:gridCol w="3108960">
-                  <a:extLst>
-                    <a:ext uri="{9D8B030D-6E8A-4147-A177-3AD203B41FA5}">
-                      <a16:colId xmlns:a16="http://schemas.microsoft.com/office/drawing/2014/main" val="20000"/>
-                    </a:ext>
-                  </a:extLst>
-                </a:gridCol>
-                <a:gridCol w="1783080">
-                  <a:extLst>
-                    <a:ext uri="{9D8B030D-6E8A-4147-A177-3AD203B41FA5}">
-                      <a16:colId xmlns:a16="http://schemas.microsoft.com/office/drawing/2014/main" val="20001"/>
-                    </a:ext>
-                  </a:extLst>
-                </a:gridCol>
-                <a:gridCol w="1783080">
-                  <a:extLst>
-                    <a:ext uri="{9D8B030D-6E8A-4147-A177-3AD203B41FA5}">
-                      <a16:colId xmlns:a16="http://schemas.microsoft.com/office/drawing/2014/main" val="20002"/>
-                    </a:ext>
-                  </a:extLst>
-                </a:gridCol>
+                <a:gridCol w="3108960"/>
+                <a:gridCol w="1783080"/>
+                <a:gridCol w="1783080"/>
               </a:tblGrid>
               <a:tr h="457200">
                 <a:tc>
@@ -11431,7 +11079,7 @@
                     <a:bodyPr/>
                     <a:lstStyle/>
                     <a:p>
-                      <a:pPr marL="0" indent="0">
+                      <a:pPr indent="0" marL="0">
                         <a:buNone/>
                       </a:pPr>
                       <a:r>
@@ -11452,7 +11100,7 @@
                       </a:endParaRPr>
                     </a:p>
                   </a:txBody>
-                  <a:tcPr anchor="ctr">
+                  <a:tcPr marL="91440" marR="91440" marT="45720" marB="45720" anchor="ctr">
                     <a:lnL w="12700" cap="flat" cmpd="sng" algn="ctr">
                       <a:solidFill>
                         <a:srgbClr val="CADCFC"/>
@@ -11499,7 +11147,7 @@
                     <a:bodyPr/>
                     <a:lstStyle/>
                     <a:p>
-                      <a:pPr marL="0" indent="0">
+                      <a:pPr indent="0" marL="0">
                         <a:buNone/>
                       </a:pPr>
                       <a:r>
@@ -11520,7 +11168,7 @@
                       </a:endParaRPr>
                     </a:p>
                   </a:txBody>
-                  <a:tcPr anchor="ctr">
+                  <a:tcPr marL="91440" marR="91440" marT="45720" marB="45720" anchor="ctr">
                     <a:lnL w="12700" cap="flat" cmpd="sng" algn="ctr">
                       <a:solidFill>
                         <a:srgbClr val="CADCFC"/>
@@ -11567,7 +11215,7 @@
                     <a:bodyPr/>
                     <a:lstStyle/>
                     <a:p>
-                      <a:pPr marL="0" indent="0">
+                      <a:pPr indent="0" marL="0">
                         <a:buNone/>
                       </a:pPr>
                       <a:r>
@@ -11588,7 +11236,7 @@
                       </a:endParaRPr>
                     </a:p>
                   </a:txBody>
-                  <a:tcPr anchor="ctr">
+                  <a:tcPr marL="91440" marR="91440" marT="45720" marB="45720" anchor="ctr">
                     <a:lnL w="12700" cap="flat" cmpd="sng" algn="ctr">
                       <a:solidFill>
                         <a:srgbClr val="CADCFC"/>
@@ -11630,11 +11278,6 @@
                     </a:solidFill>
                   </a:tcPr>
                 </a:tc>
-                <a:extLst>
-                  <a:ext uri="{0D108BD9-81ED-4DB2-BD59-A6C34878D82A}">
-                    <a16:rowId xmlns:a16="http://schemas.microsoft.com/office/drawing/2014/main" val="10000"/>
-                  </a:ext>
-                </a:extLst>
               </a:tr>
               <a:tr h="457200">
                 <a:tc>
@@ -11642,7 +11285,7 @@
                     <a:bodyPr/>
                     <a:lstStyle/>
                     <a:p>
-                      <a:pPr marL="0" indent="0">
+                      <a:pPr indent="0" marL="0">
                         <a:buNone/>
                       </a:pPr>
                       <a:r>
@@ -11663,7 +11306,7 @@
                       </a:endParaRPr>
                     </a:p>
                   </a:txBody>
-                  <a:tcPr anchor="ctr">
+                  <a:tcPr marL="91440" marR="91440" marT="45720" marB="45720" anchor="ctr">
                     <a:lnL w="12700" cap="flat" cmpd="sng" algn="ctr">
                       <a:solidFill>
                         <a:srgbClr val="CADCFC"/>
@@ -11707,7 +11350,7 @@
                     <a:bodyPr/>
                     <a:lstStyle/>
                     <a:p>
-                      <a:pPr marL="0" indent="0">
+                      <a:pPr indent="0" marL="0">
                         <a:buNone/>
                       </a:pPr>
                       <a:r>
@@ -11728,7 +11371,7 @@
                       </a:endParaRPr>
                     </a:p>
                   </a:txBody>
-                  <a:tcPr anchor="ctr">
+                  <a:tcPr marL="91440" marR="91440" marT="45720" marB="45720" anchor="ctr">
                     <a:lnL w="12700" cap="flat" cmpd="sng" algn="ctr">
                       <a:solidFill>
                         <a:srgbClr val="CADCFC"/>
@@ -11772,7 +11415,7 @@
                     <a:bodyPr/>
                     <a:lstStyle/>
                     <a:p>
-                      <a:pPr marL="0" indent="0">
+                      <a:pPr indent="0" marL="0">
                         <a:buNone/>
                       </a:pPr>
                       <a:r>
@@ -11793,7 +11436,7 @@
                       </a:endParaRPr>
                     </a:p>
                   </a:txBody>
-                  <a:tcPr anchor="ctr">
+                  <a:tcPr marL="91440" marR="91440" marT="45720" marB="45720" anchor="ctr">
                     <a:lnL w="12700" cap="flat" cmpd="sng" algn="ctr">
                       <a:solidFill>
                         <a:srgbClr val="CADCFC"/>
@@ -11832,11 +11475,6 @@
                     </a:lnB>
                   </a:tcPr>
                 </a:tc>
-                <a:extLst>
-                  <a:ext uri="{0D108BD9-81ED-4DB2-BD59-A6C34878D82A}">
-                    <a16:rowId xmlns:a16="http://schemas.microsoft.com/office/drawing/2014/main" val="10001"/>
-                  </a:ext>
-                </a:extLst>
               </a:tr>
               <a:tr h="457200">
                 <a:tc>
@@ -11844,7 +11482,7 @@
                     <a:bodyPr/>
                     <a:lstStyle/>
                     <a:p>
-                      <a:pPr marL="0" indent="0">
+                      <a:pPr indent="0" marL="0">
                         <a:buNone/>
                       </a:pPr>
                       <a:r>
@@ -11865,7 +11503,7 @@
                       </a:endParaRPr>
                     </a:p>
                   </a:txBody>
-                  <a:tcPr anchor="ctr">
+                  <a:tcPr marL="91440" marR="91440" marT="45720" marB="45720" anchor="ctr">
                     <a:lnL w="12700" cap="flat" cmpd="sng" algn="ctr">
                       <a:solidFill>
                         <a:srgbClr val="CADCFC"/>
@@ -11909,7 +11547,7 @@
                     <a:bodyPr/>
                     <a:lstStyle/>
                     <a:p>
-                      <a:pPr marL="0" indent="0">
+                      <a:pPr indent="0" marL="0">
                         <a:buNone/>
                       </a:pPr>
                       <a:r>
@@ -11930,7 +11568,7 @@
                       </a:endParaRPr>
                     </a:p>
                   </a:txBody>
-                  <a:tcPr anchor="ctr">
+                  <a:tcPr marL="91440" marR="91440" marT="45720" marB="45720" anchor="ctr">
                     <a:lnL w="12700" cap="flat" cmpd="sng" algn="ctr">
                       <a:solidFill>
                         <a:srgbClr val="CADCFC"/>
@@ -11974,7 +11612,7 @@
                     <a:bodyPr/>
                     <a:lstStyle/>
                     <a:p>
-                      <a:pPr marL="0" indent="0">
+                      <a:pPr indent="0" marL="0">
                         <a:buNone/>
                       </a:pPr>
                       <a:r>
@@ -11995,7 +11633,7 @@
                       </a:endParaRPr>
                     </a:p>
                   </a:txBody>
-                  <a:tcPr anchor="ctr">
+                  <a:tcPr marL="91440" marR="91440" marT="45720" marB="45720" anchor="ctr">
                     <a:lnL w="12700" cap="flat" cmpd="sng" algn="ctr">
                       <a:solidFill>
                         <a:srgbClr val="CADCFC"/>
@@ -12034,11 +11672,6 @@
                     </a:lnB>
                   </a:tcPr>
                 </a:tc>
-                <a:extLst>
-                  <a:ext uri="{0D108BD9-81ED-4DB2-BD59-A6C34878D82A}">
-                    <a16:rowId xmlns:a16="http://schemas.microsoft.com/office/drawing/2014/main" val="10002"/>
-                  </a:ext>
-                </a:extLst>
               </a:tr>
               <a:tr h="457200">
                 <a:tc>
@@ -12046,7 +11679,7 @@
                     <a:bodyPr/>
                     <a:lstStyle/>
                     <a:p>
-                      <a:pPr marL="0" indent="0">
+                      <a:pPr indent="0" marL="0">
                         <a:buNone/>
                       </a:pPr>
                       <a:r>
@@ -12058,7 +11691,7 @@
                           <a:ea typeface="Calibri" pitchFamily="34" charset="-122"/>
                           <a:cs typeface="Calibri" pitchFamily="34" charset="-120"/>
                         </a:rPr>
-                        <a:t>LLM path (in-repo, 60-case golden set)</a:t>
+                        <a:t>LLM path (in-repo, 80-case bilingual golden set)</a:t>
                       </a:r>
                       <a:endParaRPr lang="en-US" sz="1300" dirty="0">
                         <a:latin typeface="Calibri" charset="0"/>
@@ -12067,7 +11700,7 @@
                       </a:endParaRPr>
                     </a:p>
                   </a:txBody>
-                  <a:tcPr anchor="ctr">
+                  <a:tcPr marL="91440" marR="91440" marT="45720" marB="45720" anchor="ctr">
                     <a:lnL w="12700" cap="flat" cmpd="sng" algn="ctr">
                       <a:solidFill>
                         <a:srgbClr val="CADCFC"/>
@@ -12111,7 +11744,7 @@
                     <a:bodyPr/>
                     <a:lstStyle/>
                     <a:p>
-                      <a:pPr marL="0" indent="0">
+                      <a:pPr indent="0" marL="0">
                         <a:buNone/>
                       </a:pPr>
                       <a:r>
@@ -12123,7 +11756,7 @@
                           <a:ea typeface="Calibri" pitchFamily="34" charset="-122"/>
                           <a:cs typeface="Calibri" pitchFamily="34" charset="-120"/>
                         </a:rPr>
-                        <a:t>0.97 (sentiment)</a:t>
+                        <a:t>0.975 (sentiment)</a:t>
                       </a:r>
                       <a:endParaRPr lang="en-US" sz="1300" dirty="0">
                         <a:latin typeface="Calibri" charset="0"/>
@@ -12132,7 +11765,7 @@
                       </a:endParaRPr>
                     </a:p>
                   </a:txBody>
-                  <a:tcPr anchor="ctr">
+                  <a:tcPr marL="91440" marR="91440" marT="45720" marB="45720" anchor="ctr">
                     <a:lnL w="12700" cap="flat" cmpd="sng" algn="ctr">
                       <a:solidFill>
                         <a:srgbClr val="CADCFC"/>
@@ -12176,7 +11809,7 @@
                     <a:bodyPr/>
                     <a:lstStyle/>
                     <a:p>
-                      <a:pPr marL="0" indent="0">
+                      <a:pPr indent="0" marL="0">
                         <a:buNone/>
                       </a:pPr>
                       <a:r>
@@ -12188,7 +11821,7 @@
                           <a:ea typeface="Calibri" pitchFamily="34" charset="-122"/>
                           <a:cs typeface="Calibri" pitchFamily="34" charset="-120"/>
                         </a:rPr>
-                        <a:t>0.82 (urgency)</a:t>
+                        <a:t>0.863 (urgency)</a:t>
                       </a:r>
                       <a:endParaRPr lang="en-US" sz="1300" dirty="0">
                         <a:latin typeface="Calibri" charset="0"/>
@@ -12197,7 +11830,7 @@
                       </a:endParaRPr>
                     </a:p>
                   </a:txBody>
-                  <a:tcPr anchor="ctr">
+                  <a:tcPr marL="91440" marR="91440" marT="45720" marB="45720" anchor="ctr">
                     <a:lnL w="12700" cap="flat" cmpd="sng" algn="ctr">
                       <a:solidFill>
                         <a:srgbClr val="CADCFC"/>
@@ -12236,11 +11869,6 @@
                     </a:lnB>
                   </a:tcPr>
                 </a:tc>
-                <a:extLst>
-                  <a:ext uri="{0D108BD9-81ED-4DB2-BD59-A6C34878D82A}">
-                    <a16:rowId xmlns:a16="http://schemas.microsoft.com/office/drawing/2014/main" val="10003"/>
-                  </a:ext>
-                </a:extLst>
               </a:tr>
             </a:tbl>
           </a:graphicData>
@@ -12267,7 +11895,7 @@
           <a:bodyPr wrap="square" rtlCol="0" anchor="ctr"/>
           <a:lstStyle/>
           <a:p>
-            <a:pPr marL="0" indent="0">
+            <a:pPr indent="0" marL="0">
               <a:buNone/>
             </a:pPr>
             <a:r>
@@ -12306,7 +11934,7 @@
           <a:bodyPr wrap="square" rtlCol="0" anchor="ctr"/>
           <a:lstStyle/>
           <a:p>
-            <a:pPr marL="0" indent="0">
+            <a:pPr indent="0" marL="0">
               <a:buNone/>
             </a:pPr>
             <a:r>
@@ -12318,7 +11946,7 @@
                 <a:ea typeface="Calibri" pitchFamily="34" charset="-122"/>
                 <a:cs typeface="Calibri" pitchFamily="34" charset="-120"/>
               </a:rPr>
-              <a:t>Convergent in-repo run (CLARA, GLM-5.2, 3 Jul 2026): sentiment 96.7% · urgency 81.7% · theme 80.8% by meaning vs 45.8% exact — semantic scoring vindicated. Real-data star-proxy: ≈90% across all three sectors, zero fine-tuning.</a:t>
+              <a:t>Convergent in-repo run (CLARA, GLM-5.2, 17 Jul 2026, n=80 incl. 20 DE): sentiment 97.5% (CI 94–100) · urgency 86.3% (CI 79–94) · tag F1 80.2% by meaning vs 55.5% exact-string — semantic scoring vindicated; DE within 1.7pp of EN on urgency. Real-data star-proxy: ≈90% across all three sectors, zero fine-tuning.</a:t>
             </a:r>
             <a:endParaRPr lang="en-US" sz="1300" dirty="0"/>
           </a:p>
@@ -12326,14 +11954,14 @@
       </p:sp>
       <p:pic>
         <p:nvPicPr>
-          <p:cNvPr id="15" name="Image 0" descr="/Users/olamakri/Documents/Thesis_writing/evaluation/results/risk_confusion.png"/>
+          <p:cNvPr id="15" name="Image 0" descr="/Users/olamakri/Documents/CLARA/.claude/worktrees/review-phase-a/thesis/evaluation/results/risk_confusion.png">    </p:cNvPr>
           <p:cNvPicPr>
             <a:picLocks noChangeAspect="1"/>
           </p:cNvPicPr>
           <p:nvPr/>
         </p:nvPicPr>
         <p:blipFill>
-          <a:blip r:embed="rId3"/>
+          <a:blip r:embed="rId1"/>
           <a:stretch>
             <a:fillRect/>
           </a:stretch>
@@ -12369,7 +11997,7 @@
           <a:bodyPr wrap="square" rtlCol="0" anchor="ctr"/>
           <a:lstStyle/>
           <a:p>
-            <a:pPr marL="0" indent="0">
+            <a:pPr indent="0" marL="0">
               <a:buNone/>
             </a:pPr>
             <a:r>
@@ -12433,7 +12061,7 @@
           <a:bodyPr wrap="square" rtlCol="0" anchor="ctr"/>
           <a:lstStyle/>
           <a:p>
-            <a:pPr marL="0" indent="0">
+            <a:pPr indent="0" marL="0">
               <a:buNone/>
             </a:pPr>
             <a:r>
@@ -12472,7 +12100,7 @@
           <a:bodyPr wrap="square" rtlCol="0" anchor="ctr"/>
           <a:lstStyle/>
           <a:p>
-            <a:pPr marL="0" indent="0">
+            <a:pPr indent="0" marL="0">
               <a:buNone/>
             </a:pPr>
             <a:r>
@@ -12509,13 +12137,6 @@
           </a:solidFill>
           <a:ln/>
         </p:spPr>
-        <p:txBody>
-          <a:bodyPr/>
-          <a:lstStyle/>
-          <a:p>
-            <a:endParaRPr lang="en-DE"/>
-          </a:p>
-        </p:txBody>
       </p:sp>
       <p:sp>
         <p:nvSpPr>
@@ -12538,7 +12159,7 @@
           <a:bodyPr wrap="square" lIns="0" tIns="0" rIns="0" bIns="0" rtlCol="0" anchor="ctr"/>
           <a:lstStyle/>
           <a:p>
-            <a:pPr marL="0" indent="0" algn="ctr">
+            <a:pPr algn="ctr" indent="0" marL="0">
               <a:buNone/>
             </a:pPr>
             <a:r>
@@ -12575,13 +12196,6 @@
           </a:solidFill>
           <a:ln/>
         </p:spPr>
-        <p:txBody>
-          <a:bodyPr/>
-          <a:lstStyle/>
-          <a:p>
-            <a:endParaRPr lang="en-DE"/>
-          </a:p>
-        </p:txBody>
       </p:sp>
       <p:sp>
         <p:nvSpPr>
@@ -12604,7 +12218,7 @@
           <a:bodyPr wrap="square" lIns="0" tIns="0" rIns="0" bIns="0" rtlCol="0" anchor="ctr"/>
           <a:lstStyle/>
           <a:p>
-            <a:pPr marL="0" indent="0" algn="ctr">
+            <a:pPr algn="ctr" indent="0" marL="0">
               <a:buNone/>
             </a:pPr>
             <a:r>
@@ -12641,13 +12255,6 @@
           </a:solidFill>
           <a:ln/>
         </p:spPr>
-        <p:txBody>
-          <a:bodyPr/>
-          <a:lstStyle/>
-          <a:p>
-            <a:endParaRPr lang="en-DE"/>
-          </a:p>
-        </p:txBody>
       </p:sp>
       <p:sp>
         <p:nvSpPr>
@@ -12670,7 +12277,7 @@
           <a:bodyPr wrap="square" lIns="0" tIns="0" rIns="0" bIns="0" rtlCol="0" anchor="ctr"/>
           <a:lstStyle/>
           <a:p>
-            <a:pPr marL="0" indent="0" algn="ctr">
+            <a:pPr algn="ctr" indent="0" marL="0">
               <a:buNone/>
             </a:pPr>
             <a:r>
@@ -12707,13 +12314,6 @@
           </a:solidFill>
           <a:ln/>
         </p:spPr>
-        <p:txBody>
-          <a:bodyPr/>
-          <a:lstStyle/>
-          <a:p>
-            <a:endParaRPr lang="en-DE"/>
-          </a:p>
-        </p:txBody>
       </p:sp>
       <p:sp>
         <p:nvSpPr>
@@ -12736,7 +12336,7 @@
           <a:bodyPr wrap="square" lIns="0" tIns="0" rIns="0" bIns="0" rtlCol="0" anchor="ctr"/>
           <a:lstStyle/>
           <a:p>
-            <a:pPr marL="0" indent="0" algn="ctr">
+            <a:pPr algn="ctr" indent="0" marL="0">
               <a:buNone/>
             </a:pPr>
             <a:r>
@@ -12763,7 +12363,7 @@
         <p:spPr>
           <a:xfrm>
             <a:off x="731520" y="2011680"/>
-            <a:ext cx="3875204" cy="822960"/>
+            <a:ext cx="3291840" cy="822960"/>
           </a:xfrm>
           <a:prstGeom prst="rect">
             <a:avLst/>
@@ -12775,7 +12375,7 @@
           <a:bodyPr wrap="square" lIns="0" tIns="0" rIns="0" bIns="0" rtlCol="0" anchor="ctr"/>
           <a:lstStyle/>
           <a:p>
-            <a:pPr marL="0" indent="0" algn="ctr">
+            <a:pPr algn="ctr" indent="0" marL="0">
               <a:buNone/>
             </a:pPr>
             <a:r>
@@ -12814,7 +12414,7 @@
           <a:bodyPr wrap="square" lIns="0" tIns="0" rIns="0" bIns="0" rtlCol="0" anchor="ctr"/>
           <a:lstStyle/>
           <a:p>
-            <a:pPr marL="0" indent="0" algn="ctr">
+            <a:pPr algn="ctr" indent="0" marL="0">
               <a:buNone/>
             </a:pPr>
             <a:r>
@@ -12853,7 +12453,7 @@
           <a:bodyPr wrap="square" lIns="0" tIns="0" rIns="0" bIns="0" rtlCol="0" anchor="ctr"/>
           <a:lstStyle/>
           <a:p>
-            <a:pPr marL="0" indent="0" algn="ctr">
+            <a:pPr algn="ctr" indent="0" marL="0">
               <a:buNone/>
             </a:pPr>
             <a:r>
@@ -12892,7 +12492,7 @@
           <a:bodyPr wrap="square" lIns="0" tIns="0" rIns="0" bIns="0" rtlCol="0" anchor="ctr"/>
           <a:lstStyle/>
           <a:p>
-            <a:pPr marL="0" indent="0" algn="ctr">
+            <a:pPr algn="ctr" indent="0" marL="0">
               <a:buNone/>
             </a:pPr>
             <a:r>
@@ -12931,7 +12531,7 @@
           <a:bodyPr wrap="square" lIns="0" tIns="0" rIns="0" bIns="0" rtlCol="0" anchor="ctr"/>
           <a:lstStyle/>
           <a:p>
-            <a:pPr marL="0" indent="0" algn="ctr">
+            <a:pPr algn="ctr" indent="0" marL="0">
               <a:buNone/>
             </a:pPr>
             <a:r>
@@ -12943,7 +12543,7 @@
                 <a:ea typeface="Cambria" pitchFamily="34" charset="-122"/>
                 <a:cs typeface="Cambria" pitchFamily="34" charset="-120"/>
               </a:rPr>
-              <a:t>0 / 6.7%</a:t>
+              <a:t>0 / 2.5%</a:t>
             </a:r>
             <a:endParaRPr lang="en-US" sz="5400" dirty="0"/>
           </a:p>
@@ -12970,7 +12570,7 @@
           <a:bodyPr wrap="square" lIns="0" tIns="0" rIns="0" bIns="0" rtlCol="0" anchor="ctr"/>
           <a:lstStyle/>
           <a:p>
-            <a:pPr marL="0" indent="0" algn="ctr">
+            <a:pPr algn="ctr" indent="0" marL="0">
               <a:buNone/>
             </a:pPr>
             <a:r>
@@ -12982,7 +12582,7 @@
                 <a:ea typeface="Calibri" pitchFamily="34" charset="-122"/>
                 <a:cs typeface="Calibri" pitchFamily="34" charset="-120"/>
               </a:rPr>
-              <a:t>PII leaks across ledger / hallucination rate, latest run</a:t>
+              <a:t>PII leaks across ledger / hallucination rate, latest run (hallucination check EN-scope by construction)</a:t>
             </a:r>
             <a:endParaRPr lang="en-US" sz="1250" dirty="0"/>
           </a:p>
@@ -13014,13 +12614,6 @@
             <a:prstDash val="solid"/>
           </a:ln>
         </p:spPr>
-        <p:txBody>
-          <a:bodyPr/>
-          <a:lstStyle/>
-          <a:p>
-            <a:endParaRPr lang="en-DE"/>
-          </a:p>
-        </p:txBody>
       </p:sp>
       <p:sp>
         <p:nvSpPr>
@@ -13043,7 +12636,7 @@
           <a:bodyPr wrap="square" lIns="0" tIns="0" rIns="0" bIns="0" rtlCol="0" anchor="ctr"/>
           <a:lstStyle/>
           <a:p>
-            <a:pPr marL="0" indent="0">
+            <a:pPr indent="0" marL="0">
               <a:buNone/>
             </a:pPr>
             <a:r>
@@ -13082,7 +12675,7 @@
           <a:bodyPr wrap="square" lIns="0" tIns="0" rIns="0" bIns="0" rtlCol="0" anchor="ctr"/>
           <a:lstStyle/>
           <a:p>
-            <a:pPr marL="0" indent="0">
+            <a:pPr indent="0" marL="0">
               <a:buNone/>
             </a:pPr>
             <a:r>
@@ -13401,319 +12994,4 @@
     </a:ext>
   </a:extLst>
 </a:theme>
-</file>
-
-<file path=ppt/theme/theme2.xml><?xml version="1.0" encoding="utf-8"?>
-<a:theme xmlns:a="http://schemas.openxmlformats.org/drawingml/2006/main" name="Office Theme">
-  <a:themeElements>
-    <a:clrScheme name="Office">
-      <a:dk1>
-        <a:sysClr val="windowText" lastClr="000000"/>
-      </a:dk1>
-      <a:lt1>
-        <a:sysClr val="window" lastClr="FFFFFF"/>
-      </a:lt1>
-      <a:dk2>
-        <a:srgbClr val="0E2841"/>
-      </a:dk2>
-      <a:lt2>
-        <a:srgbClr val="E8E8E8"/>
-      </a:lt2>
-      <a:accent1>
-        <a:srgbClr val="156082"/>
-      </a:accent1>
-      <a:accent2>
-        <a:srgbClr val="E97132"/>
-      </a:accent2>
-      <a:accent3>
-        <a:srgbClr val="196B24"/>
-      </a:accent3>
-      <a:accent4>
-        <a:srgbClr val="0F9ED5"/>
-      </a:accent4>
-      <a:accent5>
-        <a:srgbClr val="A02B93"/>
-      </a:accent5>
-      <a:accent6>
-        <a:srgbClr val="4EA72E"/>
-      </a:accent6>
-      <a:hlink>
-        <a:srgbClr val="467886"/>
-      </a:hlink>
-      <a:folHlink>
-        <a:srgbClr val="96607D"/>
-      </a:folHlink>
-    </a:clrScheme>
-    <a:fontScheme name="Office">
-      <a:majorFont>
-        <a:latin typeface="Aptos Display" panose="02110004020202020204"/>
-        <a:ea typeface=""/>
-        <a:cs typeface=""/>
-        <a:font script="Jpan" typeface="游ゴシック Light"/>
-        <a:font script="Hang" typeface="맑은 고딕"/>
-        <a:font script="Hans" typeface="等线 Light"/>
-        <a:font script="Hant" typeface="新細明體"/>
-        <a:font script="Arab" typeface="Times New Roman"/>
-        <a:font script="Hebr" typeface="Times New Roman"/>
-        <a:font script="Thai" typeface="Angsana New"/>
-        <a:font script="Ethi" typeface="Nyala"/>
-        <a:font script="Beng" typeface="Vrinda"/>
-        <a:font script="Gujr" typeface="Shruti"/>
-        <a:font script="Khmr" typeface="MoolBoran"/>
-        <a:font script="Knda" typeface="Tunga"/>
-        <a:font script="Guru" typeface="Raavi"/>
-        <a:font script="Cans" typeface="Euphemia"/>
-        <a:font script="Cher" typeface="Plantagenet Cherokee"/>
-        <a:font script="Yiii" typeface="Microsoft Yi Baiti"/>
-        <a:font script="Tibt" typeface="Microsoft Himalaya"/>
-        <a:font script="Thaa" typeface="MV Boli"/>
-        <a:font script="Deva" typeface="Mangal"/>
-        <a:font script="Telu" typeface="Gautami"/>
-        <a:font script="Taml" typeface="Latha"/>
-        <a:font script="Syrc" typeface="Estrangelo Edessa"/>
-        <a:font script="Orya" typeface="Kalinga"/>
-        <a:font script="Mlym" typeface="Kartika"/>
-        <a:font script="Laoo" typeface="DokChampa"/>
-        <a:font script="Sinh" typeface="Iskoola Pota"/>
-        <a:font script="Mong" typeface="Mongolian Baiti"/>
-        <a:font script="Viet" typeface="Times New Roman"/>
-        <a:font script="Uigh" typeface="Microsoft Uighur"/>
-        <a:font script="Geor" typeface="Sylfaen"/>
-        <a:font script="Armn" typeface="Arial"/>
-        <a:font script="Bugi" typeface="Leelawadee UI"/>
-        <a:font script="Bopo" typeface="Microsoft JhengHei"/>
-        <a:font script="Java" typeface="Javanese Text"/>
-        <a:font script="Lisu" typeface="Segoe UI"/>
-        <a:font script="Mymr" typeface="Myanmar Text"/>
-        <a:font script="Nkoo" typeface="Ebrima"/>
-        <a:font script="Olck" typeface="Nirmala UI"/>
-        <a:font script="Osma" typeface="Ebrima"/>
-        <a:font script="Phag" typeface="Phagspa"/>
-        <a:font script="Syrn" typeface="Estrangelo Edessa"/>
-        <a:font script="Syrj" typeface="Estrangelo Edessa"/>
-        <a:font script="Syre" typeface="Estrangelo Edessa"/>
-        <a:font script="Sora" typeface="Nirmala UI"/>
-        <a:font script="Tale" typeface="Microsoft Tai Le"/>
-        <a:font script="Talu" typeface="Microsoft New Tai Lue"/>
-        <a:font script="Tfng" typeface="Ebrima"/>
-      </a:majorFont>
-      <a:minorFont>
-        <a:latin typeface="Aptos" panose="02110004020202020204"/>
-        <a:ea typeface=""/>
-        <a:cs typeface=""/>
-        <a:font script="Jpan" typeface="游ゴシック"/>
-        <a:font script="Hang" typeface="맑은 고딕"/>
-        <a:font script="Hans" typeface="等线"/>
-        <a:font script="Hant" typeface="新細明體"/>
-        <a:font script="Arab" typeface="Arial"/>
-        <a:font script="Hebr" typeface="Arial"/>
-        <a:font script="Thai" typeface="Cordia New"/>
-        <a:font script="Ethi" typeface="Nyala"/>
-        <a:font script="Beng" typeface="Vrinda"/>
-        <a:font script="Gujr" typeface="Shruti"/>
-        <a:font script="Khmr" typeface="DaunPenh"/>
-        <a:font script="Knda" typeface="Tunga"/>
-        <a:font script="Guru" typeface="Raavi"/>
-        <a:font script="Cans" typeface="Euphemia"/>
-        <a:font script="Cher" typeface="Plantagenet Cherokee"/>
-        <a:font script="Yiii" typeface="Microsoft Yi Baiti"/>
-        <a:font script="Tibt" typeface="Microsoft Himalaya"/>
-        <a:font script="Thaa" typeface="MV Boli"/>
-        <a:font script="Deva" typeface="Mangal"/>
-        <a:font script="Telu" typeface="Gautami"/>
-        <a:font script="Taml" typeface="Latha"/>
-        <a:font script="Syrc" typeface="Estrangelo Edessa"/>
-        <a:font script="Orya" typeface="Kalinga"/>
-        <a:font script="Mlym" typeface="Kartika"/>
-        <a:font script="Laoo" typeface="DokChampa"/>
-        <a:font script="Sinh" typeface="Iskoola Pota"/>
-        <a:font script="Mong" typeface="Mongolian Baiti"/>
-        <a:font script="Viet" typeface="Arial"/>
-        <a:font script="Uigh" typeface="Microsoft Uighur"/>
-        <a:font script="Geor" typeface="Sylfaen"/>
-        <a:font script="Armn" typeface="Arial"/>
-        <a:font script="Bugi" typeface="Leelawadee UI"/>
-        <a:font script="Bopo" typeface="Microsoft JhengHei"/>
-        <a:font script="Java" typeface="Javanese Text"/>
-        <a:font script="Lisu" typeface="Segoe UI"/>
-        <a:font script="Mymr" typeface="Myanmar Text"/>
-        <a:font script="Nkoo" typeface="Ebrima"/>
-        <a:font script="Olck" typeface="Nirmala UI"/>
-        <a:font script="Osma" typeface="Ebrima"/>
-        <a:font script="Phag" typeface="Phagspa"/>
-        <a:font script="Syrn" typeface="Estrangelo Edessa"/>
-        <a:font script="Syrj" typeface="Estrangelo Edessa"/>
-        <a:font script="Syre" typeface="Estrangelo Edessa"/>
-        <a:font script="Sora" typeface="Nirmala UI"/>
-        <a:font script="Tale" typeface="Microsoft Tai Le"/>
-        <a:font script="Talu" typeface="Microsoft New Tai Lue"/>
-        <a:font script="Tfng" typeface="Ebrima"/>
-      </a:minorFont>
-    </a:fontScheme>
-    <a:fmtScheme name="Office">
-      <a:fillStyleLst>
-        <a:solidFill>
-          <a:schemeClr val="phClr"/>
-        </a:solidFill>
-        <a:gradFill rotWithShape="1">
-          <a:gsLst>
-            <a:gs pos="0">
-              <a:schemeClr val="phClr">
-                <a:lumMod val="110000"/>
-                <a:satMod val="105000"/>
-                <a:tint val="67000"/>
-              </a:schemeClr>
-            </a:gs>
-            <a:gs pos="50000">
-              <a:schemeClr val="phClr">
-                <a:lumMod val="105000"/>
-                <a:satMod val="103000"/>
-                <a:tint val="73000"/>
-              </a:schemeClr>
-            </a:gs>
-            <a:gs pos="100000">
-              <a:schemeClr val="phClr">
-                <a:lumMod val="105000"/>
-                <a:satMod val="109000"/>
-                <a:tint val="81000"/>
-              </a:schemeClr>
-            </a:gs>
-          </a:gsLst>
-          <a:lin ang="5400000" scaled="0"/>
-        </a:gradFill>
-        <a:gradFill rotWithShape="1">
-          <a:gsLst>
-            <a:gs pos="0">
-              <a:schemeClr val="phClr">
-                <a:satMod val="103000"/>
-                <a:lumMod val="102000"/>
-                <a:tint val="94000"/>
-              </a:schemeClr>
-            </a:gs>
-            <a:gs pos="50000">
-              <a:schemeClr val="phClr">
-                <a:satMod val="110000"/>
-                <a:lumMod val="100000"/>
-                <a:shade val="100000"/>
-              </a:schemeClr>
-            </a:gs>
-            <a:gs pos="100000">
-              <a:schemeClr val="phClr">
-                <a:lumMod val="99000"/>
-                <a:satMod val="120000"/>
-                <a:shade val="78000"/>
-              </a:schemeClr>
-            </a:gs>
-          </a:gsLst>
-          <a:lin ang="5400000" scaled="0"/>
-        </a:gradFill>
-      </a:fillStyleLst>
-      <a:lnStyleLst>
-        <a:ln w="12700" cap="flat" cmpd="sng" algn="ctr">
-          <a:solidFill>
-            <a:schemeClr val="phClr"/>
-          </a:solidFill>
-          <a:prstDash val="solid"/>
-          <a:miter lim="800000"/>
-        </a:ln>
-        <a:ln w="19050" cap="flat" cmpd="sng" algn="ctr">
-          <a:solidFill>
-            <a:schemeClr val="phClr"/>
-          </a:solidFill>
-          <a:prstDash val="solid"/>
-          <a:miter lim="800000"/>
-        </a:ln>
-        <a:ln w="25400" cap="flat" cmpd="sng" algn="ctr">
-          <a:solidFill>
-            <a:schemeClr val="phClr"/>
-          </a:solidFill>
-          <a:prstDash val="solid"/>
-          <a:miter lim="800000"/>
-        </a:ln>
-      </a:lnStyleLst>
-      <a:effectStyleLst>
-        <a:effectStyle>
-          <a:effectLst/>
-        </a:effectStyle>
-        <a:effectStyle>
-          <a:effectLst/>
-        </a:effectStyle>
-        <a:effectStyle>
-          <a:effectLst>
-            <a:outerShdw blurRad="57150" dist="19050" dir="5400000" algn="ctr" rotWithShape="0">
-              <a:srgbClr val="000000">
-                <a:alpha val="63000"/>
-              </a:srgbClr>
-            </a:outerShdw>
-          </a:effectLst>
-        </a:effectStyle>
-      </a:effectStyleLst>
-      <a:bgFillStyleLst>
-        <a:solidFill>
-          <a:schemeClr val="phClr"/>
-        </a:solidFill>
-        <a:solidFill>
-          <a:schemeClr val="phClr">
-            <a:tint val="95000"/>
-            <a:satMod val="170000"/>
-          </a:schemeClr>
-        </a:solidFill>
-        <a:gradFill rotWithShape="1">
-          <a:gsLst>
-            <a:gs pos="0">
-              <a:schemeClr val="phClr">
-                <a:tint val="93000"/>
-                <a:satMod val="150000"/>
-                <a:shade val="98000"/>
-                <a:lumMod val="102000"/>
-              </a:schemeClr>
-            </a:gs>
-            <a:gs pos="50000">
-              <a:schemeClr val="phClr">
-                <a:tint val="98000"/>
-                <a:satMod val="130000"/>
-                <a:shade val="90000"/>
-                <a:lumMod val="103000"/>
-              </a:schemeClr>
-            </a:gs>
-            <a:gs pos="100000">
-              <a:schemeClr val="phClr">
-                <a:shade val="63000"/>
-                <a:satMod val="120000"/>
-              </a:schemeClr>
-            </a:gs>
-          </a:gsLst>
-          <a:lin ang="5400000" scaled="0"/>
-        </a:gradFill>
-      </a:bgFillStyleLst>
-    </a:fmtScheme>
-  </a:themeElements>
-  <a:objectDefaults>
-    <a:lnDef>
-      <a:spPr/>
-      <a:bodyPr/>
-      <a:lstStyle/>
-      <a:style>
-        <a:lnRef idx="2">
-          <a:schemeClr val="accent1"/>
-        </a:lnRef>
-        <a:fillRef idx="0">
-          <a:schemeClr val="accent1"/>
-        </a:fillRef>
-        <a:effectRef idx="1">
-          <a:schemeClr val="accent1"/>
-        </a:effectRef>
-        <a:fontRef idx="minor">
-          <a:schemeClr val="tx1"/>
-        </a:fontRef>
-      </a:style>
-    </a:lnDef>
-  </a:objectDefaults>
-  <a:extraClrSchemeLst/>
-  <a:extLst>
-    <a:ext uri="{05A4C25C-085E-4340-85A3-A5531E510DB2}">
-      <thm15:themeFamily xmlns:thm15="http://schemas.microsoft.com/office/thememl/2012/main" name="Office Theme" id="{2E142A2C-CD16-42D6-873A-C26D2A0506FA}" vid="{1BDDFF52-6CD6-40A5-AB3C-68EB2F1E4D0A}"/>
-    </a:ext>
-  </a:extLst>
-</a:theme>
 </file>
</xml_diff>

<commit_message>
thesis(deck): make the equity stat pair a like-for-like comparison
'87.5 / 87.8' was two languages under one method, sitting next to a stat that
was one language under another - and at 54pt it also risked overflowing its
box. Both stats are now the SAME eight German signals under the two methods,
0 of 8 against 7 of 8, which is the contrast the slide actually makes. The
English figure moves into the label; the table below still carries the full
matrix.

Co-Authored-By: Claude Opus 5 (1M context) <noreply@anthropic.com>
</commit_message>
<xml_diff>
--- a/thesis/defense/defense_deck.pptx
+++ b/thesis/defense/defense_deck.pptx
@@ -6922,7 +6922,7 @@
                 <a:ea typeface="Calibri" pitchFamily="34" charset="-122"/>
                 <a:cs typeface="Calibri" pitchFamily="34" charset="-120"/>
               </a:rPr>
-              <a:t>critical German signals escalated by the keyword floor — none</a:t>
+              <a:t>critical German signals escalated by the keyword floor — none of them</a:t>
             </a:r>
             <a:endParaRPr lang="en-US" sz="1250" dirty="0"/>
           </a:p>
@@ -6961,7 +6961,7 @@
                 <a:ea typeface="Cambria" pitchFamily="34" charset="-122"/>
                 <a:cs typeface="Cambria" pitchFamily="34" charset="-120"/>
               </a:rPr>
-              <a:t>87.5 / 87.8</a:t>
+              <a:t>7 of 8</a:t>
             </a:r>
             <a:endParaRPr lang="en-US" sz="5400" dirty="0"/>
           </a:p>
@@ -7000,7 +7000,7 @@
                 <a:ea typeface="Calibri" pitchFamily="34" charset="-122"/>
                 <a:cs typeface="Calibri" pitchFamily="34" charset="-120"/>
               </a:rPr>
-              <a:t>German / English escalation recall on the LLM path — near-parity</a:t>
+              <a:t>the same signals, escalated by the LLM path — 87.5%, against 87.8% for English</a:t>
             </a:r>
             <a:endParaRPr lang="en-US" sz="1250" dirty="0"/>
           </a:p>

</xml_diff>

<commit_message>
thesis: editorial pass (Step 10), rater and ethics facts recorded
Abstract cut from 406 to 317 words and rewritten to the September results;
repeated caveats trimmed to one statement per chapter; §3.7 records the
second rater and the programme contact's ethics confirmation (August 2026);
consent form updated; deck results, equity and traceability slides carry
the production rows, the repeat ranges and kappa, and pass the fit check.

Co-Authored-By: Claude Fable 5.1 <noreply@anthropic.com>
Claude-Session: https://claude.ai/code/session_01TBc4UbXhoXqQPdBJRVJv8x
</commit_message>
<xml_diff>
--- a/thesis/defense/defense_deck.pptx
+++ b/thesis/defense/defense_deck.pptx
@@ -2638,7 +2638,7 @@
           <a:p>
             <a:r>
               <a:rPr lang="en-US" dirty="0"/>
-              <a:t>2 minutes. Walk the three rungs, then go to the paired tests, which are new since she last saw this. The honest headline is that the contextual path is not measurably better than a TF-IDF model on severity at this sample size. The confusion matrix shows how the floor fails: it calls 19 of the 27 critical signals low and gets only 4 of them right, a recall of 0.15. Two caveats to have ready. The severity numbers come from Trade Republic and Henkel only, because Lieferando ships no risk label, so food delivery is absent from every n = 106 figure. And the learned model is five-fold cross-validated while the contextual path was run once at temperature 0. If she asks whether 0.86 or the 0.97 on the in-repo set is the real number: different gold standards, curated sets select for label clarity, and the thesis quotes 0.86.</a:t>
+              <a:t>2 minutes. Walk the three rungs, then go to the paired tests, which are new since she last saw this. The honest headline is that the contextual path is not measurably better than a TF-IDF model on severity at this sample size. The confusion matrix shows how the floor fails: it calls 19 of the 27 critical signals low and gets only 4 of them right, a recall of 0.15. Two caveats to have ready. The severity numbers come from Trade Republic and Henkel only, because Lieferando ships no risk label, so food delivery is absent from every n = 106 figure. And the learned model is five-fold cross-validated while the contextual path was run once at temperature 0. If she asks whether 0.86 or the 0.97 on the in-repo set is the real number: different gold standards, curated sets select for label clarity, and the thesis quotes the star-proxy figures (0.86 for the prompt, 0.83 and 0.84 for the production stage). New since August: the production stage was run on the corpus on both models, the generic prompt four times, and the production default is close to deterministic at temperature 0.</a:t>
             </a:r>
             <a:endParaRPr lang="en-US" dirty="0"/>
           </a:p>
@@ -3741,11 +3741,12 @@
             <a:tbl>
               <a:tblPr/>
               <a:tblGrid>
-                <a:gridCol w="2377440"/>
-                <a:gridCol w="548640"/>
-                <a:gridCol w="1554480"/>
-                <a:gridCol w="1554480"/>
-                <a:gridCol w="1005840"/>
+                <a:gridCol w="2011680"/>
+                <a:gridCol w="457200"/>
+                <a:gridCol w="1280160"/>
+                <a:gridCol w="1280160"/>
+                <a:gridCol w="1097280"/>
+                <a:gridCol w="914400"/>
               </a:tblGrid>
               <a:tr h="457200">
                 <a:tc>
@@ -4038,6 +4039,74 @@
                           <a:cs typeface="Calibri" pitchFamily="34" charset="-120"/>
                         </a:rPr>
                         <a:t>Contextual path</a:t>
+                      </a:r>
+                      <a:endParaRPr lang="en-US" sz="1400" dirty="0">
+                        <a:latin typeface="Calibri" charset="0"/>
+                        <a:ea typeface="Calibri" charset="0"/>
+                        <a:cs typeface="Calibri" charset="0"/>
+                      </a:endParaRPr>
+                    </a:p>
+                  </a:txBody>
+                  <a:tcPr marL="91440" marR="91440" marT="45720" marB="45720" anchor="ctr">
+                    <a:lnL w="12700" cap="flat" cmpd="sng" algn="ctr">
+                      <a:solidFill>
+                        <a:srgbClr val="CADCFC"/>
+                      </a:solidFill>
+                      <a:prstDash val="solid"/>
+                      <a:round/>
+                      <a:headEnd type="none" w="med" len="med"/>
+                      <a:tailEnd type="none" w="med" len="med"/>
+                    </a:lnL>
+                    <a:lnR w="12700" cap="flat" cmpd="sng" algn="ctr">
+                      <a:solidFill>
+                        <a:srgbClr val="CADCFC"/>
+                      </a:solidFill>
+                      <a:prstDash val="solid"/>
+                      <a:round/>
+                      <a:headEnd type="none" w="med" len="med"/>
+                      <a:tailEnd type="none" w="med" len="med"/>
+                    </a:lnR>
+                    <a:lnT w="12700" cap="flat" cmpd="sng" algn="ctr">
+                      <a:solidFill>
+                        <a:srgbClr val="CADCFC"/>
+                      </a:solidFill>
+                      <a:prstDash val="solid"/>
+                      <a:round/>
+                      <a:headEnd type="none" w="med" len="med"/>
+                      <a:tailEnd type="none" w="med" len="med"/>
+                    </a:lnT>
+                    <a:lnB w="12700" cap="flat" cmpd="sng" algn="ctr">
+                      <a:solidFill>
+                        <a:srgbClr val="CADCFC"/>
+                      </a:solidFill>
+                      <a:prstDash val="solid"/>
+                      <a:round/>
+                      <a:headEnd type="none" w="med" len="med"/>
+                      <a:tailEnd type="none" w="med" len="med"/>
+                    </a:lnB>
+                    <a:solidFill>
+                      <a:srgbClr val="1E2761"/>
+                    </a:solidFill>
+                  </a:tcPr>
+                </a:tc>
+                <a:tc>
+                  <a:txBody>
+                    <a:bodyPr/>
+                    <a:lstStyle/>
+                    <a:p>
+                      <a:pPr indent="0" marL="0">
+                        <a:buNone/>
+                      </a:pPr>
+                      <a:r>
+                        <a:rPr lang="en-US" sz="1400" b="1" dirty="0">
+                          <a:solidFill>
+                            <a:srgbClr val="FFFFFF"/>
+                          </a:solidFill>
+                          <a:latin typeface="Calibri" pitchFamily="34" charset="0"/>
+                          <a:ea typeface="Calibri" pitchFamily="34" charset="-122"/>
+                          <a:cs typeface="Calibri" pitchFamily="34" charset="-120"/>
+                        </a:rPr>
+                        <a:t>Production stage</a:t>
                       </a:r>
                       <a:endParaRPr lang="en-US" sz="1400" dirty="0">
                         <a:latin typeface="Calibri" charset="0"/>
@@ -4415,6 +4484,71 @@
                     </a:lnB>
                   </a:tcPr>
                 </a:tc>
+                <a:tc>
+                  <a:txBody>
+                    <a:bodyPr/>
+                    <a:lstStyle/>
+                    <a:p>
+                      <a:pPr indent="0" marL="0">
+                        <a:buNone/>
+                      </a:pPr>
+                      <a:r>
+                        <a:rPr lang="en-US" sz="1400" dirty="0">
+                          <a:solidFill>
+                            <a:srgbClr val="000000"/>
+                          </a:solidFill>
+                          <a:latin typeface="Calibri" pitchFamily="34" charset="0"/>
+                          <a:ea typeface="Calibri" pitchFamily="34" charset="-122"/>
+                          <a:cs typeface="Calibri" pitchFamily="34" charset="-120"/>
+                        </a:rPr>
+                        <a:t>62.5%</a:t>
+                      </a:r>
+                      <a:endParaRPr lang="en-US" sz="1400" dirty="0">
+                        <a:latin typeface="Calibri" charset="0"/>
+                        <a:ea typeface="Calibri" charset="0"/>
+                        <a:cs typeface="Calibri" charset="0"/>
+                      </a:endParaRPr>
+                    </a:p>
+                  </a:txBody>
+                  <a:tcPr marL="91440" marR="91440" marT="45720" marB="45720" anchor="ctr">
+                    <a:lnL w="12700" cap="flat" cmpd="sng" algn="ctr">
+                      <a:solidFill>
+                        <a:srgbClr val="CADCFC"/>
+                      </a:solidFill>
+                      <a:prstDash val="solid"/>
+                      <a:round/>
+                      <a:headEnd type="none" w="med" len="med"/>
+                      <a:tailEnd type="none" w="med" len="med"/>
+                    </a:lnL>
+                    <a:lnR w="12700" cap="flat" cmpd="sng" algn="ctr">
+                      <a:solidFill>
+                        <a:srgbClr val="CADCFC"/>
+                      </a:solidFill>
+                      <a:prstDash val="solid"/>
+                      <a:round/>
+                      <a:headEnd type="none" w="med" len="med"/>
+                      <a:tailEnd type="none" w="med" len="med"/>
+                    </a:lnR>
+                    <a:lnT w="12700" cap="flat" cmpd="sng" algn="ctr">
+                      <a:solidFill>
+                        <a:srgbClr val="CADCFC"/>
+                      </a:solidFill>
+                      <a:prstDash val="solid"/>
+                      <a:round/>
+                      <a:headEnd type="none" w="med" len="med"/>
+                      <a:tailEnd type="none" w="med" len="med"/>
+                    </a:lnT>
+                    <a:lnB w="12700" cap="flat" cmpd="sng" algn="ctr">
+                      <a:solidFill>
+                        <a:srgbClr val="CADCFC"/>
+                      </a:solidFill>
+                      <a:prstDash val="solid"/>
+                      <a:round/>
+                      <a:headEnd type="none" w="med" len="med"/>
+                      <a:tailEnd type="none" w="med" len="med"/>
+                    </a:lnB>
+                  </a:tcPr>
+                </a:tc>
               </a:tr>
               <a:tr h="457200">
                 <a:tc>
@@ -4742,6 +4876,71 @@
                     </a:lnB>
                   </a:tcPr>
                 </a:tc>
+                <a:tc>
+                  <a:txBody>
+                    <a:bodyPr/>
+                    <a:lstStyle/>
+                    <a:p>
+                      <a:pPr indent="0" marL="0">
+                        <a:buNone/>
+                      </a:pPr>
+                      <a:r>
+                        <a:rPr lang="en-US" sz="1400" dirty="0">
+                          <a:solidFill>
+                            <a:srgbClr val="000000"/>
+                          </a:solidFill>
+                          <a:latin typeface="Calibri" pitchFamily="34" charset="0"/>
+                          <a:ea typeface="Calibri" pitchFamily="34" charset="-122"/>
+                          <a:cs typeface="Calibri" pitchFamily="34" charset="-120"/>
+                        </a:rPr>
+                        <a:t>53.7%</a:t>
+                      </a:r>
+                      <a:endParaRPr lang="en-US" sz="1400" dirty="0">
+                        <a:latin typeface="Calibri" charset="0"/>
+                        <a:ea typeface="Calibri" charset="0"/>
+                        <a:cs typeface="Calibri" charset="0"/>
+                      </a:endParaRPr>
+                    </a:p>
+                  </a:txBody>
+                  <a:tcPr marL="91440" marR="91440" marT="45720" marB="45720" anchor="ctr">
+                    <a:lnL w="12700" cap="flat" cmpd="sng" algn="ctr">
+                      <a:solidFill>
+                        <a:srgbClr val="CADCFC"/>
+                      </a:solidFill>
+                      <a:prstDash val="solid"/>
+                      <a:round/>
+                      <a:headEnd type="none" w="med" len="med"/>
+                      <a:tailEnd type="none" w="med" len="med"/>
+                    </a:lnL>
+                    <a:lnR w="12700" cap="flat" cmpd="sng" algn="ctr">
+                      <a:solidFill>
+                        <a:srgbClr val="CADCFC"/>
+                      </a:solidFill>
+                      <a:prstDash val="solid"/>
+                      <a:round/>
+                      <a:headEnd type="none" w="med" len="med"/>
+                      <a:tailEnd type="none" w="med" len="med"/>
+                    </a:lnR>
+                    <a:lnT w="12700" cap="flat" cmpd="sng" algn="ctr">
+                      <a:solidFill>
+                        <a:srgbClr val="CADCFC"/>
+                      </a:solidFill>
+                      <a:prstDash val="solid"/>
+                      <a:round/>
+                      <a:headEnd type="none" w="med" len="med"/>
+                      <a:tailEnd type="none" w="med" len="med"/>
+                    </a:lnT>
+                    <a:lnB w="12700" cap="flat" cmpd="sng" algn="ctr">
+                      <a:solidFill>
+                        <a:srgbClr val="CADCFC"/>
+                      </a:solidFill>
+                      <a:prstDash val="solid"/>
+                      <a:round/>
+                      <a:headEnd type="none" w="med" len="med"/>
+                      <a:tailEnd type="none" w="med" len="med"/>
+                    </a:lnB>
+                  </a:tcPr>
+                </a:tc>
               </a:tr>
             </a:tbl>
           </a:graphicData>
@@ -4780,7 +4979,7 @@
                 <a:ea typeface="Calibri" pitchFamily="34" charset="-122"/>
                 <a:cs typeface="Calibri" pitchFamily="34" charset="-120"/>
               </a:rPr>
-              <a:t>On the same eight critical German-source signals: the floor escalates none of them, the learned model five, the contextual path seven. The learned model does not separate from the contextual path on aggregate severity accuracy (p = 0.644) and very distinguishable in whom it escalates: 32.6 points between the strata.</a:t>
+              <a:t>On the same eight critical German-source signals: the floor escalates none, the learned model five, the contextual path seven (six in each repeat, 78 to 81% on the English side). The learned model ties the contextual path on severity accuracy and differs in whom it escalates: 32.6 points between strata. The production stage escalates fewer in both, with no detectable gap.</a:t>
             </a:r>
             <a:endParaRPr lang="en-US" sz="1400" dirty="0"/>
           </a:p>
@@ -9587,7 +9786,7 @@
                           <a:ea typeface="Calibri" pitchFamily="34" charset="-122"/>
                           <a:cs typeface="Calibri" pitchFamily="34" charset="-120"/>
                         </a:rPr>
-                        <a:t>floor 0.0, learned 62.5, contextual 87.5 against 87.8; stratum n = 8</a:t>
+                        <a:t>floor 0.0, learned 62.5, contextual 87.5 vs 87.8, production 62.5 vs 53.7; n = 8</a:t>
                       </a:r>
                       <a:endParaRPr lang="en-US" sz="1400" dirty="0">
                         <a:latin typeface="Calibri" charset="0"/>
@@ -9981,7 +10180,7 @@
                           <a:ea typeface="Calibri" pitchFamily="34" charset="-122"/>
                           <a:cs typeface="Calibri" pitchFamily="34" charset="-120"/>
                         </a:rPr>
-                        <a:t>remedy adoption 21% to 71%; the outcomes behind it are simulated</a:t>
+                        <a:t>remedy adoption 21% to 71%; replicated on GLM-5.2, not on the production default; simulated outcomes</a:t>
                       </a:r>
                       <a:endParaRPr lang="en-US" sz="1400" dirty="0">
                         <a:latin typeface="Calibri" charset="0"/>
@@ -17753,7 +17952,7 @@
                 <a:ea typeface="Calibri" pitchFamily="34" charset="-122"/>
                 <a:cs typeface="Calibri" pitchFamily="34" charset="-120"/>
               </a:rPr>
-              <a:t>How accurately does AI enrichment and routing reproduce reference labels (star ratings, assistant-drafted seeds) on real feedback, across sectors? Answered: three predictors on one gold standard.</a:t>
+              <a:t>How accurately does AI enrichment and routing reproduce reference labels on real feedback, across sectors? Answered: three predictors on one gold standard.</a:t>
             </a:r>
             <a:endParaRPr lang="en-US" sz="1300" dirty="0"/>
           </a:p>
@@ -21483,7 +21682,7 @@
                           <a:ea typeface="Calibri" pitchFamily="34" charset="-122"/>
                           <a:cs typeface="Calibri" pitchFamily="34" charset="-120"/>
                         </a:rPr>
-                        <a:t>Contextual model path</a:t>
+                        <a:t>Contextual model path (generic prompt)</a:t>
                       </a:r>
                       <a:endParaRPr lang="en-US" sz="1400" dirty="0">
                         <a:latin typeface="Calibri" charset="0"/>
@@ -21662,6 +21861,400 @@
                   </a:tcPr>
                 </a:tc>
               </a:tr>
+              <a:tr h="457200">
+                <a:tc>
+                  <a:txBody>
+                    <a:bodyPr/>
+                    <a:lstStyle/>
+                    <a:p>
+                      <a:pPr indent="0" marL="0">
+                        <a:buNone/>
+                      </a:pPr>
+                      <a:r>
+                        <a:rPr lang="en-US" sz="1400" dirty="0">
+                          <a:solidFill>
+                            <a:srgbClr val="000000"/>
+                          </a:solidFill>
+                          <a:latin typeface="Calibri" pitchFamily="34" charset="0"/>
+                          <a:ea typeface="Calibri" pitchFamily="34" charset="-122"/>
+                          <a:cs typeface="Calibri" pitchFamily="34" charset="-120"/>
+                        </a:rPr>
+                        <a:t>Production enrichment stage, same model</a:t>
+                      </a:r>
+                      <a:endParaRPr lang="en-US" sz="1400" dirty="0">
+                        <a:latin typeface="Calibri" charset="0"/>
+                        <a:ea typeface="Calibri" charset="0"/>
+                        <a:cs typeface="Calibri" charset="0"/>
+                      </a:endParaRPr>
+                    </a:p>
+                  </a:txBody>
+                  <a:tcPr marL="91440" marR="91440" marT="45720" marB="45720" anchor="ctr">
+                    <a:lnL w="12700" cap="flat" cmpd="sng" algn="ctr">
+                      <a:solidFill>
+                        <a:srgbClr val="CADCFC"/>
+                      </a:solidFill>
+                      <a:prstDash val="solid"/>
+                      <a:round/>
+                      <a:headEnd type="none" w="med" len="med"/>
+                      <a:tailEnd type="none" w="med" len="med"/>
+                    </a:lnL>
+                    <a:lnR w="12700" cap="flat" cmpd="sng" algn="ctr">
+                      <a:solidFill>
+                        <a:srgbClr val="CADCFC"/>
+                      </a:solidFill>
+                      <a:prstDash val="solid"/>
+                      <a:round/>
+                      <a:headEnd type="none" w="med" len="med"/>
+                      <a:tailEnd type="none" w="med" len="med"/>
+                    </a:lnR>
+                    <a:lnT w="12700" cap="flat" cmpd="sng" algn="ctr">
+                      <a:solidFill>
+                        <a:srgbClr val="CADCFC"/>
+                      </a:solidFill>
+                      <a:prstDash val="solid"/>
+                      <a:round/>
+                      <a:headEnd type="none" w="med" len="med"/>
+                      <a:tailEnd type="none" w="med" len="med"/>
+                    </a:lnT>
+                    <a:lnB w="12700" cap="flat" cmpd="sng" algn="ctr">
+                      <a:solidFill>
+                        <a:srgbClr val="CADCFC"/>
+                      </a:solidFill>
+                      <a:prstDash val="solid"/>
+                      <a:round/>
+                      <a:headEnd type="none" w="med" len="med"/>
+                      <a:tailEnd type="none" w="med" len="med"/>
+                    </a:lnB>
+                  </a:tcPr>
+                </a:tc>
+                <a:tc>
+                  <a:txBody>
+                    <a:bodyPr/>
+                    <a:lstStyle/>
+                    <a:p>
+                      <a:pPr indent="0" marL="0">
+                        <a:buNone/>
+                      </a:pPr>
+                      <a:r>
+                        <a:rPr lang="en-US" sz="1400" dirty="0">
+                          <a:solidFill>
+                            <a:srgbClr val="000000"/>
+                          </a:solidFill>
+                          <a:latin typeface="Calibri" pitchFamily="34" charset="0"/>
+                          <a:ea typeface="Calibri" pitchFamily="34" charset="-122"/>
+                          <a:cs typeface="Calibri" pitchFamily="34" charset="-120"/>
+                        </a:rPr>
+                        <a:t>0.83</a:t>
+                      </a:r>
+                      <a:endParaRPr lang="en-US" sz="1400" dirty="0">
+                        <a:latin typeface="Calibri" charset="0"/>
+                        <a:ea typeface="Calibri" charset="0"/>
+                        <a:cs typeface="Calibri" charset="0"/>
+                      </a:endParaRPr>
+                    </a:p>
+                  </a:txBody>
+                  <a:tcPr marL="91440" marR="91440" marT="45720" marB="45720" anchor="ctr">
+                    <a:lnL w="12700" cap="flat" cmpd="sng" algn="ctr">
+                      <a:solidFill>
+                        <a:srgbClr val="CADCFC"/>
+                      </a:solidFill>
+                      <a:prstDash val="solid"/>
+                      <a:round/>
+                      <a:headEnd type="none" w="med" len="med"/>
+                      <a:tailEnd type="none" w="med" len="med"/>
+                    </a:lnL>
+                    <a:lnR w="12700" cap="flat" cmpd="sng" algn="ctr">
+                      <a:solidFill>
+                        <a:srgbClr val="CADCFC"/>
+                      </a:solidFill>
+                      <a:prstDash val="solid"/>
+                      <a:round/>
+                      <a:headEnd type="none" w="med" len="med"/>
+                      <a:tailEnd type="none" w="med" len="med"/>
+                    </a:lnR>
+                    <a:lnT w="12700" cap="flat" cmpd="sng" algn="ctr">
+                      <a:solidFill>
+                        <a:srgbClr val="CADCFC"/>
+                      </a:solidFill>
+                      <a:prstDash val="solid"/>
+                      <a:round/>
+                      <a:headEnd type="none" w="med" len="med"/>
+                      <a:tailEnd type="none" w="med" len="med"/>
+                    </a:lnT>
+                    <a:lnB w="12700" cap="flat" cmpd="sng" algn="ctr">
+                      <a:solidFill>
+                        <a:srgbClr val="CADCFC"/>
+                      </a:solidFill>
+                      <a:prstDash val="solid"/>
+                      <a:round/>
+                      <a:headEnd type="none" w="med" len="med"/>
+                      <a:tailEnd type="none" w="med" len="med"/>
+                    </a:lnB>
+                  </a:tcPr>
+                </a:tc>
+                <a:tc>
+                  <a:txBody>
+                    <a:bodyPr/>
+                    <a:lstStyle/>
+                    <a:p>
+                      <a:pPr indent="0" marL="0">
+                        <a:buNone/>
+                      </a:pPr>
+                      <a:r>
+                        <a:rPr lang="en-US" sz="1400" dirty="0">
+                          <a:solidFill>
+                            <a:srgbClr val="000000"/>
+                          </a:solidFill>
+                          <a:latin typeface="Calibri" pitchFamily="34" charset="0"/>
+                          <a:ea typeface="Calibri" pitchFamily="34" charset="-122"/>
+                          <a:cs typeface="Calibri" pitchFamily="34" charset="-120"/>
+                        </a:rPr>
+                        <a:t>0.41</a:t>
+                      </a:r>
+                      <a:endParaRPr lang="en-US" sz="1400" dirty="0">
+                        <a:latin typeface="Calibri" charset="0"/>
+                        <a:ea typeface="Calibri" charset="0"/>
+                        <a:cs typeface="Calibri" charset="0"/>
+                      </a:endParaRPr>
+                    </a:p>
+                  </a:txBody>
+                  <a:tcPr marL="91440" marR="91440" marT="45720" marB="45720" anchor="ctr">
+                    <a:lnL w="12700" cap="flat" cmpd="sng" algn="ctr">
+                      <a:solidFill>
+                        <a:srgbClr val="CADCFC"/>
+                      </a:solidFill>
+                      <a:prstDash val="solid"/>
+                      <a:round/>
+                      <a:headEnd type="none" w="med" len="med"/>
+                      <a:tailEnd type="none" w="med" len="med"/>
+                    </a:lnL>
+                    <a:lnR w="12700" cap="flat" cmpd="sng" algn="ctr">
+                      <a:solidFill>
+                        <a:srgbClr val="CADCFC"/>
+                      </a:solidFill>
+                      <a:prstDash val="solid"/>
+                      <a:round/>
+                      <a:headEnd type="none" w="med" len="med"/>
+                      <a:tailEnd type="none" w="med" len="med"/>
+                    </a:lnR>
+                    <a:lnT w="12700" cap="flat" cmpd="sng" algn="ctr">
+                      <a:solidFill>
+                        <a:srgbClr val="CADCFC"/>
+                      </a:solidFill>
+                      <a:prstDash val="solid"/>
+                      <a:round/>
+                      <a:headEnd type="none" w="med" len="med"/>
+                      <a:tailEnd type="none" w="med" len="med"/>
+                    </a:lnT>
+                    <a:lnB w="12700" cap="flat" cmpd="sng" algn="ctr">
+                      <a:solidFill>
+                        <a:srgbClr val="CADCFC"/>
+                      </a:solidFill>
+                      <a:prstDash val="solid"/>
+                      <a:round/>
+                      <a:headEnd type="none" w="med" len="med"/>
+                      <a:tailEnd type="none" w="med" len="med"/>
+                    </a:lnB>
+                  </a:tcPr>
+                </a:tc>
+              </a:tr>
+              <a:tr h="457200">
+                <a:tc>
+                  <a:txBody>
+                    <a:bodyPr/>
+                    <a:lstStyle/>
+                    <a:p>
+                      <a:pPr indent="0" marL="0">
+                        <a:buNone/>
+                      </a:pPr>
+                      <a:r>
+                        <a:rPr lang="en-US" sz="1400" dirty="0">
+                          <a:solidFill>
+                            <a:srgbClr val="000000"/>
+                          </a:solidFill>
+                          <a:latin typeface="Calibri" pitchFamily="34" charset="0"/>
+                          <a:ea typeface="Calibri" pitchFamily="34" charset="-122"/>
+                          <a:cs typeface="Calibri" pitchFamily="34" charset="-120"/>
+                        </a:rPr>
+                        <a:t>Production enrichment stage, production default</a:t>
+                      </a:r>
+                      <a:endParaRPr lang="en-US" sz="1400" dirty="0">
+                        <a:latin typeface="Calibri" charset="0"/>
+                        <a:ea typeface="Calibri" charset="0"/>
+                        <a:cs typeface="Calibri" charset="0"/>
+                      </a:endParaRPr>
+                    </a:p>
+                  </a:txBody>
+                  <a:tcPr marL="91440" marR="91440" marT="45720" marB="45720" anchor="ctr">
+                    <a:lnL w="12700" cap="flat" cmpd="sng" algn="ctr">
+                      <a:solidFill>
+                        <a:srgbClr val="CADCFC"/>
+                      </a:solidFill>
+                      <a:prstDash val="solid"/>
+                      <a:round/>
+                      <a:headEnd type="none" w="med" len="med"/>
+                      <a:tailEnd type="none" w="med" len="med"/>
+                    </a:lnL>
+                    <a:lnR w="12700" cap="flat" cmpd="sng" algn="ctr">
+                      <a:solidFill>
+                        <a:srgbClr val="CADCFC"/>
+                      </a:solidFill>
+                      <a:prstDash val="solid"/>
+                      <a:round/>
+                      <a:headEnd type="none" w="med" len="med"/>
+                      <a:tailEnd type="none" w="med" len="med"/>
+                    </a:lnR>
+                    <a:lnT w="12700" cap="flat" cmpd="sng" algn="ctr">
+                      <a:solidFill>
+                        <a:srgbClr val="CADCFC"/>
+                      </a:solidFill>
+                      <a:prstDash val="solid"/>
+                      <a:round/>
+                      <a:headEnd type="none" w="med" len="med"/>
+                      <a:tailEnd type="none" w="med" len="med"/>
+                    </a:lnT>
+                    <a:lnB w="12700" cap="flat" cmpd="sng" algn="ctr">
+                      <a:solidFill>
+                        <a:srgbClr val="CADCFC"/>
+                      </a:solidFill>
+                      <a:prstDash val="solid"/>
+                      <a:round/>
+                      <a:headEnd type="none" w="med" len="med"/>
+                      <a:tailEnd type="none" w="med" len="med"/>
+                    </a:lnB>
+                  </a:tcPr>
+                </a:tc>
+                <a:tc>
+                  <a:txBody>
+                    <a:bodyPr/>
+                    <a:lstStyle/>
+                    <a:p>
+                      <a:pPr indent="0" marL="0">
+                        <a:buNone/>
+                      </a:pPr>
+                      <a:r>
+                        <a:rPr lang="en-US" sz="1400" dirty="0">
+                          <a:solidFill>
+                            <a:srgbClr val="000000"/>
+                          </a:solidFill>
+                          <a:latin typeface="Calibri" pitchFamily="34" charset="0"/>
+                          <a:ea typeface="Calibri" pitchFamily="34" charset="-122"/>
+                          <a:cs typeface="Calibri" pitchFamily="34" charset="-120"/>
+                        </a:rPr>
+                        <a:t>0.84</a:t>
+                      </a:r>
+                      <a:endParaRPr lang="en-US" sz="1400" dirty="0">
+                        <a:latin typeface="Calibri" charset="0"/>
+                        <a:ea typeface="Calibri" charset="0"/>
+                        <a:cs typeface="Calibri" charset="0"/>
+                      </a:endParaRPr>
+                    </a:p>
+                  </a:txBody>
+                  <a:tcPr marL="91440" marR="91440" marT="45720" marB="45720" anchor="ctr">
+                    <a:lnL w="12700" cap="flat" cmpd="sng" algn="ctr">
+                      <a:solidFill>
+                        <a:srgbClr val="CADCFC"/>
+                      </a:solidFill>
+                      <a:prstDash val="solid"/>
+                      <a:round/>
+                      <a:headEnd type="none" w="med" len="med"/>
+                      <a:tailEnd type="none" w="med" len="med"/>
+                    </a:lnL>
+                    <a:lnR w="12700" cap="flat" cmpd="sng" algn="ctr">
+                      <a:solidFill>
+                        <a:srgbClr val="CADCFC"/>
+                      </a:solidFill>
+                      <a:prstDash val="solid"/>
+                      <a:round/>
+                      <a:headEnd type="none" w="med" len="med"/>
+                      <a:tailEnd type="none" w="med" len="med"/>
+                    </a:lnR>
+                    <a:lnT w="12700" cap="flat" cmpd="sng" algn="ctr">
+                      <a:solidFill>
+                        <a:srgbClr val="CADCFC"/>
+                      </a:solidFill>
+                      <a:prstDash val="solid"/>
+                      <a:round/>
+                      <a:headEnd type="none" w="med" len="med"/>
+                      <a:tailEnd type="none" w="med" len="med"/>
+                    </a:lnT>
+                    <a:lnB w="12700" cap="flat" cmpd="sng" algn="ctr">
+                      <a:solidFill>
+                        <a:srgbClr val="CADCFC"/>
+                      </a:solidFill>
+                      <a:prstDash val="solid"/>
+                      <a:round/>
+                      <a:headEnd type="none" w="med" len="med"/>
+                      <a:tailEnd type="none" w="med" len="med"/>
+                    </a:lnB>
+                  </a:tcPr>
+                </a:tc>
+                <a:tc>
+                  <a:txBody>
+                    <a:bodyPr/>
+                    <a:lstStyle/>
+                    <a:p>
+                      <a:pPr indent="0" marL="0">
+                        <a:buNone/>
+                      </a:pPr>
+                      <a:r>
+                        <a:rPr lang="en-US" sz="1400" dirty="0">
+                          <a:solidFill>
+                            <a:srgbClr val="000000"/>
+                          </a:solidFill>
+                          <a:latin typeface="Calibri" pitchFamily="34" charset="0"/>
+                          <a:ea typeface="Calibri" pitchFamily="34" charset="-122"/>
+                          <a:cs typeface="Calibri" pitchFamily="34" charset="-120"/>
+                        </a:rPr>
+                        <a:t>0.53</a:t>
+                      </a:r>
+                      <a:endParaRPr lang="en-US" sz="1400" dirty="0">
+                        <a:latin typeface="Calibri" charset="0"/>
+                        <a:ea typeface="Calibri" charset="0"/>
+                        <a:cs typeface="Calibri" charset="0"/>
+                      </a:endParaRPr>
+                    </a:p>
+                  </a:txBody>
+                  <a:tcPr marL="91440" marR="91440" marT="45720" marB="45720" anchor="ctr">
+                    <a:lnL w="12700" cap="flat" cmpd="sng" algn="ctr">
+                      <a:solidFill>
+                        <a:srgbClr val="CADCFC"/>
+                      </a:solidFill>
+                      <a:prstDash val="solid"/>
+                      <a:round/>
+                      <a:headEnd type="none" w="med" len="med"/>
+                      <a:tailEnd type="none" w="med" len="med"/>
+                    </a:lnL>
+                    <a:lnR w="12700" cap="flat" cmpd="sng" algn="ctr">
+                      <a:solidFill>
+                        <a:srgbClr val="CADCFC"/>
+                      </a:solidFill>
+                      <a:prstDash val="solid"/>
+                      <a:round/>
+                      <a:headEnd type="none" w="med" len="med"/>
+                      <a:tailEnd type="none" w="med" len="med"/>
+                    </a:lnR>
+                    <a:lnT w="12700" cap="flat" cmpd="sng" algn="ctr">
+                      <a:solidFill>
+                        <a:srgbClr val="CADCFC"/>
+                      </a:solidFill>
+                      <a:prstDash val="solid"/>
+                      <a:round/>
+                      <a:headEnd type="none" w="med" len="med"/>
+                      <a:tailEnd type="none" w="med" len="med"/>
+                    </a:lnT>
+                    <a:lnB w="12700" cap="flat" cmpd="sng" algn="ctr">
+                      <a:solidFill>
+                        <a:srgbClr val="CADCFC"/>
+                      </a:solidFill>
+                      <a:prstDash val="solid"/>
+                      <a:round/>
+                      <a:headEnd type="none" w="med" len="med"/>
+                      <a:tailEnd type="none" w="med" len="med"/>
+                    </a:lnB>
+                  </a:tcPr>
+                </a:tc>
+              </a:tr>
             </a:tbl>
           </a:graphicData>
         </a:graphic>
@@ -21757,7 +22350,7 @@
               <a:buNone/>
             </a:pPr>
             <a:r>
-              <a:rPr lang="en-US" sz="1350" dirty="0">
+              <a:rPr lang="en-US" sz="1150" dirty="0">
                 <a:solidFill>
                   <a:srgbClr val="1A1A2E"/>
                 </a:solidFill>
@@ -21765,9 +22358,9 @@
                 <a:ea typeface="Calibri" pitchFamily="34" charset="-122"/>
                 <a:cs typeface="Calibri" pitchFamily="34" charset="-120"/>
               </a:rPr>
-              <a:t>Both learned methods beat the floor on both tasks (p &lt; 0.0001). The contextual path beats the learned model on sentiment (p = 0.029) and does not separate from it on severity accuracy, 0.68 against 0.72 (p = 0.644).</a:t>
-            </a:r>
-            <a:endParaRPr lang="en-US" sz="1350" dirty="0"/>
+              <a:t>Both learned methods beat the floor (p &lt; 0.0001). The contextual path beats the learned model on sentiment in all four runs (p = 0.019 to 0.029) and ties it on severity; the production stage matches it on sentiment and sits one severity level below the seeds.</a:t>
+            </a:r>
+            <a:endParaRPr lang="en-US" sz="1150" dirty="0"/>
           </a:p>
         </p:txBody>
       </p:sp>
@@ -21804,7 +22397,7 @@
                 <a:ea typeface="Calibri" pitchFamily="34" charset="-122"/>
                 <a:cs typeface="Calibri" pitchFamily="34" charset="-120"/>
               </a:rPr>
-              <a:t>Contextual reasoning buys a great deal on sentiment and nothing I can demonstrate on severity, because severity is carried by lexical markers that character n-grams already learn. So the loop's precondition can be met by more than one method, and a deployer weighing cost, latency and model sovereignty has a choice to make rather than an instruction to follow.</a:t>
+              <a:t>Contextual reasoning buys a great deal on sentiment and nothing demonstrable on severity, which lexical markers already carry. The production stage's severity shift is partly the seed labels' own calibration: a blind second rater put seven of ten seed-critical items at high (kappa 0.55, weighted 0.70). The precondition can be met by more than one method; a deployer has a choice, not an instruction.</a:t>
             </a:r>
             <a:endParaRPr lang="en-US" sz="1400" dirty="0"/>
           </a:p>
@@ -21925,7 +22518,7 @@
               <a:buNone/>
             </a:pPr>
             <a:r>
-              <a:rPr lang="en-US" sz="1200" dirty="0">
+              <a:rPr lang="en-US" sz="1100" dirty="0">
                 <a:solidFill>
                   <a:srgbClr val="1A1A2E"/>
                 </a:solidFill>
@@ -21933,9 +22526,9 @@
                 <a:ea typeface="Calibri" pitchFamily="34" charset="-122"/>
                 <a:cs typeface="Calibri" pitchFamily="34" charset="-120"/>
               </a:rPr>
-              <a:t>188 real public signals, paraphrased and de-identified, with seed labels authored independently of the artifact. Sentiment is scored against the 1 to 5 star rating, which is independent of the text the classifier reads.</a:t>
-            </a:r>
-            <a:endParaRPr lang="en-US" sz="1200" dirty="0"/>
+              <a:t>188 real public signals, paraphrased and de-identified; seed labels drafted by a language-model assistant, used as delivered. Sentiment is scored against the star rating, the one human-origin reference.</a:t>
+            </a:r>
+            <a:endParaRPr lang="en-US" sz="1100" dirty="0"/>
           </a:p>
         </p:txBody>
       </p:sp>

</xml_diff>

<commit_message>
thesis: regenerate the defence deck from the corrected make_deck.js
The tracked .pptx still carried the 'no kappa / no second annotator' and
'missing kappa' slides after make_deck.js was corrected; rebuilt with
pptxgenjs so the binary matches the source (check_fit.js could not run here:
its dependency is not installed).

Co-Authored-By: Claude Fable 5.1 <noreply@anthropic.com>
Claude-Session: https://claude.ai/code/session_01VzwetuxqeGNDhgRcTiXwn9
</commit_message>
<xml_diff>
--- a/thesis/defense/defense_deck.pptx
+++ b/thesis/defense/defense_deck.pptx
@@ -614,7 +614,7 @@
           <a:p>
             <a:r>
               <a:rPr lang="en-US" dirty="0"/>
-              <a:t>2 minutes, and for a Responsible AI thesis this is the most important results slide. Read the zero out loud and then pause. Then make the new point: the middle column was added on 20 August and it sharpens the finding, because a respectable learned model shows the same gap, so this is not an artefact of a weak baseline. Volunteer the bounds before she asks. Be precise if she pushes: the supported claim is the paired one on the same eight signals, not a cross-stratum claim that German is handled worse than English, which this corpus cannot establish. If she asks whether it generalises, the answer is no, the thesis says so, and the claim is about method choice on this corpus. One more honest caveat if she presses on the zero: across the three new datasets the same floor escalates German-source signals at 0.36 and 0.40, so the zero here is the low end of what a keyword floor does, not a fixed property of it.</a:t>
+              <a:t>2 minutes, and for a Responsible AI thesis this is the most important results slide. Read the zero out loud and then pause. Then make the new point: the middle column was added on 20 August and it shows that a respectable learned model has an observed gap of its own, so this is not only about a weak baseline. Say plainly, before she does, that the learned model's significant within-predictor test beside the contextual path's non-significant one does not rank the two predictors (Gelman and Stern, 2006): the eight-item stratum cannot carry a ranking, and the thesis reports the gaps descriptively and recommends per-stratum monitoring rather than a predictor. Volunteer the bounds before she asks. Be precise if she pushes: the supported claim is the paired one on the same eight signals, not a cross-stratum claim that German is handled worse than English, which this corpus cannot establish. If she asks whether it generalises, the answer is no, the thesis says so, and the claim is about method choice on this corpus. One more honest caveat if she presses on the zero: across the three new datasets the same floor escalates German-source signals at 0.36 and 0.40, so the zero here is the low end of what a keyword floor does, not a fixed property of it.</a:t>
             </a:r>
             <a:endParaRPr lang="en-US" dirty="0"/>
           </a:p>
@@ -1054,7 +1054,7 @@
           <a:p>
             <a:r>
               <a:rPr lang="en-US" dirty="0"/>
-              <a:t>90 seconds. Use this to pre-empt the founder question: externally authored labels, standard instruments, a reproducible harness, a declared conflict of interest, and this table. Since 20 August participants are told before consent that the interviewer built the prototype and has a commercial interest, there is a fourth consent checkbox, and there is a standing rule of no sales content in sessions and no commercial follow-up for six months. Be honest that the manuscript's method chapter does not yet cite that policy. The two pending rows are what the asks are about.</a:t>
+              <a:t>90 seconds. Use this to pre-empt the founder question: externally authored labels, standard instruments, a reproducible harness, a declared conflict of interest, and this table. Since 20 August participants are told before consent that the interviewer built the prototype and has a commercial interest, there is a fourth consent checkbox, and there is a standing rule of no sales content in sessions and no commercial follow-up for six months. Be honest that the manuscript's method chapter does not yet cite that policy. The pending RQ4 row and the once-measured agreement row are what the asks are about.</a:t>
             </a:r>
             <a:endParaRPr lang="en-US" dirty="0"/>
           </a:p>
@@ -2550,7 +2550,7 @@
           <a:p>
             <a:r>
               <a:rPr lang="en-US" dirty="0"/>
-              <a:t>2 minutes, and this is the slide I would spend extra time on if she engages. The embedding story is the portable architecture lesson: cosine thresholds are not comparable across embedding models, so a provider swap that looks like a config change silently rewrites the behaviour of every semantic feature. Be honest about the residual, which is that the calibrated values live in the deployment environment and the in-code defaults are still the old ones. If she asks what is still open from the review: there is still no inter-annotator agreement number behind either gold standard, and that is the most attackable gap in the thesis.</a:t>
+              <a:t>2 minutes, and this is the slide I would spend extra time on if she engages. The embedding story is the portable architecture lesson: cosine thresholds are not comparable across embedding models, so a provider swap that looks like a config change silently rewrites the behaviour of every semantic feature. Be honest about the residual, which is that the calibrated values live in the deployment environment and the in-code defaults are still the old ones. If she asks what is still open from the review: the one agreement number is the 40-item blind second risk rating (kappa 0.55 unweighted, 0.70 weighted), attested as a second person's, with its provenance recorded in PROVENANCE_kappa.md and the rater's exposure to AI suggestions unrecorded; there is none behind the in-repo golden set, and that remains the most attackable gap.</a:t>
             </a:r>
             <a:endParaRPr lang="en-US" dirty="0"/>
           </a:p>
@@ -4979,7 +4979,7 @@
                 <a:ea typeface="Calibri" pitchFamily="34" charset="-122"/>
                 <a:cs typeface="Calibri" pitchFamily="34" charset="-120"/>
               </a:rPr>
-              <a:t>On the same eight critical German-source signals: the floor escalates none, the learned model five, the contextual path seven (six in each repeat, 78 to 81% on the English side). The learned model ties the contextual path on severity accuracy and differs in whom it escalates: 32.6 points between strata. The production stage escalates fewer in both, with no detectable gap.</a:t>
+              <a:t>On the same eight German-source signals whose reference label warrants escalation: the floor escalates none, the learned model five, the contextual path seven (six in each repeat, 78 to 81% on the English side). The learned model ties the contextual path on severity accuracy; its stratum recalls differ by 32.6 points and the contextual path's by 0.3, descriptive figures on eight items. A significant test for one predictor beside a non-significant one for another does not compare the two gaps. The production stage escalates fewer in both strata.</a:t>
             </a:r>
             <a:endParaRPr lang="en-US" sz="1400" dirty="0"/>
           </a:p>
@@ -5076,7 +5076,7 @@
               <a:buNone/>
             </a:pPr>
             <a:r>
-              <a:rPr lang="en-US" sz="1150" dirty="0">
+              <a:rPr lang="en-US" sz="1100" dirty="0">
                 <a:solidFill>
                   <a:srgbClr val="1A1A2E"/>
                 </a:solidFill>
@@ -5086,20 +5086,20 @@
               </a:rPr>
               <a:t>The German-source escalate stratum is eight signals. A 95% interval on 7 of 8 runs from roughly 47% to 100%, and on 5 of 8 from roughly 25% to 92%.</a:t>
             </a:r>
-            <a:endParaRPr lang="en-US" sz="1150" dirty="0"/>
+            <a:endParaRPr lang="en-US" sz="1100" dirty="0"/>
           </a:p>
           <a:p>
             <a:pPr indent="0" marL="0">
               <a:buNone/>
             </a:pPr>
-            <a:endParaRPr lang="en-US" sz="1150" dirty="0"/>
+            <a:endParaRPr lang="en-US" sz="1100" dirty="0"/>
           </a:p>
           <a:p>
             <a:pPr indent="0" marL="0">
               <a:buNone/>
             </a:pPr>
             <a:r>
-              <a:rPr lang="en-US" sz="1150" dirty="0">
+              <a:rPr lang="en-US" sz="1100" dirty="0">
                 <a:solidFill>
                   <a:srgbClr val="1A1A2E"/>
                 </a:solidFill>
@@ -5109,20 +5109,20 @@
               </a:rPr>
               <a:t>Language is confounded with sector on this corpus.</a:t>
             </a:r>
-            <a:endParaRPr lang="en-US" sz="1150" dirty="0"/>
+            <a:endParaRPr lang="en-US" sz="1100" dirty="0"/>
           </a:p>
           <a:p>
             <a:pPr indent="0" marL="0">
               <a:buNone/>
             </a:pPr>
-            <a:endParaRPr lang="en-US" sz="1150" dirty="0"/>
+            <a:endParaRPr lang="en-US" sz="1100" dirty="0"/>
           </a:p>
           <a:p>
             <a:pPr indent="0" marL="0">
               <a:buNone/>
             </a:pPr>
             <a:r>
-              <a:rPr lang="en-US" sz="1150" dirty="0">
+              <a:rPr lang="en-US" sz="1100" dirty="0">
                 <a:solidFill>
                   <a:srgbClr val="1A1A2E"/>
                 </a:solidFill>
@@ -5132,20 +5132,20 @@
               </a:rPr>
               <a:t>The texts are English paraphrases throughout, so the mechanism cannot be German-language processing. What differs is what German-language customers wrote about, and how they phrased it.</a:t>
             </a:r>
-            <a:endParaRPr lang="en-US" sz="1150" dirty="0"/>
+            <a:endParaRPr lang="en-US" sz="1100" dirty="0"/>
           </a:p>
           <a:p>
             <a:pPr indent="0" marL="0">
               <a:buNone/>
             </a:pPr>
-            <a:endParaRPr lang="en-US" sz="1150" dirty="0"/>
+            <a:endParaRPr lang="en-US" sz="1100" dirty="0"/>
           </a:p>
           <a:p>
             <a:pPr indent="0" marL="0">
               <a:buNone/>
             </a:pPr>
             <a:r>
-              <a:rPr lang="en-US" sz="1150" dirty="0">
+              <a:rPr lang="en-US" sz="1100" dirty="0">
                 <a:solidFill>
                   <a:srgbClr val="1A1A2E"/>
                 </a:solidFill>
@@ -5155,7 +5155,30 @@
               </a:rPr>
               <a:t>The aggregate cross-language accuracy comparison was retracted for the same reason.</a:t>
             </a:r>
-            <a:endParaRPr lang="en-US" sz="1150" dirty="0"/>
+            <a:endParaRPr lang="en-US" sz="1100" dirty="0"/>
+          </a:p>
+          <a:p>
+            <a:pPr indent="0" marL="0">
+              <a:buNone/>
+            </a:pPr>
+            <a:endParaRPr lang="en-US" sz="1100" dirty="0"/>
+          </a:p>
+          <a:p>
+            <a:pPr indent="0" marL="0">
+              <a:buNone/>
+            </a:pPr>
+            <a:r>
+              <a:rPr lang="en-US" sz="1100" dirty="0">
+                <a:solidFill>
+                  <a:srgbClr val="1A1A2E"/>
+                </a:solidFill>
+                <a:latin typeface="Calibri" pitchFamily="34" charset="0"/>
+                <a:ea typeface="Calibri" pitchFamily="34" charset="-122"/>
+                <a:cs typeface="Calibri" pitchFamily="34" charset="-120"/>
+              </a:rPr>
+              <a:t>The Fisher tests are within-predictor. No test on the difference between predictors' gaps has been run (Gelman and Stern, 2006).</a:t>
+            </a:r>
+            <a:endParaRPr lang="en-US" sz="1100" dirty="0"/>
           </a:p>
         </p:txBody>
       </p:sp>
@@ -7235,7 +7258,7 @@
                 <a:ea typeface="Calibri" pitchFamily="34" charset="-122"/>
                 <a:cs typeface="Calibri" pitchFamily="34" charset="-120"/>
               </a:rPr>
-              <a:t>Vodafone is the only new set with two source strata large enough to compare. There the learned model escalates German-source signals at 50% against English-source at 81.8%. Same direction, and nearly the same size as the 32.6 point gap on the thesis corpus.</a:t>
+              <a:t>Vodafone is the only new set with two source strata large enough to compare. There the learned model escalates German-source signals at 50% against English-source at 81.8%. Same direction as the learned model's observed 32.6 point gap on the thesis corpus, on draft labels, and descriptive in both cases.</a:t>
             </a:r>
             <a:endParaRPr lang="en-US" sz="1300" dirty="0"/>
           </a:p>
@@ -10706,7 +10729,7 @@
                           <a:ea typeface="Calibri" pitchFamily="34" charset="-122"/>
                           <a:cs typeface="Calibri" pitchFamily="34" charset="-120"/>
                         </a:rPr>
-                        <a:t>Pending</a:t>
+                        <a:t>Measured once, on attestation</a:t>
                       </a:r>
                       <a:endParaRPr lang="en-US" sz="1400" dirty="0">
                         <a:latin typeface="Calibri" charset="0"/>
@@ -10771,7 +10794,7 @@
                           <a:ea typeface="Calibri" pitchFamily="34" charset="-122"/>
                           <a:cs typeface="Calibri" pitchFamily="34" charset="-120"/>
                         </a:rPr>
-                        <a:t>export and scoring tooling shipped; no second annotator, no kappa</a:t>
+                        <a:t>40-item blind risk rating: kappa 0.55 unweighted, 0.70 weighted; a second person on the owner's attestation, AI exposure unrecorded; none on the golden set</a:t>
                       </a:r>
                       <a:endParaRPr lang="en-US" sz="1400" dirty="0">
                         <a:latin typeface="Calibri" charset="0"/>
@@ -11559,7 +11582,7 @@
                 <a:ea typeface="Calibri" pitchFamily="34" charset="-122"/>
                 <a:cs typeface="Calibri" pitchFamily="34" charset="-120"/>
               </a:rPr>
-              <a:t>No inter-annotator agreement number exists behind either gold standard.</a:t>
+              <a:t>One agreement number exists: kappa 0.55 on a 40-item blind risk rating, a second person's on the owner's attestation, with the rater's exposure to AI suggestions unrecorded. None exists behind the golden set.</a:t>
             </a:r>
             <a:endParaRPr lang="en-US" sz="1250" dirty="0"/>
           </a:p>
@@ -11746,7 +11769,7 @@
                 <a:ea typeface="Calibri" pitchFamily="34" charset="-122"/>
                 <a:cs typeface="Calibri" pitchFamily="34" charset="-120"/>
               </a:rPr>
-              <a:t>A second annotator on a stratified sample of the gold set, which produces the missing kappa.</a:t>
+              <a:t>A second independent human rating on a new sample of the risk seeds, and a first one on the golden set, with rater and date recorded: the existing kappa rests on attestation, and repeats on the same forty items would not be replication.</a:t>
             </a:r>
             <a:endParaRPr lang="en-US" sz="1250" dirty="0"/>
           </a:p>
@@ -12266,7 +12289,7 @@
                 <a:ea typeface="Calibri" pitchFamily="34" charset="-122"/>
                 <a:cs typeface="Calibri" pitchFamily="34" charset="-120"/>
               </a:rPr>
-              <a:t>Of what is left, interviews, one live outcome measurement, a second annotator for the missing kappa, semantic scoring of two gold fields and free-form routing, which do you consider required and which is honest future work?</a:t>
+              <a:t>Of what is left, interviews, one live outcome measurement, a second independent human rating on a new sample (the existing kappa rests on attestation), semantic scoring of two gold fields and free-form routing, which do you consider required and which is honest future work?</a:t>
             </a:r>
             <a:endParaRPr lang="en-US" sz="1200" dirty="0"/>
           </a:p>
@@ -12476,7 +12499,7 @@
                 <a:ea typeface="Calibri" pitchFamily="34" charset="-122"/>
                 <a:cs typeface="Calibri" pitchFamily="34" charset="-120"/>
               </a:rPr>
-              <a:t>The learned model now carries a 32.6 point gap of its own, which answers the strawman objection, and the German-source stratum is still eight signals. Is that enough as written, or do I need natural German-language data first? That decides whether relabelling the new corpora is required work.</a:t>
+              <a:t>The learned model now shows an observed 32.6 point gap of its own on eight German-source signals, reported descriptively because within-predictor tests do not rank predictors, and the stratum is still eight signals. Is that enough as written, or do I need natural German-language data first? That decides whether relabelling the new corpora is required work.</a:t>
             </a:r>
             <a:endParaRPr lang="en-US" sz="1200" dirty="0"/>
           </a:p>
@@ -13889,7 +13912,7 @@
                 <a:ea typeface="Calibri" pitchFamily="34" charset="-122"/>
                 <a:cs typeface="Calibri" pitchFamily="34" charset="-120"/>
               </a:rPr>
-              <a:t>Triage accuracy depends on the method, and the method decides whose problems reach a human. Only the contextual path escalates German-source and English-source signals at close to the same rate.</a:t>
+              <a:t>Triage accuracy depends on the method, and the method can change whose problems reach a human. On eight German-source signals whose label warrants escalation the floor escalates none, the learned model five and the contextual path seven: descriptive on that stratum, reported without ranking the predictors.</a:t>
             </a:r>
             <a:endParaRPr lang="en-US" sz="1200" dirty="0"/>
           </a:p>
@@ -19916,7 +19939,7 @@
                 <a:ea typeface="Calibri" pitchFamily="34" charset="-122"/>
                 <a:cs typeface="Calibri" pitchFamily="34" charset="-120"/>
               </a:rPr>
-              <a:t>The learned model joined the escalation equity table and carries a 32.6 point gap of its own, so that finding is no longer about a weak baseline.</a:t>
+              <a:t>The learned model joined the escalation equity table: 62.5% against 95.1% across the two strata, an observed 32.6 point gap on eight German-source items, reported as descriptive and without ranking the predictors.</a:t>
             </a:r>
             <a:endParaRPr lang="en-US" sz="1350" dirty="0"/>
           </a:p>
@@ -22358,7 +22381,7 @@
                 <a:ea typeface="Calibri" pitchFamily="34" charset="-122"/>
                 <a:cs typeface="Calibri" pitchFamily="34" charset="-120"/>
               </a:rPr>
-              <a:t>Both learned methods beat the floor (p &lt; 0.0001). The contextual path beats the learned model on sentiment in all four runs (p = 0.019 to 0.029) and ties it on severity; the production stage matches it on sentiment and sits one severity level below the seeds.</a:t>
+              <a:t>Both learned methods beat the floor (p &lt; 0.0001). The contextual path beats the learned model on sentiment in all four runs (p = 0.019 to 0.029) and ties it on severity; the production stage lands within three points of it on sentiment (8 discordant pairs to 3, p = 0.23) and one severity level below the seeds. The two production rows differ in model, batch size and run date together, so they compare deployment configurations, not the model alone.</a:t>
             </a:r>
             <a:endParaRPr lang="en-US" sz="1150" dirty="0"/>
           </a:p>

</xml_diff>

<commit_message>
thesis deck: fit the review-edited text boxes and rebuild the binary
check_fit.js (run with pptxgenjs) flagged 14 overflowing boxes after the
review edits against 7 in the pre-review source; the eight boxes the edits
introduced or worsened (slides 2, 7, 9, 10, 12, 15, 16, 17) are shortened
without changing any claim, two of them at a smaller font. The five
remaining overflows (slides 2, 6, 8, 24) predate the review.

Co-Authored-By: Claude Fable 5.1 <noreply@anthropic.com>
Claude-Session: https://claude.ai/code/session_01VzwetuxqeGNDhgRcTiXwn9
</commit_message>
<xml_diff>
--- a/thesis/defense/defense_deck.pptx
+++ b/thesis/defense/defense_deck.pptx
@@ -4971,7 +4971,7 @@
               <a:buNone/>
             </a:pPr>
             <a:r>
-              <a:rPr lang="en-US" sz="1400" dirty="0">
+              <a:rPr lang="en-US" sz="1300" dirty="0">
                 <a:solidFill>
                   <a:srgbClr val="1A1A2E"/>
                 </a:solidFill>
@@ -4979,9 +4979,9 @@
                 <a:ea typeface="Calibri" pitchFamily="34" charset="-122"/>
                 <a:cs typeface="Calibri" pitchFamily="34" charset="-120"/>
               </a:rPr>
-              <a:t>On the same eight German-source signals whose reference label warrants escalation: the floor escalates none, the learned model five, the contextual path seven (six in each repeat, 78 to 81% on the English side). The learned model ties the contextual path on severity accuracy; its stratum recalls differ by 32.6 points and the contextual path's by 0.3, descriptive figures on eight items. A significant test for one predictor beside a non-significant one for another does not compare the two gaps. The production stage escalates fewer in both strata.</a:t>
-            </a:r>
-            <a:endParaRPr lang="en-US" sz="1400" dirty="0"/>
+              <a:t>On the eight German-source signals whose reference label warrants escalation: the floor escalates none, the learned model five, the contextual path seven. The learned model ties the contextual path on severity accuracy; its stratum recalls differ by 32.6 points, the contextual path's by 0.3, descriptive figures on eight items. One significant test beside a non-significant one does not compare the two gaps.</a:t>
+            </a:r>
+            <a:endParaRPr lang="en-US" sz="1300" dirty="0"/>
           </a:p>
         </p:txBody>
       </p:sp>
@@ -5084,7 +5084,7 @@
                 <a:ea typeface="Calibri" pitchFamily="34" charset="-122"/>
                 <a:cs typeface="Calibri" pitchFamily="34" charset="-120"/>
               </a:rPr>
-              <a:t>The German-source escalate stratum is eight signals. A 95% interval on 7 of 8 runs from roughly 47% to 100%, and on 5 of 8 from roughly 25% to 92%.</a:t>
+              <a:t>The German-source escalate stratum is eight signals. A 95% interval on 7 of 8 runs from roughly 47% to 100%, on 5 of 8 from 25% to 92%.</a:t>
             </a:r>
             <a:endParaRPr lang="en-US" sz="1100" dirty="0"/>
           </a:p>
@@ -5092,6 +5092,17 @@
             <a:pPr indent="0" marL="0">
               <a:buNone/>
             </a:pPr>
+            <a:r>
+              <a:rPr lang="en-US" sz="1100" dirty="0">
+                <a:solidFill>
+                  <a:srgbClr val="1A1A2E"/>
+                </a:solidFill>
+                <a:latin typeface="Calibri" pitchFamily="34" charset="0"/>
+                <a:ea typeface="Calibri" pitchFamily="34" charset="-122"/>
+                <a:cs typeface="Calibri" pitchFamily="34" charset="-120"/>
+              </a:rPr>
+              <a:t>Language is confounded with sector on this corpus.</a:t>
+            </a:r>
             <a:endParaRPr lang="en-US" sz="1100" dirty="0"/>
           </a:p>
           <a:p>
@@ -5107,7 +5118,7 @@
                 <a:ea typeface="Calibri" pitchFamily="34" charset="-122"/>
                 <a:cs typeface="Calibri" pitchFamily="34" charset="-120"/>
               </a:rPr>
-              <a:t>Language is confounded with sector on this corpus.</a:t>
+              <a:t>The texts are English paraphrases, so the mechanism cannot be German-language processing; what differs is what German-language customers wrote about, and how.</a:t>
             </a:r>
             <a:endParaRPr lang="en-US" sz="1100" dirty="0"/>
           </a:p>
@@ -5115,6 +5126,17 @@
             <a:pPr indent="0" marL="0">
               <a:buNone/>
             </a:pPr>
+            <a:r>
+              <a:rPr lang="en-US" sz="1100" dirty="0">
+                <a:solidFill>
+                  <a:srgbClr val="1A1A2E"/>
+                </a:solidFill>
+                <a:latin typeface="Calibri" pitchFamily="34" charset="0"/>
+                <a:ea typeface="Calibri" pitchFamily="34" charset="-122"/>
+                <a:cs typeface="Calibri" pitchFamily="34" charset="-120"/>
+              </a:rPr>
+              <a:t>The aggregate cross-language accuracy comparison was retracted for the same reason.</a:t>
+            </a:r>
             <a:endParaRPr lang="en-US" sz="1100" dirty="0"/>
           </a:p>
           <a:p>
@@ -5130,53 +5152,7 @@
                 <a:ea typeface="Calibri" pitchFamily="34" charset="-122"/>
                 <a:cs typeface="Calibri" pitchFamily="34" charset="-120"/>
               </a:rPr>
-              <a:t>The texts are English paraphrases throughout, so the mechanism cannot be German-language processing. What differs is what German-language customers wrote about, and how they phrased it.</a:t>
-            </a:r>
-            <a:endParaRPr lang="en-US" sz="1100" dirty="0"/>
-          </a:p>
-          <a:p>
-            <a:pPr indent="0" marL="0">
-              <a:buNone/>
-            </a:pPr>
-            <a:endParaRPr lang="en-US" sz="1100" dirty="0"/>
-          </a:p>
-          <a:p>
-            <a:pPr indent="0" marL="0">
-              <a:buNone/>
-            </a:pPr>
-            <a:r>
-              <a:rPr lang="en-US" sz="1100" dirty="0">
-                <a:solidFill>
-                  <a:srgbClr val="1A1A2E"/>
-                </a:solidFill>
-                <a:latin typeface="Calibri" pitchFamily="34" charset="0"/>
-                <a:ea typeface="Calibri" pitchFamily="34" charset="-122"/>
-                <a:cs typeface="Calibri" pitchFamily="34" charset="-120"/>
-              </a:rPr>
-              <a:t>The aggregate cross-language accuracy comparison was retracted for the same reason.</a:t>
-            </a:r>
-            <a:endParaRPr lang="en-US" sz="1100" dirty="0"/>
-          </a:p>
-          <a:p>
-            <a:pPr indent="0" marL="0">
-              <a:buNone/>
-            </a:pPr>
-            <a:endParaRPr lang="en-US" sz="1100" dirty="0"/>
-          </a:p>
-          <a:p>
-            <a:pPr indent="0" marL="0">
-              <a:buNone/>
-            </a:pPr>
-            <a:r>
-              <a:rPr lang="en-US" sz="1100" dirty="0">
-                <a:solidFill>
-                  <a:srgbClr val="1A1A2E"/>
-                </a:solidFill>
-                <a:latin typeface="Calibri" pitchFamily="34" charset="0"/>
-                <a:ea typeface="Calibri" pitchFamily="34" charset="-122"/>
-                <a:cs typeface="Calibri" pitchFamily="34" charset="-120"/>
-              </a:rPr>
-              <a:t>The Fisher tests are within-predictor. No test on the difference between predictors' gaps has been run (Gelman and Stern, 2006).</a:t>
+              <a:t>The Fisher tests are within-predictor; no test on the difference between predictors' gaps has been run (Gelman and Stern, 2006).</a:t>
             </a:r>
             <a:endParaRPr lang="en-US" sz="1100" dirty="0"/>
           </a:p>
@@ -7258,7 +7234,7 @@
                 <a:ea typeface="Calibri" pitchFamily="34" charset="-122"/>
                 <a:cs typeface="Calibri" pitchFamily="34" charset="-120"/>
               </a:rPr>
-              <a:t>Vodafone is the only new set with two source strata large enough to compare. There the learned model escalates German-source signals at 50% against English-source at 81.8%. Same direction as the learned model's observed 32.6 point gap on the thesis corpus, on draft labels, and descriptive in both cases.</a:t>
+              <a:t>Vodafone is the only new set with two source strata large enough to compare: the learned model escalates German-source signals at 50% against 81.8% English-source. Same direction as its observed 32.6-point gap on the thesis corpus; draft labels, descriptive in both cases.</a:t>
             </a:r>
             <a:endParaRPr lang="en-US" sz="1300" dirty="0"/>
           </a:p>
@@ -10794,7 +10770,7 @@
                           <a:ea typeface="Calibri" pitchFamily="34" charset="-122"/>
                           <a:cs typeface="Calibri" pitchFamily="34" charset="-120"/>
                         </a:rPr>
-                        <a:t>40-item blind risk rating: kappa 0.55 unweighted, 0.70 weighted; a second person on the owner's attestation, AI exposure unrecorded; none on the golden set</a:t>
+                        <a:t>kappa 0.55 (0.70 weighted), 40 blind risk items; second person (attested), AI exposure unrecorded; none on golden set</a:t>
                       </a:r>
                       <a:endParaRPr lang="en-US" sz="1400" dirty="0">
                         <a:latin typeface="Calibri" charset="0"/>
@@ -11519,7 +11495,7 @@
                 <a:ea typeface="Calibri" pitchFamily="34" charset="-122"/>
                 <a:cs typeface="Calibri" pitchFamily="34" charset="-120"/>
               </a:rPr>
-              <a:t>Language is confounded with sector, and the texts are English paraphrases throughout, so every per-language result is a source-language stratum. One cross-language claim was retracted rather than defended.</a:t>
+              <a:t>Language is confounded with sector and the texts are English paraphrases, so every per-language result is a source-language stratum; one cross-language claim was retracted rather than defended.</a:t>
             </a:r>
             <a:endParaRPr lang="en-US" sz="1250" dirty="0"/>
           </a:p>
@@ -11582,7 +11558,7 @@
                 <a:ea typeface="Calibri" pitchFamily="34" charset="-122"/>
                 <a:cs typeface="Calibri" pitchFamily="34" charset="-120"/>
               </a:rPr>
-              <a:t>One agreement number exists: kappa 0.55 on a 40-item blind risk rating, a second person's on the owner's attestation, with the rater's exposure to AI suggestions unrecorded. None exists behind the golden set.</a:t>
+              <a:t>One agreement number: kappa 0.55, 40 blind risk items, second person (attested; AI exposure unrecorded); none on golden set.</a:t>
             </a:r>
             <a:endParaRPr lang="en-US" sz="1250" dirty="0"/>
           </a:p>
@@ -11603,7 +11579,7 @@
                 <a:ea typeface="Calibri" pitchFamily="34" charset="-122"/>
                 <a:cs typeface="Calibri" pitchFamily="34" charset="-120"/>
               </a:rPr>
-              <a:t>The urgency exemplar effect was tested at n = 60, 80 and 100 without alpha spending, so the claim rests on three consecutive significant runs rather than on the first crossing.</a:t>
+              <a:t>Urgency exemplar effect tested at n = 60, 80, 100 without alpha spending; the claim rests on three consecutive significant runs, not the first crossing.</a:t>
             </a:r>
             <a:endParaRPr lang="en-US" sz="1250" dirty="0"/>
           </a:p>
@@ -12499,7 +12475,7 @@
                 <a:ea typeface="Calibri" pitchFamily="34" charset="-122"/>
                 <a:cs typeface="Calibri" pitchFamily="34" charset="-120"/>
               </a:rPr>
-              <a:t>The learned model now shows an observed 32.6 point gap of its own on eight German-source signals, reported descriptively because within-predictor tests do not rank predictors, and the stratum is still eight signals. Is that enough as written, or do I need natural German-language data first? That decides whether relabelling the new corpora is required work.</a:t>
+              <a:t>The learned model shows an observed 32.6-point gap of its own on eight German-source signals, reported descriptively because within-predictor tests do not rank predictors. Is that enough as written, or do I need natural German-language data first? That decides whether relabelling the new corpora is required work.</a:t>
             </a:r>
             <a:endParaRPr lang="en-US" sz="1200" dirty="0"/>
           </a:p>
@@ -13912,7 +13888,7 @@
                 <a:ea typeface="Calibri" pitchFamily="34" charset="-122"/>
                 <a:cs typeface="Calibri" pitchFamily="34" charset="-120"/>
               </a:rPr>
-              <a:t>Triage accuracy depends on the method, and the method can change whose problems reach a human. On eight German-source signals whose label warrants escalation the floor escalates none, the learned model five and the contextual path seven: descriptive on that stratum, reported without ranking the predictors.</a:t>
+              <a:t>Triage accuracy depends on the method, and the method can change whose problems reach a human. On eight German-source signals whose label warrants escalation: floor none, learned model five, contextual path seven (descriptive; no predictor ranking).</a:t>
             </a:r>
             <a:endParaRPr lang="en-US" sz="1200" dirty="0"/>
           </a:p>
@@ -19939,7 +19915,7 @@
                 <a:ea typeface="Calibri" pitchFamily="34" charset="-122"/>
                 <a:cs typeface="Calibri" pitchFamily="34" charset="-120"/>
               </a:rPr>
-              <a:t>The learned model joined the escalation equity table: 62.5% against 95.1% across the two strata, an observed 32.6 point gap on eight German-source items, reported as descriptive and without ranking the predictors.</a:t>
+              <a:t>The learned model joined the escalation equity table: 62.5% against 95.1% across the two strata, a 32.6-point gap on eight German-source items; descriptive, no ranking.</a:t>
             </a:r>
             <a:endParaRPr lang="en-US" sz="1350" dirty="0"/>
           </a:p>
@@ -22373,7 +22349,7 @@
               <a:buNone/>
             </a:pPr>
             <a:r>
-              <a:rPr lang="en-US" sz="1150" dirty="0">
+              <a:rPr lang="en-US" sz="1050" dirty="0">
                 <a:solidFill>
                   <a:srgbClr val="1A1A2E"/>
                 </a:solidFill>
@@ -22381,9 +22357,9 @@
                 <a:ea typeface="Calibri" pitchFamily="34" charset="-122"/>
                 <a:cs typeface="Calibri" pitchFamily="34" charset="-120"/>
               </a:rPr>
-              <a:t>Both learned methods beat the floor (p &lt; 0.0001). The contextual path beats the learned model on sentiment in all four runs (p = 0.019 to 0.029) and ties it on severity; the production stage lands within three points of it on sentiment (8 discordant pairs to 3, p = 0.23) and one severity level below the seeds. The two production rows differ in model, batch size and run date together, so they compare deployment configurations, not the model alone.</a:t>
-            </a:r>
-            <a:endParaRPr lang="en-US" sz="1150" dirty="0"/>
+              <a:t>Both learned methods beat the floor (p &lt; 0.0001). The contextual path beats the learned model on sentiment in all four runs (p = 0.019–0.029) and ties it on severity; the production stage is within three points on sentiment (p = 0.23) and one severity level below the seeds. The production rows compare configurations (model, batch size, run date), not the model alone.</a:t>
+            </a:r>
+            <a:endParaRPr lang="en-US" sz="1050" dirty="0"/>
           </a:p>
         </p:txBody>
       </p:sp>

</xml_diff>

<commit_message>
thesis: Appendix G trimmed to 2,990 words; deck, board and README brought in line with the revised manuscript; retrospective read named as observational
Appendix G keeps the observed-versus-attested record of G.1 verbatim, the
run trajectory as one table, one line per correction and per dated cycle,
and the deployment dating of 15 September. The deck and board state RQ4 as
not conducted, the ten-comparison Holm family, the gate's limits and the
dated deployment claims; the deck is regenerated with four pre-existing
overflows. README rows describe the revised Chapter 5, Appendix G and the
tooling. retrospective_its.py no longer calls its read a natural experiment.

Co-Authored-By: Claude Fable 5.1 <noreply@anthropic.com>
Claude-Session: https://claude.ai/code/session_01VzwetuxqeGNDhgRcTiXwn9
</commit_message>
<xml_diff>
--- a/thesis/defense/defense_deck.pptx
+++ b/thesis/defense/defense_deck.pptx
@@ -790,7 +790,7 @@
           <a:p>
             <a:r>
               <a:rPr lang="en-US" dirty="0"/>
-              <a:t>90 seconds. Present this as exploratory replication and not as corpus growth, and say the corpus is still 188 in the same breath. The interesting half is the negative one: the severity advantage of a learned model over a keyword floor does not reproduce on any of the three new sets, which is a caution about how much weight the severity numbers can carry. The Vodafone escalation gap is the encouraging half, because it is an independent set in a different sector pointing the same way. Ask five on the last slide is about whether relabelling these to gold standard is required work before submission.</a:t>
+              <a:t>90 seconds. Present this as a descriptive check on held-out sets and not as corpus growth, and say the corpus is still 188 in the same breath. The interesting half is the negative one: the severity advantage of a learned model over a keyword floor does not reproduce on any of the three new sets, which is a caution about how much weight the severity numbers can carry. The Vodafone escalation gap is the encouraging half, because it is an independent set in a different sector pointing the same way. Ask five on the last slide is about whether relabelling these to gold standard is required work before submission.</a:t>
             </a:r>
             <a:endParaRPr lang="en-US" dirty="0"/>
           </a:p>
@@ -966,7 +966,7 @@
           <a:p>
             <a:r>
               <a:rPr lang="en-US" dirty="0"/>
-              <a:t>90 seconds. Lead with the number and land on the boundary. The distinction between a mechanism that is measured and a benefit that is not is the one an examiner rewards, and it is written into the traceability matrix on the next slide rather than only said out loud here. Ask four is exactly this trade-off.</a:t>
+              <a:t>90 seconds. Lead with the number and land on the boundary. The distinction between a retrieval effect probed on one model and a benefit that is not established is the one an examiner rewards, and it is written into the traceability matrix on the next slide rather than only said out loud here. Ask four is exactly this trade-off.</a:t>
             </a:r>
             <a:endParaRPr lang="en-US" dirty="0"/>
           </a:p>
@@ -1054,7 +1054,7 @@
           <a:p>
             <a:r>
               <a:rPr lang="en-US" dirty="0"/>
-              <a:t>90 seconds. Use this to pre-empt the founder question: externally authored labels, standard instruments, a reproducible harness, a declared conflict of interest, and this table. Since 20 August participants are told before consent that the interviewer built the prototype and has a commercial interest, there is a fourth consent checkbox, and there is a standing rule of no sales content in sessions and no commercial follow-up for six months. Be honest that the manuscript's method chapter does not yet cite that policy. The pending RQ4 row and the once-measured agreement row are what the asks are about.</a:t>
+              <a:t>90 seconds. Use this to pre-empt the founder question: reference labels of stated provenance, standard instruments, a reproducible harness, a declared conflict of interest, and this table. The consent form tells participants before consent that the interviewer built the prototype and has a commercial interest, there is a fourth consent checkbox, and there is a standing rule of no sales content in sessions and no commercial follow-up for six months. The not-conducted RQ4 row and the provenance-unverified agreement row are what the asks are about.</a:t>
             </a:r>
             <a:endParaRPr lang="en-US" dirty="0"/>
           </a:p>
@@ -1142,7 +1142,7 @@
           <a:p>
             <a:r>
               <a:rPr lang="en-US" dirty="0"/>
-              <a:t>90 seconds. Say the first item slowly, because it is the single most important next artifact. One real action, one real metric, one contract, one window, one verdict. Everything else on the right is bounded work with a known method. Stop here and move to the asks.</a:t>
+              <a:t>90 seconds. Say the first item slowly, because until the practitioner sessions run RQ4 is unanswered. The fourth item is the single most important next artifact for the outcome claim: one real action, one real metric, one contract, one window, one verdict. Everything else on the right is bounded work with a known method. Stop here and move to the asks.</a:t>
             </a:r>
             <a:endParaRPr lang="en-US" dirty="0"/>
           </a:p>
@@ -1582,7 +1582,7 @@
           <a:p>
             <a:r>
               <a:rPr lang="en-US" dirty="0"/>
-              <a:t>60 seconds if summoned. The honesty features are the point: real data only, seed labels written before and outside the artifact, a non-circular sentiment reference, and a reproducible harness. Two gold standards exist, they disagree, and the thesis quotes the lower one.</a:t>
+              <a:t>60 seconds if summoned. The design features are the point: real data only, seed labels of stated provenance produced without reference to the artifact, a non-circular sentiment reference, and a reproducible harness. Two gold standards exist, they disagree, and the thesis quotes the lower one.</a:t>
             </a:r>
             <a:endParaRPr lang="en-US" dirty="0"/>
           </a:p>
@@ -2022,7 +2022,7 @@
           <a:p>
             <a:r>
               <a:rPr lang="en-US" dirty="0"/>
-              <a:t>90 seconds if summoned, and only for commercial questions. The category moved toward the thesis. Each rival owns a fragment and nobody verifiably holds the combination, and I apply the same verification standard to my own artifact, which is why the traceability slide says the outcome half is demonstrated rather than proven.</a:t>
+              <a:t>90 seconds if summoned, and only for commercial questions. The category moved toward the thesis. Each rival owns a fragment and, within the literature and product documentation reviewed, no evaluated system was identified that holds the combination; I apply the same documentation standard to my own artifact, which is why the traceability slide says the outcome half is implemented and tested on simulated data rather than field-measured.</a:t>
             </a:r>
             <a:endParaRPr lang="en-US" dirty="0"/>
           </a:p>
@@ -2110,7 +2110,7 @@
           <a:p>
             <a:r>
               <a:rPr lang="en-US" dirty="0"/>
-              <a:t>60 seconds. Why design science in one line: the question is what works by design, not what is. Then the change I need her view on. RQ3 became RQ3a and RQ3b after the August run, because the equity answer turned out to be the more important one and it was sitting inside RQ3 as a sub-clause. For a Responsible AI thesis that felt wrong. Say plainly that RQ4 has not started and that ask one and ask two are about unblocking it.</a:t>
+              <a:t>60 seconds. Why design science in one line: the question is what works by design, not what is. Then the change I need her view on. RQ3 became RQ3a and RQ3b after the August run, because the equity answer turned out to be the more important one and it was sitting inside RQ3 as a sub-clause. For a Responsible AI thesis that felt wrong. Say plainly that RQ4 was not conducted, that the thesis reports it as such with the tiers fixed in advance, and that ask one and ask two are about unblocking it.</a:t>
             </a:r>
             <a:endParaRPr lang="en-US" dirty="0"/>
           </a:p>
@@ -2374,7 +2374,7 @@
           <a:p>
             <a:r>
               <a:rPr lang="en-US" dirty="0"/>
-              <a:t>2 minutes. This is the heart of the Responsible AI argument. Two lines matter most. The gate goes past Article 14 on purpose, because the legal literature says awareness measures alone do not de-bias overseers. And the audit instrumentation is what found the platform's own unenforced controls in July, which is governance working rather than governance claimed. Finish on the three levels of closure, because the results slides measure the first two and not yet the third.</a:t>
+              <a:t>2 minutes. This is the heart of the Responsible AI argument. Two lines matter most. The gate goes past Article 14 on purpose, because the legal literature says awareness measures alone do not de-bias overseers, and it carries its limit: it controls false positives and cannot recover what the enrichment ranks too low. And the audit instrumentation is what found the platform's own unenforced controls in July, which is governance working rather than governance claimed. Finish on the three meanings of closure: the estimator has run on simulated outcome data only, so target attainment and attributed improvement are demonstrated, not field-measured.</a:t>
             </a:r>
             <a:endParaRPr lang="en-US" dirty="0"/>
           </a:p>
@@ -2550,7 +2550,7 @@
           <a:p>
             <a:r>
               <a:rPr lang="en-US" dirty="0"/>
-              <a:t>2 minutes, and this is the slide I would spend extra time on if she engages. The embedding story is the portable architecture lesson: cosine thresholds are not comparable across embedding models, so a provider swap that looks like a config change silently rewrites the behaviour of every semantic feature. Be honest about the residual, which is that the calibrated values live in the deployment environment and the in-code defaults are still the old ones. If she asks what is still open from the review: the one agreement number is the 40-item second risk rating (kappa 0.55 unweighted, 0.70 weighted); its independent human provenance is unverified (the owner attests a second person, the files identify no rater, and the 13 September review reports an AI-assistant task record with identical labels), so it is second-rating agreement and not a human check; there is none behind the in-repo golden set, and that remains the most attackable gap.</a:t>
+              <a:t>2 minutes, and this is the slide I would spend extra time on if she engages. The embedding story is the portable architecture lesson: cosine thresholds are not comparable across embedding models, so a provider swap that looks like a config change silently rewrites the behaviour of every semantic feature. Be honest about the residual, which is that the calibrated values live in the deployment environment and the in-code defaults are still the old ones. If she asks what is still open from the review: the one agreement number is the 40-item second risk rating (kappa 0.55 unweighted, 0.70 weighted); its independent human provenance is unverified (Appendix G.1 keeps what is observed and what is attested apart), so it is second-rating agreement with independent human provenance unverified and is never used as human validation; there is none behind the in-repo golden set, and that remains the most attackable gap.</a:t>
             </a:r>
             <a:endParaRPr lang="en-US" dirty="0"/>
           </a:p>
@@ -2638,7 +2638,7 @@
           <a:p>
             <a:r>
               <a:rPr lang="en-US" dirty="0"/>
-              <a:t>2 minutes. Walk the three rungs, then go to the paired tests, which are new since she last saw this. The honest headline is that the contextual path is not measurably better than a TF-IDF model on severity at this sample size. The confusion matrix shows how the floor fails: it calls 19 of the 27 critical signals low and gets only 4 of them right, a recall of 0.15. Two caveats to have ready. The severity numbers come from Trade Republic and Henkel only, because Lieferando ships no risk label, so food delivery is absent from every n = 106 figure. And the learned model is five-fold cross-validated while the contextual path was run once at temperature 0. If she asks whether 0.86 or the 0.97 on the in-repo set is the real number: different gold standards, curated sets select for label clarity, and the thesis quotes the star-proxy figures (0.86 for the prompt, 0.83 and 0.84 for the production stage). New since August: the production stage was run on the corpus on both models, the generic prompt four times, and the production default is close to deterministic at temperature 0.</a:t>
+              <a:t>2 minutes. Walk the five rows, then go to the paired tests, which are new since she last saw this. The headline is that after the retrospective Holm correction only the floor comparisons survive on sentiment, and on risk the generic prompt and TF-IDF are not distinguishable on this corpus. The confusion matrix shows how the floor fails: it calls 19 of the 27 critical signals low. Two caveats to have ready. The risk numbers come from Trade Republic and Henkel only, because Lieferando ships no risk label, so food delivery is absent from every n = 106 figure. And the learned model is five-fold cross-validated while the generic prompt rests on a reported run plus three repeats at temperature 0, and the production stage on GLM-5.2 was run once. If she asks whether 0.86 or the 99% on the in-repo set is the real number: different gold standards, the golden set is a development and validation benchmark co-developed with the artifact, and the thesis quotes the star-proxy figures (0.86 for the prompt, 0.83 and 0.84 for the production stage). New since August: the production stage was run on the corpus on both models, the generic prompt four times, and the production default assigns identical sentiment labels on 99.3–100% of items across four runs at temperature 0.</a:t>
             </a:r>
             <a:endParaRPr lang="en-US" dirty="0"/>
           </a:p>
@@ -3970,7 +3970,7 @@
                           <a:ea typeface="Calibri" pitchFamily="34" charset="-122"/>
                           <a:cs typeface="Calibri" pitchFamily="34" charset="-120"/>
                         </a:rPr>
-                        <a:t>TF-IDF and LR</a:t>
+                        <a:t>TF-IDF + LR</a:t>
                       </a:r>
                       <a:endParaRPr lang="en-US" sz="1400" dirty="0">
                         <a:latin typeface="Calibri" charset="0"/>
@@ -4038,7 +4038,7 @@
                           <a:ea typeface="Calibri" pitchFamily="34" charset="-122"/>
                           <a:cs typeface="Calibri" pitchFamily="34" charset="-120"/>
                         </a:rPr>
-                        <a:t>Contextual path</a:t>
+                        <a:t>Generic prompt</a:t>
                       </a:r>
                       <a:endParaRPr lang="en-US" sz="1400" dirty="0">
                         <a:latin typeface="Calibri" charset="0"/>
@@ -4306,7 +4306,7 @@
                           <a:ea typeface="Calibri" pitchFamily="34" charset="-122"/>
                           <a:cs typeface="Calibri" pitchFamily="34" charset="-120"/>
                         </a:rPr>
-                        <a:t>0.0%</a:t>
+                        <a:t>0 of 8</a:t>
                       </a:r>
                       <a:endParaRPr lang="en-US" sz="1400" dirty="0">
                         <a:latin typeface="Calibri" charset="0"/>
@@ -4371,7 +4371,7 @@
                           <a:ea typeface="Calibri" pitchFamily="34" charset="-122"/>
                           <a:cs typeface="Calibri" pitchFamily="34" charset="-120"/>
                         </a:rPr>
-                        <a:t>62.5%</a:t>
+                        <a:t>5 of 8</a:t>
                       </a:r>
                       <a:endParaRPr lang="en-US" sz="1400" dirty="0">
                         <a:latin typeface="Calibri" charset="0"/>
@@ -4436,7 +4436,7 @@
                           <a:ea typeface="Calibri" pitchFamily="34" charset="-122"/>
                           <a:cs typeface="Calibri" pitchFamily="34" charset="-120"/>
                         </a:rPr>
-                        <a:t>87.5%</a:t>
+                        <a:t>7 of 8</a:t>
                       </a:r>
                       <a:endParaRPr lang="en-US" sz="1400" dirty="0">
                         <a:latin typeface="Calibri" charset="0"/>
@@ -4501,7 +4501,7 @@
                           <a:ea typeface="Calibri" pitchFamily="34" charset="-122"/>
                           <a:cs typeface="Calibri" pitchFamily="34" charset="-120"/>
                         </a:rPr>
-                        <a:t>62.5%</a:t>
+                        <a:t>5 of 8</a:t>
                       </a:r>
                       <a:endParaRPr lang="en-US" sz="1400" dirty="0">
                         <a:latin typeface="Calibri" charset="0"/>
@@ -4698,7 +4698,7 @@
                           <a:ea typeface="Calibri" pitchFamily="34" charset="-122"/>
                           <a:cs typeface="Calibri" pitchFamily="34" charset="-120"/>
                         </a:rPr>
-                        <a:t>19.5%</a:t>
+                        <a:t>8 of 41</a:t>
                       </a:r>
                       <a:endParaRPr lang="en-US" sz="1400" dirty="0">
                         <a:latin typeface="Calibri" charset="0"/>
@@ -4763,7 +4763,7 @@
                           <a:ea typeface="Calibri" pitchFamily="34" charset="-122"/>
                           <a:cs typeface="Calibri" pitchFamily="34" charset="-120"/>
                         </a:rPr>
-                        <a:t>95.1%</a:t>
+                        <a:t>39 of 41</a:t>
                       </a:r>
                       <a:endParaRPr lang="en-US" sz="1400" dirty="0">
                         <a:latin typeface="Calibri" charset="0"/>
@@ -4828,7 +4828,7 @@
                           <a:ea typeface="Calibri" pitchFamily="34" charset="-122"/>
                           <a:cs typeface="Calibri" pitchFamily="34" charset="-120"/>
                         </a:rPr>
-                        <a:t>87.8%</a:t>
+                        <a:t>36 of 41</a:t>
                       </a:r>
                       <a:endParaRPr lang="en-US" sz="1400" dirty="0">
                         <a:latin typeface="Calibri" charset="0"/>
@@ -4893,7 +4893,7 @@
                           <a:ea typeface="Calibri" pitchFamily="34" charset="-122"/>
                           <a:cs typeface="Calibri" pitchFamily="34" charset="-120"/>
                         </a:rPr>
-                        <a:t>53.7%</a:t>
+                        <a:t>22 of 41</a:t>
                       </a:r>
                       <a:endParaRPr lang="en-US" sz="1400" dirty="0">
                         <a:latin typeface="Calibri" charset="0"/>
@@ -4971,7 +4971,7 @@
               <a:buNone/>
             </a:pPr>
             <a:r>
-              <a:rPr lang="en-US" sz="1300" dirty="0">
+              <a:rPr lang="en-US" sz="1250" dirty="0">
                 <a:solidFill>
                   <a:srgbClr val="1A1A2E"/>
                 </a:solidFill>
@@ -4979,9 +4979,9 @@
                 <a:ea typeface="Calibri" pitchFamily="34" charset="-122"/>
                 <a:cs typeface="Calibri" pitchFamily="34" charset="-120"/>
               </a:rPr>
-              <a:t>On the eight German-source signals whose reference label warrants escalation: the floor escalates none, the learned model five, the contextual path seven. The learned model ties the contextual path on severity accuracy; its stratum recalls differ by 32.6 points, the contextual path's by 0.3, descriptive figures on eight items. One significant test beside a non-significant one does not compare the two gaps.</a:t>
-            </a:r>
-            <a:endParaRPr lang="en-US" sz="1300" dirty="0"/>
+              <a:t>On the eight German-source positives the floor escalates none, the learned model five, the generic prompt seven, the production stage five. The learned model and the generic prompt are not distinguishable on risk accuracy; the stratum recalls are descriptive figures on eight items (within-predictor Fisher p 0.026 and 1.0), and a significant test beside a non-significant one does not compare the two gaps.</a:t>
+            </a:r>
+            <a:endParaRPr lang="en-US" sz="1250" dirty="0"/>
           </a:p>
         </p:txBody>
       </p:sp>
@@ -5084,7 +5084,7 @@
                 <a:ea typeface="Calibri" pitchFamily="34" charset="-122"/>
                 <a:cs typeface="Calibri" pitchFamily="34" charset="-120"/>
               </a:rPr>
-              <a:t>The German-source escalate stratum is eight signals. A 95% interval on 7 of 8 runs from roughly 47% to 100%, on 5 of 8 from 25% to 92%.</a:t>
+              <a:t>The German-source escalate stratum is eight signals. A 95% interval on 7 of 8 runs from 53% to 98%, on 5 of 8 from 31% to 86%.</a:t>
             </a:r>
             <a:endParaRPr lang="en-US" sz="1100" dirty="0"/>
           </a:p>
@@ -5252,7 +5252,7 @@
                 <a:ea typeface="Calibri" pitchFamily="34" charset="-122"/>
                 <a:cs typeface="Calibri" pitchFamily="34" charset="-120"/>
               </a:rPr>
-              <a:t>An uneven triage layer does not only score worse. It means some customers' problems are systematically less likely to reach a human at all. That is a fairness property of the loop rather than of a classifier, and the choice of triage method largely determines it.</a:t>
+              <a:t>An uneven triage layer does not only score worse. It means some customers' problems are less likely to reach a human at all, a fairness property of the loop rather than of a classifier. On this corpus the figures are descriptive and no predictor is ranked; per-stratum monitoring is the design consequence.</a:t>
             </a:r>
             <a:endParaRPr lang="en-US" sz="1550" dirty="0"/>
           </a:p>
@@ -5472,7 +5472,7 @@
                 <a:ea typeface="Calibri" pitchFamily="34" charset="-122"/>
                 <a:cs typeface="Calibri" pitchFamily="34" charset="-120"/>
               </a:rPr>
-              <a:t>of genuine reviews flagged by a stylometric detector at 81% recall. At 1 to 5% contamination that is 78 to 95 real customers per 100 flags.</a:t>
+              <a:t>of genuine reviews flagged by a stylometric detector at 81% recall, on 6,740 texts. Most flags would land on real customers.</a:t>
             </a:r>
             <a:endParaRPr lang="en-US" sz="1300" dirty="0"/>
           </a:p>
@@ -5550,7 +5550,7 @@
                 <a:ea typeface="Calibri" pitchFamily="34" charset="-122"/>
                 <a:cs typeface="Calibri" pitchFamily="34" charset="-120"/>
               </a:rPr>
-              <a:t>AUROC for a Binoculars cross-perplexity detector, English stratum. Below 0.5 is worse than chance: complaint text is the more predictable text.</a:t>
+              <a:t>AUROC of a Binoculars-style detector, English stratum. Below 0.5 is worse than chance: complaint text is the more predictable text.</a:t>
             </a:r>
             <a:endParaRPr lang="en-US" sz="1300" dirty="0"/>
           </a:p>
@@ -5628,7 +5628,7 @@
                 <a:ea typeface="Calibri" pitchFamily="34" charset="-122"/>
                 <a:cs typeface="Calibri" pitchFamily="34" charset="-120"/>
               </a:rPr>
-              <a:t>spread in flag rate across languages, Greek 44.4% against Polish 14.8%, because the lexicon encoded English and German cues only.</a:t>
+              <a:t>spread in flag rate across languages, because the lexicon encoded English and German cues only.</a:t>
             </a:r>
             <a:endParaRPr lang="en-US" sz="1300" dirty="0"/>
           </a:p>
@@ -5767,7 +5767,7 @@
                 <a:ea typeface="Calibri" pitchFamily="34" charset="-122"/>
                 <a:cs typeface="Calibri" pitchFamily="34" charset="-120"/>
               </a:rPr>
-              <a:t>Provenance, exact duplication, volume bursts against a source's own trailing median, and batch-level uniformity, annotated for a human rather than enforced. It abstains below ten words, which is 23% of a real corpus, and it reports its own flag rate per language so an uneven filter is visible before anyone excludes anything.</a:t>
+              <a:t>Provenance, exact duplication, volume bursts against a source's own trailing median, and batch-level uniformity, annotated for a human rather than enforced. It abstains below ten words, which is 23% of all 6,740 texts, and it reports its own flag rate per language so an uneven filter is visible before anyone excludes anything.</a:t>
             </a:r>
             <a:endParaRPr lang="en-US" sz="1300" dirty="0"/>
           </a:p>
@@ -5790,7 +5790,7 @@
                 <a:ea typeface="Calibri" pitchFamily="34" charset="-122"/>
                 <a:cs typeface="Calibri" pitchFamily="34" charset="-120"/>
               </a:rPr>
-              <a:t>Per-comment authorship attribution is not implemented. On the same 6,154 genuine reviews the shipped gate flags 0.86%, and every one is a true duplicate.</a:t>
+              <a:t>Per-comment authorship attribution is not implemented. On 6,154 genuine reviews the shipped gate flags 0.86%, and every one is an exact duplicate.</a:t>
             </a:r>
             <a:endParaRPr lang="en-US" sz="1300" dirty="0"/>
           </a:p>
@@ -7090,7 +7090,7 @@
                 <a:ea typeface="Calibri" pitchFamily="34" charset="-122"/>
                 <a:cs typeface="Calibri" pitchFamily="34" charset="-120"/>
               </a:rPr>
-              <a:t>What replicates, and what does not</a:t>
+              <a:t>What holds on the new sets, and what does not</a:t>
             </a:r>
             <a:endParaRPr lang="en-US" sz="1450" dirty="0"/>
           </a:p>
@@ -7129,7 +7129,7 @@
                 <a:ea typeface="Calibri" pitchFamily="34" charset="-122"/>
                 <a:cs typeface="Calibri" pitchFamily="34" charset="-120"/>
               </a:rPr>
-              <a:t>The sentiment result holds on all three. The severity result does not. On none of the three does the learned model separate from the keyword floor on severity, where on the thesis corpus it clearly did. Severity behaviour looks corpus dependent, and the discussion should say so.</a:t>
+              <a:t>The sentiment result holds on all three. The severity result does not. On none of the three does the learned model separate from the keyword floor on severity, where on the thesis corpus it did. Severity behaviour looks corpus dependent, and the discussion should say so.</a:t>
             </a:r>
             <a:endParaRPr lang="en-US" sz="1300" dirty="0"/>
           </a:p>
@@ -7234,7 +7234,7 @@
                 <a:ea typeface="Calibri" pitchFamily="34" charset="-122"/>
                 <a:cs typeface="Calibri" pitchFamily="34" charset="-120"/>
               </a:rPr>
-              <a:t>Vodafone is the only new set with two source strata large enough to compare: the learned model escalates German-source signals at 50% against 81.8% English-source. Same direction as its observed 32.6-point gap on the thesis corpus; draft labels, descriptive in both cases.</a:t>
+              <a:t>Vodafone is the only new set with two source strata large enough to compare: the learned model escalates German-source signals at 50% against 81.8% English-source. Same direction as its observed gap on the thesis corpus (5 of 8 against 39 of 41); draft labels, descriptive in both cases.</a:t>
             </a:r>
             <a:endParaRPr lang="en-US" sz="1300" dirty="0"/>
           </a:p>
@@ -8455,7 +8455,7 @@
                 <a:ea typeface="Calibri" pitchFamily="34" charset="-122"/>
                 <a:cs typeface="Calibri" pitchFamily="34" charset="-120"/>
               </a:rPr>
-              <a:t>Supplying the class inventory is easier than the free-form condition production runs, so 0.59 and 0.40 are an upper bound and not an estimate. n = 182, with six signals lost to endpoint errors. Restricted to classes with at least five gold examples, macro-F1 falls to 0.28 and 0.18.</a:t>
+              <a:t>The class inventory is supplied, so this is a constrained task distinct from the free-form routing production runs, not a bound on it. n = 182, with six signals lost to endpoint errors; macro-F1 0.50 and 0.32. On classes with at least five examples, macro-F1 is 0.55 and 0.42 and accuracy 0.58 and 0.44.</a:t>
             </a:r>
             <a:endParaRPr lang="en-US" sz="1250" dirty="0"/>
           </a:p>
@@ -8516,7 +8516,7 @@
                 <a:ea typeface="Calibri" pitchFamily="34" charset="-122"/>
                 <a:cs typeface="Calibri" pitchFamily="34" charset="-120"/>
               </a:rPr>
-              <a:t>Why this strengthens the design</a:t>
+              <a:t>What the approval gate controls, and what it cannot</a:t>
             </a:r>
             <a:endParaRPr lang="en-US" sz="1400" dirty="0"/>
           </a:p>
@@ -8547,7 +8547,7 @@
               <a:buNone/>
             </a:pPr>
             <a:r>
-              <a:rPr lang="en-US" sz="1400" dirty="0">
+              <a:rPr lang="en-US" sz="1350" dirty="0">
                 <a:solidFill>
                   <a:srgbClr val="FFFFFF"/>
                 </a:solidFill>
@@ -8555,22 +8555,22 @@
                 <a:ea typeface="Calibri" pitchFamily="34" charset="-122"/>
                 <a:cs typeface="Calibri" pitchFamily="34" charset="-120"/>
               </a:rPr>
-              <a:t>The approval gate is the control that makes a pipeline of this accuracy safe to deploy. These fields are useful as a draft that a human accepts or corrects, and unsafe as an unattended decision. I did not choose the numbers to make that argument. They are what the run produced, and I report them because they are the strongest available answer to the question of why the agent does not simply route it.</a:t>
-            </a:r>
-            <a:endParaRPr lang="en-US" sz="1400" dirty="0"/>
+              <a:t>The gate controls false positives, the wrong or harmful actions that would otherwise reach an external system. It cannot recover escalation-worthy signals the enrichment ranks too low: 22 of 50 under the seed labels on the production rubric. These fields are a draft that a human accepts or corrects, not an unattended decision. The numbers are what the run produced; they are the strongest available answer to why the agent does not simply route it.</a:t>
+            </a:r>
+            <a:endParaRPr lang="en-US" sz="1350" dirty="0"/>
           </a:p>
           <a:p>
             <a:pPr indent="0" marL="0">
               <a:buNone/>
             </a:pPr>
-            <a:endParaRPr lang="en-US" sz="1400" dirty="0"/>
+            <a:endParaRPr lang="en-US" sz="1350" dirty="0"/>
           </a:p>
           <a:p>
             <a:pPr indent="0" marL="0">
               <a:buNone/>
             </a:pPr>
             <a:r>
-              <a:rPr lang="en-US" sz="1400" dirty="0">
+              <a:rPr lang="en-US" sz="1350" dirty="0">
                 <a:solidFill>
                   <a:srgbClr val="FFFFFF"/>
                 </a:solidFill>
@@ -8578,9 +8578,9 @@
                 <a:ea typeface="Calibri" pitchFamily="34" charset="-122"/>
                 <a:cs typeface="Calibri" pitchFamily="34" charset="-120"/>
               </a:rPr>
-              <a:t>Since the review, journey-stage routing can run the closed-inventory condition in production behind a flag, off by default. Measuring that condition is the next iteration.</a:t>
-            </a:r>
-            <a:endParaRPr lang="en-US" sz="1400" dirty="0"/>
+              <a:t>Journey-stage routing can run the closed-inventory condition behind a flag, off by default, in the build at the September commits. Measuring that condition is the next iteration.</a:t>
+            </a:r>
+            <a:endParaRPr lang="en-US" sz="1350" dirty="0"/>
           </a:p>
         </p:txBody>
       </p:sp>
@@ -8681,7 +8681,7 @@
                 <a:ea typeface="Cambria" pitchFamily="34" charset="-122"/>
                 <a:cs typeface="Cambria" pitchFamily="34" charset="-120"/>
               </a:rPr>
-              <a:t>The memory steers the recommendation</a:t>
+              <a:t>The memory can steer the recommendation</a:t>
             </a:r>
             <a:endParaRPr lang="en-US" sz="3000" dirty="0"/>
           </a:p>
@@ -8720,7 +8720,7 @@
                 <a:ea typeface="Calibri" pitchFamily="34" charset="-122"/>
                 <a:cs typeface="Calibri" pitchFamily="34" charset="-120"/>
               </a:rPr>
-              <a:t>The mechanism is measured. The benefit is not.</a:t>
+              <a:t>Retrieval altered recommendations in small probes on GLM-5.2. The benefit of decay is untested.</a:t>
             </a:r>
             <a:endParaRPr lang="en-US" sz="1500" dirty="0"/>
           </a:p>
@@ -8798,7 +8798,7 @@
                 <a:ea typeface="Calibri" pitchFamily="34" charset="-122"/>
                 <a:cs typeface="Calibri" pitchFamily="34" charset="-120"/>
               </a:rPr>
-              <a:t>share of a past remedy appearing in the new recommendation once retrieval is on, at 66.7% adoption</a:t>
+              <a:t>share of a past remedy appearing in the new recommendation once retrieval is on (3 July 2026, GLM-5.2; contemporaneous record only)</a:t>
             </a:r>
             <a:endParaRPr lang="en-US" sz="1300" dirty="0"/>
           </a:p>
@@ -8837,7 +8837,7 @@
                 <a:ea typeface="Cambria" pitchFamily="34" charset="-122"/>
                 <a:cs typeface="Cambria" pitchFamily="34" charset="-120"/>
               </a:rPr>
-              <a:t>0.503</a:t>
+              <a:t>3 of 3</a:t>
             </a:r>
             <a:endParaRPr lang="en-US" sz="4600" dirty="0"/>
           </a:p>
@@ -8876,7 +8876,7 @@
                 <a:ea typeface="Calibri" pitchFamily="34" charset="-122"/>
                 <a:cs typeface="Calibri" pitchFamily="34" charset="-120"/>
               </a:rPr>
-              <a:t>alignment lift against a same-run noise floor that absorbs model jitter</a:t>
+              <a:t>themes on which the 6 September re-run reproduced adoption on GLM-5.2 (contemporaneous record)</a:t>
             </a:r>
             <a:endParaRPr lang="en-US" sz="1300" dirty="0"/>
           </a:p>
@@ -8909,13 +8909,13 @@
             <a:r>
               <a:rPr lang="en-US" sz="4600" b="1" dirty="0">
                 <a:solidFill>
-                  <a:srgbClr val="1E2761"/>
+                  <a:srgbClr val="990011"/>
                 </a:solidFill>
                 <a:latin typeface="Cambria" pitchFamily="34" charset="0"/>
                 <a:ea typeface="Cambria" pitchFamily="34" charset="-122"/>
                 <a:cs typeface="Cambria" pitchFamily="34" charset="-120"/>
               </a:rPr>
-              <a:t>0 and 2.5%</a:t>
+              <a:t>1 of 4</a:t>
             </a:r>
             <a:endParaRPr lang="en-US" sz="4600" dirty="0"/>
           </a:p>
@@ -8954,7 +8954,7 @@
                 <a:ea typeface="Calibri" pitchFamily="34" charset="-122"/>
                 <a:cs typeface="Calibri" pitchFamily="34" charset="-120"/>
               </a:rPr>
-              <a:t>PII leaks across the local run ledger, and the hallucination rate at the 17 July run, English scope by construction</a:t>
+              <a:t>themes on the production default in the same re-run: the effect did not reproduce on Mistral Small 4</a:t>
             </a:r>
             <a:endParaRPr lang="en-US" sz="1300" dirty="0"/>
           </a:p>
@@ -9059,7 +9059,7 @@
                 <a:ea typeface="Calibri" pitchFamily="34" charset="-122"/>
                 <a:cs typeface="Calibri" pitchFamily="34" charset="-120"/>
               </a:rPr>
-              <a:t>The outcome data behind these learnings is simulated. Adoption shows that the loop steers recommendations. Whether the steered remedy is better needs a live outcome contract on real data, which is the single most important open step in the thesis.</a:t>
+              <a:t>The probes varied whether a learning was retrieved, not its age, and ran on simulation-authored learnings over simulated outcome data, a condition the retrieval gate no longer admits. Decay (DP2) is an implemented design hypothesis whose benefit remains untested; whether the steered remedy is better needs a live outcome contract on real data.</a:t>
             </a:r>
             <a:endParaRPr lang="en-US" sz="1500" dirty="0"/>
           </a:p>
@@ -9162,7 +9162,7 @@
                 <a:ea typeface="Cambria" pitchFamily="34" charset="-122"/>
                 <a:cs typeface="Cambria" pitchFamily="34" charset="-120"/>
               </a:rPr>
-              <a:t>What is proven, what is demonstrated, what is pending</a:t>
+              <a:t>What is measured, demonstrated, and not conducted</a:t>
             </a:r>
             <a:endParaRPr lang="en-US" sz="3000" dirty="0"/>
           </a:p>
@@ -9201,7 +9201,7 @@
                 <a:ea typeface="Calibri" pitchFamily="34" charset="-122"/>
                 <a:cs typeface="Calibri" pitchFamily="34" charset="-120"/>
               </a:rPr>
-              <a:t>The traceability matrix, Appendix D</a:t>
+              <a:t>The traceability matrix, Appendix D, in the status vocabulary of §1.7</a:t>
             </a:r>
             <a:endParaRPr lang="en-US" sz="1500" dirty="0"/>
           </a:p>
@@ -9458,7 +9458,7 @@
                           <a:ea typeface="Calibri" pitchFamily="34" charset="-122"/>
                           <a:cs typeface="Calibri" pitchFamily="34" charset="-120"/>
                         </a:rPr>
-                        <a:t>Triage accuracy (RQ3a)</a:t>
+                        <a:t>Triage agreement (RQ3a)</a:t>
                       </a:r>
                       <a:endParaRPr lang="en-US" sz="1400" dirty="0">
                         <a:latin typeface="Calibri" charset="0"/>
@@ -9523,7 +9523,7 @@
                           <a:ea typeface="Calibri" pitchFamily="34" charset="-122"/>
                           <a:cs typeface="Calibri" pitchFamily="34" charset="-120"/>
                         </a:rPr>
-                        <a:t>Measured</a:t>
+                        <a:t>Measured (bounded)</a:t>
                       </a:r>
                       <a:endParaRPr lang="en-US" sz="1400" dirty="0">
                         <a:latin typeface="Calibri" charset="0"/>
@@ -9588,7 +9588,7 @@
                           <a:ea typeface="Calibri" pitchFamily="34" charset="-122"/>
                           <a:cs typeface="Calibri" pitchFamily="34" charset="-120"/>
                         </a:rPr>
-                        <a:t>three predictors on one gold standard, with pairwise McNemar tests</a:t>
+                        <a:t>five predictors on one gold standard; McNemar tests in one retrospective Holm family per task</a:t>
                       </a:r>
                       <a:endParaRPr lang="en-US" sz="1400" dirty="0">
                         <a:latin typeface="Calibri" charset="0"/>
@@ -9720,7 +9720,7 @@
                           <a:ea typeface="Calibri" pitchFamily="34" charset="-122"/>
                           <a:cs typeface="Calibri" pitchFamily="34" charset="-120"/>
                         </a:rPr>
-                        <a:t>Measured, bounded</a:t>
+                        <a:t>Descriptive</a:t>
                       </a:r>
                       <a:endParaRPr lang="en-US" sz="1400" dirty="0">
                         <a:latin typeface="Calibri" charset="0"/>
@@ -9785,7 +9785,7 @@
                           <a:ea typeface="Calibri" pitchFamily="34" charset="-122"/>
                           <a:cs typeface="Calibri" pitchFamily="34" charset="-120"/>
                         </a:rPr>
-                        <a:t>floor 0.0, learned 62.5, contextual 87.5 vs 87.8, production 62.5 vs 53.7; n = 8</a:t>
+                        <a:t>German-source 8 positives: floor 0, TF-IDF 5, generic 7, production 5; English-source 41: 8, 39, 36, 22</a:t>
                       </a:r>
                       <a:endParaRPr lang="en-US" sz="1400" dirty="0">
                         <a:latin typeface="Calibri" charset="0"/>
@@ -9917,7 +9917,7 @@
                           <a:ea typeface="Calibri" pitchFamily="34" charset="-122"/>
                           <a:cs typeface="Calibri" pitchFamily="34" charset="-120"/>
                         </a:rPr>
-                        <a:t>Measured, bounded</a:t>
+                        <a:t>Measured (bounded)</a:t>
                       </a:r>
                       <a:endParaRPr lang="en-US" sz="1400" dirty="0">
                         <a:latin typeface="Calibri" charset="0"/>
@@ -9982,7 +9982,7 @@
                           <a:ea typeface="Calibri" pitchFamily="34" charset="-122"/>
                           <a:cs typeface="Calibri" pitchFamily="34" charset="-120"/>
                         </a:rPr>
-                        <a:t>scored with the inventory supplied, which is an upper bound</a:t>
+                        <a:t>scored with the inventory supplied, a constrained task distinct from free-form routing; n = 182</a:t>
                       </a:r>
                       <a:endParaRPr lang="en-US" sz="1400" dirty="0">
                         <a:latin typeface="Calibri" charset="0"/>
@@ -10114,7 +10114,7 @@
                           <a:ea typeface="Calibri" pitchFamily="34" charset="-122"/>
                           <a:cs typeface="Calibri" pitchFamily="34" charset="-120"/>
                         </a:rPr>
-                        <a:t>Partially measured</a:t>
+                        <a:t>Implemented; untested hypothesis</a:t>
                       </a:r>
                       <a:endParaRPr lang="en-US" sz="1400" dirty="0">
                         <a:latin typeface="Calibri" charset="0"/>
@@ -10179,7 +10179,7 @@
                           <a:ea typeface="Calibri" pitchFamily="34" charset="-122"/>
                           <a:cs typeface="Calibri" pitchFamily="34" charset="-120"/>
                         </a:rPr>
-                        <a:t>remedy adoption 21% to 71%; replicated on GLM-5.2, not on the production default; simulated outcomes</a:t>
+                        <a:t>retrieval altered recommendations in small probes on GLM-5.2, not on the production default; simulated outcomes</a:t>
                       </a:r>
                       <a:endParaRPr lang="en-US" sz="1400" dirty="0">
                         <a:latin typeface="Calibri" charset="0"/>
@@ -10311,7 +10311,7 @@
                           <a:ea typeface="Calibri" pitchFamily="34" charset="-122"/>
                           <a:cs typeface="Calibri" pitchFamily="34" charset="-120"/>
                         </a:rPr>
-                        <a:t>Demonstrated</a:t>
+                        <a:t>Implemented and tested</a:t>
                       </a:r>
                       <a:endParaRPr lang="en-US" sz="1400" dirty="0">
                         <a:latin typeface="Calibri" charset="0"/>
@@ -10376,7 +10376,7 @@
                           <a:ea typeface="Calibri" pitchFamily="34" charset="-122"/>
                           <a:cs typeface="Calibri" pitchFamily="34" charset="-120"/>
                         </a:rPr>
-                        <a:t>designed, built and instrumented; one live contract still pending</a:t>
+                        <a:t>refusal below minimum data requirements tested; simulated outcome data only; not deployed at the time of writing</a:t>
                       </a:r>
                       <a:endParaRPr lang="en-US" sz="1400" dirty="0">
                         <a:latin typeface="Calibri" charset="0"/>
@@ -10508,7 +10508,7 @@
                           <a:ea typeface="Calibri" pitchFamily="34" charset="-122"/>
                           <a:cs typeface="Calibri" pitchFamily="34" charset="-120"/>
                         </a:rPr>
-                        <a:t>Shipped, partly measured</a:t>
+                        <a:t>Implemented and tested</a:t>
                       </a:r>
                       <a:endParaRPr lang="en-US" sz="1400" dirty="0">
                         <a:latin typeface="Calibri" charset="0"/>
@@ -10573,7 +10573,7 @@
                           <a:ea typeface="Calibri" pitchFamily="34" charset="-122"/>
                           <a:cs typeface="Calibri" pitchFamily="34" charset="-120"/>
                         </a:rPr>
-                        <a:t>calibration and the refusal harness measured; the rest covered by unit tests</a:t>
+                        <a:t>calibration and the refusal harness measured; the rest covered by regression tests</a:t>
                       </a:r>
                       <a:endParaRPr lang="en-US" sz="1400" dirty="0">
                         <a:latin typeface="Calibri" charset="0"/>
@@ -10705,7 +10705,7 @@
                           <a:ea typeface="Calibri" pitchFamily="34" charset="-122"/>
                           <a:cs typeface="Calibri" pitchFamily="34" charset="-120"/>
                         </a:rPr>
-                        <a:t>Measured once, provenance unverified</a:t>
+                        <a:t>Provenance unverified</a:t>
                       </a:r>
                       <a:endParaRPr lang="en-US" sz="1400" dirty="0">
                         <a:latin typeface="Calibri" charset="0"/>
@@ -10770,7 +10770,7 @@
                           <a:ea typeface="Calibri" pitchFamily="34" charset="-122"/>
                           <a:cs typeface="Calibri" pitchFamily="34" charset="-120"/>
                         </a:rPr>
-                        <a:t>kappa 0.55 (0.70 weighted), 40 risk items; independent human provenance unverified, so no human check; none on golden set</a:t>
+                        <a:t>kappa 0.55 (0.70 weighted), 40 risk items; independent human provenance unverified, so not human validation</a:t>
                       </a:r>
                       <a:endParaRPr lang="en-US" sz="1400" dirty="0">
                         <a:latin typeface="Calibri" charset="0"/>
@@ -10902,7 +10902,7 @@
                           <a:ea typeface="Calibri" pitchFamily="34" charset="-122"/>
                           <a:cs typeface="Calibri" pitchFamily="34" charset="-120"/>
                         </a:rPr>
-                        <a:t>Measured, refused</a:t>
+                        <a:t>Measured (bounded)</a:t>
                       </a:r>
                       <a:endParaRPr lang="en-US" sz="1400" dirty="0">
                         <a:latin typeface="Calibri" charset="0"/>
@@ -11034,7 +11034,7 @@
                           <a:ea typeface="Calibri" pitchFamily="34" charset="-122"/>
                           <a:cs typeface="Calibri" pitchFamily="34" charset="-120"/>
                         </a:rPr>
-                        <a:t>Practitioner value (RQ4)</a:t>
+                        <a:t>Practitioner experience (RQ4)</a:t>
                       </a:r>
                       <a:endParaRPr lang="en-US" sz="1400" dirty="0">
                         <a:latin typeface="Calibri" charset="0"/>
@@ -11099,7 +11099,7 @@
                           <a:ea typeface="Calibri" pitchFamily="34" charset="-122"/>
                           <a:cs typeface="Calibri" pitchFamily="34" charset="-120"/>
                         </a:rPr>
-                        <a:t>Pending</a:t>
+                        <a:t>Not conducted</a:t>
                       </a:r>
                       <a:endParaRPr lang="en-US" sz="1400" dirty="0">
                         <a:latin typeface="Calibri" charset="0"/>
@@ -11164,7 +11164,7 @@
                           <a:ea typeface="Calibri" pitchFamily="34" charset="-122"/>
                           <a:cs typeface="Calibri" pitchFamily="34" charset="-120"/>
                         </a:rPr>
-                        <a:t>instruments ready; interviews not started</a:t>
+                        <a:t>protocol, instruments and pre-registered tiers retained (Appendix A; §5B)</a:t>
                       </a:r>
                       <a:endParaRPr lang="en-US" sz="1400" dirty="0">
                         <a:latin typeface="Calibri" charset="0"/>
@@ -11250,7 +11250,7 @@
                 <a:ea typeface="Calibri" pitchFamily="34" charset="-122"/>
                 <a:cs typeface="Calibri" pitchFamily="34" charset="-120"/>
               </a:rPr>
-              <a:t>A claim's status is stated once, in one place, and every chapter has to agree with it. That is what the truth audit tested on 20 August. Where a chapter disagreed with this table, I changed the chapter.</a:t>
+              <a:t>A claim's status is stated once, in one place, and every chapter has to agree with it. That is what the truth audit tested on 20 August and the 17 September revision re-checked. Where a chapter disagreed with this table, I changed the chapter.</a:t>
             </a:r>
             <a:endParaRPr lang="en-US" sz="1300" dirty="0"/>
           </a:p>
@@ -11460,13 +11460,13 @@
           <a:p>
             <a:pPr marL="342900" indent="-342900">
               <a:spcAft>
-                <a:spcPts val="700"/>
+                <a:spcPts val="500"/>
               </a:spcAft>
               <a:buSzPct val="100000"/>
               <a:buChar char="•"/>
             </a:pPr>
             <a:r>
-              <a:rPr lang="en-US" sz="1250" dirty="0">
+              <a:rPr lang="en-US" sz="1150" dirty="0">
                 <a:solidFill>
                   <a:srgbClr val="1A1A2E"/>
                 </a:solidFill>
@@ -11476,8 +11476,216 @@
               </a:rPr>
               <a:t>A modest, balanced corpus of 188 signals. It characterises the pipeline, not a population.</a:t>
             </a:r>
-            <a:endParaRPr lang="en-US" sz="1250" dirty="0"/>
-          </a:p>
+            <a:endParaRPr lang="en-US" sz="1150" dirty="0"/>
+          </a:p>
+          <a:p>
+            <a:pPr marL="342900" indent="-342900">
+              <a:spcAft>
+                <a:spcPts val="500"/>
+              </a:spcAft>
+              <a:buSzPct val="100000"/>
+              <a:buChar char="•"/>
+            </a:pPr>
+            <a:r>
+              <a:rPr lang="en-US" sz="1150" dirty="0">
+                <a:solidFill>
+                  <a:srgbClr val="1A1A2E"/>
+                </a:solidFill>
+                <a:latin typeface="Calibri" pitchFamily="34" charset="0"/>
+                <a:ea typeface="Calibri" pitchFamily="34" charset="-122"/>
+                <a:cs typeface="Calibri" pitchFamily="34" charset="-120"/>
+              </a:rPr>
+              <a:t>Language is confounded with sector, the texts are English paraphrases, and the German-source escalate stratum is eight signals; one cross-language claim was retracted.</a:t>
+            </a:r>
+            <a:endParaRPr lang="en-US" sz="1150" dirty="0"/>
+          </a:p>
+          <a:p>
+            <a:pPr marL="342900" indent="-342900">
+              <a:spcAft>
+                <a:spcPts val="500"/>
+              </a:spcAft>
+              <a:buSzPct val="100000"/>
+              <a:buChar char="•"/>
+            </a:pPr>
+            <a:r>
+              <a:rPr lang="en-US" sz="1150" dirty="0">
+                <a:solidFill>
+                  <a:srgbClr val="1A1A2E"/>
+                </a:solidFill>
+                <a:latin typeface="Calibri" pitchFamily="34" charset="0"/>
+                <a:ea typeface="Calibri" pitchFamily="34" charset="-122"/>
+                <a:cs typeface="Calibri" pitchFamily="34" charset="-120"/>
+              </a:rPr>
+              <a:t>Routing is scored only with the inventory supplied, a constrained task; theme and action carry labels but no metric.</a:t>
+            </a:r>
+            <a:endParaRPr lang="en-US" sz="1150" dirty="0"/>
+          </a:p>
+          <a:p>
+            <a:pPr marL="342900" indent="-342900">
+              <a:spcAft>
+                <a:spcPts val="500"/>
+              </a:spcAft>
+              <a:buSzPct val="100000"/>
+              <a:buChar char="•"/>
+            </a:pPr>
+            <a:r>
+              <a:rPr lang="en-US" sz="1150" dirty="0">
+                <a:solidFill>
+                  <a:srgbClr val="1A1A2E"/>
+                </a:solidFill>
+                <a:latin typeface="Calibri" pitchFamily="34" charset="0"/>
+                <a:ea typeface="Calibri" pitchFamily="34" charset="-122"/>
+                <a:cs typeface="Calibri" pitchFamily="34" charset="-120"/>
+              </a:rPr>
+              <a:t>One agreement number: kappa 0.55 on 40 risk items, second-rating agreement with independent human provenance unverified, never used as human validation; none on golden set.</a:t>
+            </a:r>
+            <a:endParaRPr lang="en-US" sz="1150" dirty="0"/>
+          </a:p>
+          <a:p>
+            <a:pPr marL="342900" indent="-342900">
+              <a:spcAft>
+                <a:spcPts val="500"/>
+              </a:spcAft>
+              <a:buSzPct val="100000"/>
+              <a:buChar char="•"/>
+            </a:pPr>
+            <a:r>
+              <a:rPr lang="en-US" sz="1150" dirty="0">
+                <a:solidFill>
+                  <a:srgbClr val="1A1A2E"/>
+                </a:solidFill>
+                <a:latin typeface="Calibri" pitchFamily="34" charset="0"/>
+                <a:ea typeface="Calibri" pitchFamily="34" charset="-122"/>
+                <a:cs typeface="Calibri" pitchFamily="34" charset="-120"/>
+              </a:rPr>
+              <a:t>The golden set's urgency exemplar effect is sequential testing without alpha spending; same-item re-runs do not replace alpha control, so it carries no confirmatory weight.</a:t>
+            </a:r>
+            <a:endParaRPr lang="en-US" sz="1150" dirty="0"/>
+          </a:p>
+          <a:p>
+            <a:pPr marL="342900" indent="-342900">
+              <a:spcAft>
+                <a:spcPts val="500"/>
+              </a:spcAft>
+              <a:buSzPct val="100000"/>
+              <a:buChar char="•"/>
+            </a:pPr>
+            <a:r>
+              <a:rPr lang="en-US" sz="1150" dirty="0">
+                <a:solidFill>
+                  <a:srgbClr val="1A1A2E"/>
+                </a:solidFill>
+                <a:latin typeface="Calibri" pitchFamily="34" charset="0"/>
+                <a:ea typeface="Calibri" pitchFamily="34" charset="-122"/>
+                <a:cs typeface="Calibri" pitchFamily="34" charset="-120"/>
+              </a:rPr>
+              <a:t>Outcome data behind the learning loop is simulated; the contract, verdict and memory mechanisms are tested at commits not deployed at the time of writing.</a:t>
+            </a:r>
+            <a:endParaRPr lang="en-US" sz="1150" dirty="0"/>
+          </a:p>
+          <a:p>
+            <a:pPr marL="342900" indent="-342900">
+              <a:spcAft>
+                <a:spcPts val="500"/>
+              </a:spcAft>
+              <a:buSzPct val="100000"/>
+              <a:buChar char="•"/>
+            </a:pPr>
+            <a:r>
+              <a:rPr lang="en-US" sz="1150" dirty="0">
+                <a:solidFill>
+                  <a:srgbClr val="1A1A2E"/>
+                </a:solidFill>
+                <a:latin typeface="Calibri" pitchFamily="34" charset="0"/>
+                <a:ea typeface="Calibri" pitchFamily="34" charset="-122"/>
+                <a:cs typeface="Calibri" pitchFamily="34" charset="-120"/>
+              </a:rPr>
+              <a:t>The practitioner study was not conducted, so RQ4 is unanswered and the friction clause of RQ2 is open.</a:t>
+            </a:r>
+            <a:endParaRPr lang="en-US" sz="1150" dirty="0"/>
+          </a:p>
+          <a:p>
+            <a:pPr marL="342900" indent="-342900">
+              <a:spcAft>
+                <a:spcPts val="500"/>
+              </a:spcAft>
+              <a:buSzPct val="100000"/>
+              <a:buChar char="•"/>
+            </a:pPr>
+            <a:r>
+              <a:rPr lang="en-US" sz="1150" dirty="0">
+                <a:solidFill>
+                  <a:srgbClr val="1A1A2E"/>
+                </a:solidFill>
+                <a:latin typeface="Calibri" pitchFamily="34" charset="0"/>
+                <a:ea typeface="Calibri" pitchFamily="34" charset="-122"/>
+                <a:cs typeface="Calibri" pitchFamily="34" charset="-120"/>
+              </a:rPr>
+              <a:t>I am the designer, the founder and the researcher, managed by reference labels of stated provenance, standard instruments and a reproducible harness.</a:t>
+            </a:r>
+            <a:endParaRPr lang="en-US" sz="1150" dirty="0"/>
+          </a:p>
+        </p:txBody>
+      </p:sp>
+      <p:sp>
+        <p:nvSpPr>
+          <p:cNvPr id="7" name="Text 5"/>
+          <p:cNvSpPr/>
+          <p:nvPr/>
+        </p:nvSpPr>
+        <p:spPr>
+          <a:xfrm>
+            <a:off x="6309360" y="1371600"/>
+            <a:ext cx="5303520" cy="310896"/>
+          </a:xfrm>
+          <a:prstGeom prst="rect">
+            <a:avLst/>
+          </a:prstGeom>
+          <a:noFill/>
+          <a:ln/>
+        </p:spPr>
+        <p:txBody>
+          <a:bodyPr wrap="square" rtlCol="0" anchor="ctr"/>
+          <a:lstStyle/>
+          <a:p>
+            <a:pPr indent="0" marL="0">
+              <a:buNone/>
+            </a:pPr>
+            <a:r>
+              <a:rPr lang="en-US" sz="1700" b="1" dirty="0">
+                <a:solidFill>
+                  <a:srgbClr val="1E2761"/>
+                </a:solidFill>
+                <a:latin typeface="Cambria" pitchFamily="34" charset="0"/>
+                <a:ea typeface="Cambria" pitchFamily="34" charset="-122"/>
+                <a:cs typeface="Cambria" pitchFamily="34" charset="-120"/>
+              </a:rPr>
+              <a:t>Next, in the order of §6.5</a:t>
+            </a:r>
+            <a:endParaRPr lang="en-US" sz="1700" dirty="0"/>
+          </a:p>
+        </p:txBody>
+      </p:sp>
+      <p:sp>
+        <p:nvSpPr>
+          <p:cNvPr id="8" name="Text 6"/>
+          <p:cNvSpPr/>
+          <p:nvPr/>
+        </p:nvSpPr>
+        <p:spPr>
+          <a:xfrm>
+            <a:off x="6492240" y="1755648"/>
+            <a:ext cx="5120640" cy="4297680"/>
+          </a:xfrm>
+          <a:prstGeom prst="rect">
+            <a:avLst/>
+          </a:prstGeom>
+          <a:noFill/>
+          <a:ln/>
+        </p:spPr>
+        <p:txBody>
+          <a:bodyPr wrap="square" rtlCol="0" anchor="ctr"/>
+          <a:lstStyle/>
           <a:p>
             <a:pPr marL="342900" indent="-342900">
               <a:spcAft>
@@ -11487,7 +11695,7 @@
               <a:buChar char="•"/>
             </a:pPr>
             <a:r>
-              <a:rPr lang="en-US" sz="1250" dirty="0">
+              <a:rPr lang="en-US" sz="1200" dirty="0">
                 <a:solidFill>
                   <a:srgbClr val="1A1A2E"/>
                 </a:solidFill>
@@ -11495,9 +11703,9 @@
                 <a:ea typeface="Calibri" pitchFamily="34" charset="-122"/>
                 <a:cs typeface="Calibri" pitchFamily="34" charset="-120"/>
               </a:rPr>
-              <a:t>Language is confounded with sector and the texts are English paraphrases, so every per-language result is a source-language stratum; one cross-language claim was retracted rather than defended.</a:t>
-            </a:r>
-            <a:endParaRPr lang="en-US" sz="1250" dirty="0"/>
+              <a:t>The practitioner study. Instruments, reporting tiers and the survey script are ready; twelve to fifteen interviews and task sessions, with the survey for breadth.</a:t>
+            </a:r>
+            <a:endParaRPr lang="en-US" sz="1200" dirty="0"/>
           </a:p>
           <a:p>
             <a:pPr marL="342900" indent="-342900">
@@ -11508,7 +11716,7 @@
               <a:buChar char="•"/>
             </a:pPr>
             <a:r>
-              <a:rPr lang="en-US" sz="1250" dirty="0">
+              <a:rPr lang="en-US" sz="1200" dirty="0">
                 <a:solidFill>
                   <a:srgbClr val="1A1A2E"/>
                 </a:solidFill>
@@ -11516,9 +11724,9 @@
                 <a:ea typeface="Calibri" pitchFamily="34" charset="-122"/>
                 <a:cs typeface="Calibri" pitchFamily="34" charset="-120"/>
               </a:rPr>
-              <a:t>The German-source escalate stratum is eight signals.</a:t>
-            </a:r>
-            <a:endParaRPr lang="en-US" sz="1250" dirty="0"/>
+              <a:t>The human annotation study on the existing corpus, with a provenance audit of the seed labels first: two raters blind, adjudication, every prediction file re-scored, the learned baseline retrained on the adjudicated gold.</a:t>
+            </a:r>
+            <a:endParaRPr lang="en-US" sz="1200" dirty="0"/>
           </a:p>
           <a:p>
             <a:pPr marL="342900" indent="-342900">
@@ -11529,7 +11737,7 @@
               <a:buChar char="•"/>
             </a:pPr>
             <a:r>
-              <a:rPr lang="en-US" sz="1250" dirty="0">
+              <a:rPr lang="en-US" sz="1200" dirty="0">
                 <a:solidFill>
                   <a:srgbClr val="1A1A2E"/>
                 </a:solidFill>
@@ -11537,9 +11745,9 @@
                 <a:ea typeface="Calibri" pitchFamily="34" charset="-122"/>
                 <a:cs typeface="Calibri" pitchFamily="34" charset="-120"/>
               </a:rPr>
-              <a:t>Routing is scored only with the inventory supplied, and two of the six gold fields are not scored at all.</a:t>
-            </a:r>
-            <a:endParaRPr lang="en-US" sz="1250" dirty="0"/>
+              <a:t>Compare no memory, memory without decay and memory with decay on frozen scenarios, with blind assessment across several half-lives, as the test of DP2.</a:t>
+            </a:r>
+            <a:endParaRPr lang="en-US" sz="1200" dirty="0"/>
           </a:p>
           <a:p>
             <a:pPr marL="342900" indent="-342900">
@@ -11550,7 +11758,7 @@
               <a:buChar char="•"/>
             </a:pPr>
             <a:r>
-              <a:rPr lang="en-US" sz="1250" dirty="0">
+              <a:rPr lang="en-US" sz="1200" dirty="0">
                 <a:solidFill>
                   <a:srgbClr val="1A1A2E"/>
                 </a:solidFill>
@@ -11558,9 +11766,9 @@
                 <a:ea typeface="Calibri" pitchFamily="34" charset="-122"/>
                 <a:cs typeface="Calibri" pitchFamily="34" charset="-120"/>
               </a:rPr>
-              <a:t>One agreement number: kappa 0.55 on 40 risk items, human provenance unverified, so no human check; none on golden set.</a:t>
-            </a:r>
-            <a:endParaRPr lang="en-US" sz="1250" dirty="0"/>
+              <a:t>One live outcome contract on non-simulated data measured through its window, preceded by a retrospective observational read of the shipped estimator over real dated inflow, which describes rather than attributes.</a:t>
+            </a:r>
+            <a:endParaRPr lang="en-US" sz="1200" dirty="0"/>
           </a:p>
           <a:p>
             <a:pPr marL="342900" indent="-342900">
@@ -11571,7 +11779,7 @@
               <a:buChar char="•"/>
             </a:pPr>
             <a:r>
-              <a:rPr lang="en-US" sz="1250" dirty="0">
+              <a:rPr lang="en-US" sz="1200" dirty="0">
                 <a:solidFill>
                   <a:srgbClr val="1A1A2E"/>
                 </a:solidFill>
@@ -11579,9 +11787,9 @@
                 <a:ea typeface="Calibri" pitchFamily="34" charset="-122"/>
                 <a:cs typeface="Calibri" pitchFamily="34" charset="-120"/>
               </a:rPr>
-              <a:t>Urgency exemplar effect tested at n = 60, 80, 100 without alpha spending; same-item re-runs bound model noise and do not replace alpha control, so the claim is exploratory.</a:t>
-            </a:r>
-            <a:endParaRPr lang="en-US" sz="1250" dirty="0"/>
+              <a:t>Source-stratum fairness monitoring of escalation and routing distributions, with denominators, as a standing control.</a:t>
+            </a:r>
+            <a:endParaRPr lang="en-US" sz="1200" dirty="0"/>
           </a:p>
           <a:p>
             <a:pPr marL="342900" indent="-342900">
@@ -11592,7 +11800,7 @@
               <a:buChar char="•"/>
             </a:pPr>
             <a:r>
-              <a:rPr lang="en-US" sz="1250" dirty="0">
+              <a:rPr lang="en-US" sz="1200" dirty="0">
                 <a:solidFill>
                   <a:srgbClr val="1A1A2E"/>
                 </a:solidFill>
@@ -11600,217 +11808,9 @@
                 <a:ea typeface="Calibri" pitchFamily="34" charset="-122"/>
                 <a:cs typeface="Calibri" pitchFamily="34" charset="-120"/>
               </a:rPr>
-              <a:t>Outcome data behind the learning loop is simulated, so the distinctive claim is demonstrated and not field-proven.</a:t>
-            </a:r>
-            <a:endParaRPr lang="en-US" sz="1250" dirty="0"/>
-          </a:p>
-          <a:p>
-            <a:pPr marL="342900" indent="-342900">
-              <a:spcAft>
-                <a:spcPts val="700"/>
-              </a:spcAft>
-              <a:buSzPct val="100000"/>
-              <a:buChar char="•"/>
-            </a:pPr>
-            <a:r>
-              <a:rPr lang="en-US" sz="1250" dirty="0">
-                <a:solidFill>
-                  <a:srgbClr val="1A1A2E"/>
-                </a:solidFill>
-                <a:latin typeface="Calibri" pitchFamily="34" charset="0"/>
-                <a:ea typeface="Calibri" pitchFamily="34" charset="-122"/>
-                <a:cs typeface="Calibri" pitchFamily="34" charset="-120"/>
-              </a:rPr>
-              <a:t>I am the designer, the founder and the researcher, managed by external labels, standard instruments and a reproducible harness.</a:t>
-            </a:r>
-            <a:endParaRPr lang="en-US" sz="1250" dirty="0"/>
-          </a:p>
-        </p:txBody>
-      </p:sp>
-      <p:sp>
-        <p:nvSpPr>
-          <p:cNvPr id="7" name="Text 5"/>
-          <p:cNvSpPr/>
-          <p:nvPr/>
-        </p:nvSpPr>
-        <p:spPr>
-          <a:xfrm>
-            <a:off x="6309360" y="1371600"/>
-            <a:ext cx="5303520" cy="310896"/>
-          </a:xfrm>
-          <a:prstGeom prst="rect">
-            <a:avLst/>
-          </a:prstGeom>
-          <a:noFill/>
-          <a:ln/>
-        </p:spPr>
-        <p:txBody>
-          <a:bodyPr wrap="square" rtlCol="0" anchor="ctr"/>
-          <a:lstStyle/>
-          <a:p>
-            <a:pPr indent="0" marL="0">
-              <a:buNone/>
-            </a:pPr>
-            <a:r>
-              <a:rPr lang="en-US" sz="1700" b="1" dirty="0">
-                <a:solidFill>
-                  <a:srgbClr val="1E2761"/>
-                </a:solidFill>
-                <a:latin typeface="Cambria" pitchFamily="34" charset="0"/>
-                <a:ea typeface="Cambria" pitchFamily="34" charset="-122"/>
-                <a:cs typeface="Cambria" pitchFamily="34" charset="-120"/>
-              </a:rPr>
-              <a:t>Next, in order of value</a:t>
-            </a:r>
-            <a:endParaRPr lang="en-US" sz="1700" dirty="0"/>
-          </a:p>
-        </p:txBody>
-      </p:sp>
-      <p:sp>
-        <p:nvSpPr>
-          <p:cNvPr id="8" name="Text 6"/>
-          <p:cNvSpPr/>
-          <p:nvPr/>
-        </p:nvSpPr>
-        <p:spPr>
-          <a:xfrm>
-            <a:off x="6492240" y="1755648"/>
-            <a:ext cx="5120640" cy="4297680"/>
-          </a:xfrm>
-          <a:prstGeom prst="rect">
-            <a:avLst/>
-          </a:prstGeom>
-          <a:noFill/>
-          <a:ln/>
-        </p:spPr>
-        <p:txBody>
-          <a:bodyPr wrap="square" rtlCol="0" anchor="ctr"/>
-          <a:lstStyle/>
-          <a:p>
-            <a:pPr marL="342900" indent="-342900">
-              <a:spcAft>
-                <a:spcPts val="700"/>
-              </a:spcAft>
-              <a:buSzPct val="100000"/>
-              <a:buChar char="•"/>
-            </a:pPr>
-            <a:r>
-              <a:rPr lang="en-US" sz="1250" dirty="0">
-                <a:solidFill>
-                  <a:srgbClr val="1A1A2E"/>
-                </a:solidFill>
-                <a:latin typeface="Calibri" pitchFamily="34" charset="0"/>
-                <a:ea typeface="Calibri" pitchFamily="34" charset="-122"/>
-                <a:cs typeface="Calibri" pitchFamily="34" charset="-120"/>
-              </a:rPr>
-              <a:t>One live outcome contract on real data, scored by interrupted time series at the action date, then synthetic difference in differences as panels accumulate (Arkhangelsky et al., 2021). The estimator is already built and tested.</a:t>
-            </a:r>
-            <a:endParaRPr lang="en-US" sz="1250" dirty="0"/>
-          </a:p>
-          <a:p>
-            <a:pPr marL="342900" indent="-342900">
-              <a:spcAft>
-                <a:spcPts val="700"/>
-              </a:spcAft>
-              <a:buSzPct val="100000"/>
-              <a:buChar char="•"/>
-            </a:pPr>
-            <a:r>
-              <a:rPr lang="en-US" sz="1250" dirty="0">
-                <a:solidFill>
-                  <a:srgbClr val="1A1A2E"/>
-                </a:solidFill>
-                <a:latin typeface="Calibri" pitchFamily="34" charset="0"/>
-                <a:ea typeface="Calibri" pitchFamily="34" charset="-122"/>
-                <a:cs typeface="Calibri" pitchFamily="34" charset="-120"/>
-              </a:rPr>
-              <a:t>The practitioner study. Twelve to fifteen interviews and task sessions, with the survey for breadth.</a:t>
-            </a:r>
-            <a:endParaRPr lang="en-US" sz="1250" dirty="0"/>
-          </a:p>
-          <a:p>
-            <a:pPr marL="342900" indent="-342900">
-              <a:spcAft>
-                <a:spcPts val="700"/>
-              </a:spcAft>
-              <a:buSzPct val="100000"/>
-              <a:buChar char="•"/>
-            </a:pPr>
-            <a:r>
-              <a:rPr lang="en-US" sz="1250" dirty="0">
-                <a:solidFill>
-                  <a:srgbClr val="1A1A2E"/>
-                </a:solidFill>
-                <a:latin typeface="Calibri" pitchFamily="34" charset="0"/>
-                <a:ea typeface="Calibri" pitchFamily="34" charset="-122"/>
-                <a:cs typeface="Calibri" pitchFamily="34" charset="-120"/>
-              </a:rPr>
-              <a:t>A human rating with recorded provenance on a new sample of the risk seeds, and a first one on the golden set, with rater role, dates and AI access recorded: the existing kappa's independent human provenance is unverified, and repeats on the same forty items would not be replication.</a:t>
-            </a:r>
-            <a:endParaRPr lang="en-US" sz="1250" dirty="0"/>
-          </a:p>
-          <a:p>
-            <a:pPr marL="342900" indent="-342900">
-              <a:spcAft>
-                <a:spcPts val="700"/>
-              </a:spcAft>
-              <a:buSzPct val="100000"/>
-              <a:buChar char="•"/>
-            </a:pPr>
-            <a:r>
-              <a:rPr lang="en-US" sz="1250" dirty="0">
-                <a:solidFill>
-                  <a:srgbClr val="1A1A2E"/>
-                </a:solidFill>
-                <a:latin typeface="Calibri" pitchFamily="34" charset="0"/>
-                <a:ea typeface="Calibri" pitchFamily="34" charset="-122"/>
-                <a:cs typeface="Calibri" pitchFamily="34" charset="-120"/>
-              </a:rPr>
-              <a:t>Score theme and recommended action by the semantic agreement procedure, closing the last two of six gold fields.</a:t>
-            </a:r>
-            <a:endParaRPr lang="en-US" sz="1250" dirty="0"/>
-          </a:p>
-          <a:p>
-            <a:pPr marL="342900" indent="-342900">
-              <a:spcAft>
-                <a:spcPts val="700"/>
-              </a:spcAft>
-              <a:buSzPct val="100000"/>
-              <a:buChar char="•"/>
-            </a:pPr>
-            <a:r>
-              <a:rPr lang="en-US" sz="1250" dirty="0">
-                <a:solidFill>
-                  <a:srgbClr val="1A1A2E"/>
-                </a:solidFill>
-                <a:latin typeface="Calibri" pitchFamily="34" charset="0"/>
-                <a:ea typeface="Calibri" pitchFamily="34" charset="-122"/>
-                <a:cs typeface="Calibri" pitchFamily="34" charset="-120"/>
-              </a:rPr>
-              <a:t>Score routing in the free-form production condition, so the numbers describe the deployed system.</a:t>
-            </a:r>
-            <a:endParaRPr lang="en-US" sz="1250" dirty="0"/>
-          </a:p>
-          <a:p>
-            <a:pPr marL="342900" indent="-342900">
-              <a:spcAft>
-                <a:spcPts val="700"/>
-              </a:spcAft>
-              <a:buSzPct val="100000"/>
-              <a:buChar char="•"/>
-            </a:pPr>
-            <a:r>
-              <a:rPr lang="en-US" sz="1250" dirty="0">
-                <a:solidFill>
-                  <a:srgbClr val="1A1A2E"/>
-                </a:solidFill>
-                <a:latin typeface="Calibri" pitchFamily="34" charset="0"/>
-                <a:ea typeface="Calibri" pitchFamily="34" charset="-122"/>
-                <a:cs typeface="Calibri" pitchFamily="34" charset="-120"/>
-              </a:rPr>
-              <a:t>Relabel the new multi-market data to gold standard, which would break the language and sector confound.</a:t>
-            </a:r>
-            <a:endParaRPr lang="en-US" sz="1250" dirty="0"/>
+              <a:t>Also open: score theme and action by the semantic-agreement procedure (not executed), score routing free-form, relabel the held-out corpora to gold.</a:t>
+            </a:r>
+            <a:endParaRPr lang="en-US" sz="1200" dirty="0"/>
           </a:p>
         </p:txBody>
       </p:sp>
@@ -12370,7 +12370,7 @@
                 <a:ea typeface="Calibri" pitchFamily="34" charset="-122"/>
                 <a:cs typeface="Calibri" pitchFamily="34" charset="-120"/>
               </a:rPr>
-              <a:t>Section 6.5 still calls one live outcome contract the most important next step. Is the thesis defensible with the contract demonstrated and perceived but not measured, or do I force one small live measurement in at the cost of interview time?</a:t>
+              <a:t>Section 6.5 lists one live outcome contract among its five items. Is the thesis defensible with the contract implemented and tested on simulated outcome data but not measured live, or do I force one small live measurement in at the cost of interview time?</a:t>
             </a:r>
             <a:endParaRPr lang="en-US" sz="1200" dirty="0"/>
           </a:p>
@@ -12475,7 +12475,7 @@
                 <a:ea typeface="Calibri" pitchFamily="34" charset="-122"/>
                 <a:cs typeface="Calibri" pitchFamily="34" charset="-120"/>
               </a:rPr>
-              <a:t>The learned model shows an observed 32.6-point gap of its own on eight German-source signals, reported descriptively because within-predictor tests do not rank predictors. Is that enough as written, or do I need natural German-language data first? That decides whether relabelling the new corpora is required work.</a:t>
+              <a:t>The learned model escalates 5 of 8 German-source against 39 of 41 English-source positives, reported descriptively because within-predictor tests do not rank predictors. Is that enough as written, or do I need natural German-language data first? That decides whether relabelling the new corpora is required work.</a:t>
             </a:r>
             <a:endParaRPr lang="en-US" sz="1200" dirty="0"/>
           </a:p>
@@ -13639,7 +13639,7 @@
                 <a:ea typeface="Calibri" pitchFamily="34" charset="-122"/>
                 <a:cs typeface="Calibri" pitchFamily="34" charset="-120"/>
               </a:rPr>
-              <a:t>Built and running</a:t>
+              <a:t>Built, tested, partly deployed</a:t>
             </a:r>
             <a:endParaRPr lang="en-US" sz="1450" dirty="0"/>
           </a:p>
@@ -13678,7 +13678,7 @@
                 <a:ea typeface="Calibri" pitchFamily="34" charset="-122"/>
                 <a:cs typeface="Calibri" pitchFamily="34" charset="-120"/>
               </a:rPr>
-              <a:t>The artifact runs the whole loop in production. Signal in, insight, approved action out to Jira and Slack, outcome measured against a contract, learning kept and retrieved on the next decision.</a:t>
+              <a:t>In production since July 2026: signal in, insight, approved action out to Jira and Slack. The outcome contracts, loop verdicts and learning memory are implemented and regression-tested at September commits, not deployed at the time of writing.</a:t>
             </a:r>
             <a:endParaRPr lang="en-US" sz="1200" dirty="0"/>
           </a:p>
@@ -13744,7 +13744,7 @@
                 <a:ea typeface="Calibri" pitchFamily="34" charset="-122"/>
                 <a:cs typeface="Calibri" pitchFamily="34" charset="-120"/>
               </a:rPr>
-              <a:t>Measured</a:t>
+              <a:t>Measured (bounded)</a:t>
             </a:r>
             <a:endParaRPr lang="en-US" sz="1450" dirty="0"/>
           </a:p>
@@ -13783,7 +13783,7 @@
                 <a:ea typeface="Calibri" pitchFamily="34" charset="-122"/>
                 <a:cs typeface="Calibri" pitchFamily="34" charset="-120"/>
               </a:rPr>
-              <a:t>The quantitative evaluation is complete on 188 real seed-labelled signals. Three predictors now sit on one gold standard, with paired significance tests between all three.</a:t>
+              <a:t>The quantitative evaluation is complete on 188 paraphrased signals with reference labels of stated provenance. Five predictors sit on one gold standard, with paired McNemar tests corrected in one retrospective Holm family per task.</a:t>
             </a:r>
             <a:endParaRPr lang="en-US" sz="1200" dirty="0"/>
           </a:p>
@@ -13993,7 +13993,7 @@
                 <a:ea typeface="Calibri" pitchFamily="34" charset="-122"/>
                 <a:cs typeface="Calibri" pitchFamily="34" charset="-120"/>
               </a:rPr>
-              <a:t>The practitioner study is still at zero interviews, and the outcome data behind the learning loop is still simulated. Both sit on the critical path to submission.</a:t>
+              <a:t>The practitioner study was not conducted, and the outcome data behind the learning loop is still simulated. Both sit on the critical path to submission.</a:t>
             </a:r>
             <a:endParaRPr lang="en-US" sz="1200" dirty="0"/>
           </a:p>
@@ -14398,7 +14398,7 @@
                 <a:ea typeface="Calibri" pitchFamily="34" charset="-122"/>
                 <a:cs typeface="Calibri" pitchFamily="34" charset="-120"/>
               </a:rPr>
-              <a:t>188 real public signals, paraphrased and de-identified. Fintech 67, food delivery 82, B2B industrial 39. Source language English 102, German 84. Seed labels authored independently of the artifact.</a:t>
+              <a:t>188 English paraphrases of public reviews, de-identified. Fintech 67, food delivery 82, B2B industrial 39. Source language English 102, German 84. Seed labels drafted by a language-model assistant on 21 June 2026 and used as delivered; neither gold standard is human-labelled.</a:t>
             </a:r>
             <a:endParaRPr lang="en-US" sz="1300" dirty="0"/>
           </a:p>
@@ -14503,7 +14503,7 @@
                 <a:ea typeface="Calibri" pitchFamily="34" charset="-122"/>
                 <a:cs typeface="Calibri" pitchFamily="34" charset="-120"/>
               </a:rPr>
-              <a:t>100 curated bilingual cases committed in the repository, with published metrics served from the model card. Reported as convergent evidence and never merged into the tables, because the gold standards differ.</a:t>
+              <a:t>100 curated bilingual cases committed in the repository, with published metrics served from the model card. A development and validation benchmark co-developed with the artifact, not independent confirmation, and never merged into the tables, because the gold standards differ.</a:t>
             </a:r>
             <a:endParaRPr lang="en-US" sz="1300" dirty="0"/>
           </a:p>
@@ -15143,7 +15143,7 @@
                 <a:ea typeface="Calibri" pitchFamily="34" charset="-122"/>
                 <a:cs typeface="Calibri" pitchFamily="34" charset="-120"/>
               </a:rPr>
-              <a:t>Diagrams re-rendered from the September sources, which draw the deployed graph and tables. The numbers above are the verified ones.</a:t>
+              <a:t>Diagrams re-rendered from the September sources, which draw the build at the September commits; the serving image predates them (§4.1). The counts above are read from the repository.</a:t>
             </a:r>
             <a:endParaRPr lang="en-US" sz="1300" dirty="0"/>
           </a:p>
@@ -15643,7 +15643,7 @@
                 <a:ea typeface="Calibri" pitchFamily="34" charset="-122"/>
                 <a:cs typeface="Calibri" pitchFamily="34" charset="-120"/>
               </a:rPr>
-              <a:t>actions_log binds one to one to outcome_contracts at creation, and outcome_measurements grade closure from operational to customer to outcome. A closed action is a row with evidence behind it.</a:t>
+              <a:t>actions_log binds one to one to outcome_contracts at creation, and outcome_measurements carry each checkpoint reading with its grade (D, E if manual) beside the fitted estimate (C). The loop verdict is issued on target attainment, never on dispatch; a closed action is a row with evidence behind it.</a:t>
             </a:r>
             <a:endParaRPr lang="en-US" sz="1200" dirty="0"/>
           </a:p>
@@ -16415,7 +16415,7 @@
                 <a:ea typeface="Calibri" pitchFamily="34" charset="-122"/>
                 <a:cs typeface="Calibri" pitchFamily="34" charset="-120"/>
               </a:rPr>
-              <a:t>Decayed-confidence retrieval into new decisions, in the case-based reasoning lineage. Only human-validated conclusions are retrieval-eligible, so an unvalidated causal claim cannot launder itself into the next recommendation. Cost: retrieval quality gates usefulness.</a:t>
+              <a:t>Decayed-confidence retrieval into new decisions, in the case-based reasoning lineage. Only human-validated conclusions are retrieval-eligible, so an unvalidated causal claim cannot launder itself into the next recommendation. Cost: retrieval quality bounds the benefit, which is untested.</a:t>
             </a:r>
             <a:endParaRPr lang="en-US" sz="1200" dirty="0"/>
           </a:p>
@@ -17182,7 +17182,7 @@
                 <a:ea typeface="Calibri" pitchFamily="34" charset="-122"/>
                 <a:cs typeface="Calibri" pitchFamily="34" charset="-120"/>
               </a:rPr>
-              <a:t>SMB agents that trigger real work, and broad connector coverage. No approval gates and no outcome measurement that could be verified.</a:t>
+              <a:t>SMB agents that trigger work, broad connectors. Outcome measurement not documented in the sources reviewed; autonomy contradicted.</a:t>
             </a:r>
             <a:endParaRPr lang="en-US" sz="1250" dirty="0"/>
           </a:p>
@@ -17243,7 +17243,7 @@
                 <a:ea typeface="Calibri" pitchFamily="34" charset="-122"/>
                 <a:cs typeface="Calibri" pitchFamily="34" charset="-120"/>
               </a:rPr>
-              <a:t>The unclaimed combination</a:t>
+              <a:t>The combination no reviewed source holds</a:t>
             </a:r>
             <a:endParaRPr lang="en-US" sz="1400" dirty="0"/>
           </a:p>
@@ -17282,7 +17282,7 @@
                 <a:ea typeface="Calibri" pitchFamily="34" charset="-122"/>
                 <a:cs typeface="Calibri" pitchFamily="34" charset="-120"/>
               </a:rPr>
-              <a:t>Outcome contracts with verified closure</a:t>
+              <a:t>Outcome contracts measured against a contract, with explicit grades</a:t>
             </a:r>
             <a:endParaRPr lang="en-US" sz="1550" dirty="0"/>
           </a:p>
@@ -17455,7 +17455,7 @@
                 <a:ea typeface="Calibri" pitchFamily="34" charset="-122"/>
                 <a:cs typeface="Calibri" pitchFamily="34" charset="-120"/>
               </a:rPr>
-              <a:t>Gartner (2025) expects more than 40% of agentic AI projects to be cancelled by 2027, for unclear business value and inadequate risk controls. Those are the two this design answers.</a:t>
+              <a:t>Gartner (2025) expects many agentic AI projects to be cancelled for unclear business value and inadequate risk controls. Those are the two a draft-and-approve loop is built to avoid.</a:t>
             </a:r>
             <a:endParaRPr lang="en-US" sz="1300" dirty="0"/>
           </a:p>
@@ -17733,7 +17733,7 @@
               <a:buNone/>
             </a:pPr>
             <a:r>
-              <a:rPr lang="en-US" sz="1300" dirty="0">
+              <a:rPr lang="en-US" sz="1250" dirty="0">
                 <a:solidFill>
                   <a:srgbClr val="1A1A2E"/>
                 </a:solidFill>
@@ -17741,9 +17741,9 @@
                 <a:ea typeface="Calibri" pitchFamily="34" charset="-122"/>
                 <a:cs typeface="Calibri" pitchFamily="34" charset="-120"/>
               </a:rPr>
-              <a:t>How can an artifact make actions governed, executed and verified to have closed, and turn what worked into learning that is reused?</a:t>
-            </a:r>
-            <a:endParaRPr lang="en-US" sz="1300" dirty="0"/>
+              <a:t>How can an artifact make actions governed, executed and measured for closure against a contract, with reusable learning captured? Answered by design and demonstration.</a:t>
+            </a:r>
+            <a:endParaRPr lang="en-US" sz="1250" dirty="0"/>
           </a:p>
         </p:txBody>
       </p:sp>
@@ -17838,7 +17838,7 @@
               <a:buNone/>
             </a:pPr>
             <a:r>
-              <a:rPr lang="en-US" sz="1300" dirty="0">
+              <a:rPr lang="en-US" sz="1250" dirty="0">
                 <a:solidFill>
                   <a:srgbClr val="1A1A2E"/>
                 </a:solidFill>
@@ -17846,9 +17846,9 @@
                 <a:ea typeface="Calibri" pitchFamily="34" charset="-122"/>
                 <a:cs typeface="Calibri" pitchFamily="34" charset="-120"/>
               </a:rPr>
-              <a:t>What design lets automated action meet the EU AI Act and GDPR without slowing practitioners more than the risk warrants?</a:t>
-            </a:r>
-            <a:endParaRPr lang="en-US" sz="1300" dirty="0"/>
+              <a:t>What design principles enable governed action-taking under the EU AI Act and GDPR, and how do practitioners experience the friction? Controls tested; friction clause not conducted.</a:t>
+            </a:r>
+            <a:endParaRPr lang="en-US" sz="1250" dirty="0"/>
           </a:p>
         </p:txBody>
       </p:sp>
@@ -17912,7 +17912,7 @@
                 <a:ea typeface="Calibri" pitchFamily="34" charset="-122"/>
                 <a:cs typeface="Calibri" pitchFamily="34" charset="-120"/>
               </a:rPr>
-              <a:t>RQ3a. Accuracy</a:t>
+              <a:t>RQ3a. Agreement</a:t>
             </a:r>
             <a:endParaRPr lang="en-US" sz="1450" dirty="0"/>
           </a:p>
@@ -17943,7 +17943,7 @@
               <a:buNone/>
             </a:pPr>
             <a:r>
-              <a:rPr lang="en-US" sz="1300" dirty="0">
+              <a:rPr lang="en-US" sz="1250" dirty="0">
                 <a:solidFill>
                   <a:srgbClr val="1A1A2E"/>
                 </a:solidFill>
@@ -17951,9 +17951,9 @@
                 <a:ea typeface="Calibri" pitchFamily="34" charset="-122"/>
                 <a:cs typeface="Calibri" pitchFamily="34" charset="-120"/>
               </a:rPr>
-              <a:t>How accurately does AI enrichment and routing reproduce reference labels on real feedback, across sectors? Answered: three predictors on one gold standard.</a:t>
-            </a:r>
-            <a:endParaRPr lang="en-US" sz="1300" dirty="0"/>
+              <a:t>How closely does the enrichment pipeline agree with reference labels on paraphrased public reviews? Measured (bounded): five predictors on one gold standard.</a:t>
+            </a:r>
+            <a:endParaRPr lang="en-US" sz="1250" dirty="0"/>
           </a:p>
         </p:txBody>
       </p:sp>
@@ -18048,7 +18048,7 @@
               <a:buNone/>
             </a:pPr>
             <a:r>
-              <a:rPr lang="en-US" sz="1300" dirty="0">
+              <a:rPr lang="en-US" sz="1250" dirty="0">
                 <a:solidFill>
                   <a:srgbClr val="1A1A2E"/>
                 </a:solidFill>
@@ -18056,9 +18056,9 @@
                 <a:ea typeface="Calibri" pitchFamily="34" charset="-122"/>
                 <a:cs typeface="Calibri" pitchFamily="34" charset="-120"/>
               </a:rPr>
-              <a:t>Is triage reliability equal across language strata, defined here by the source review's language? Answered, and tightly bounded.</a:t>
-            </a:r>
-            <a:endParaRPr lang="en-US" sz="1300" dirty="0"/>
+              <a:t>Does the choice of triage method change whose problems are escalated, across source-language strata? Answered descriptively; no ranking, no language effect.</a:t>
+            </a:r>
+            <a:endParaRPr lang="en-US" sz="1250" dirty="0"/>
           </a:p>
         </p:txBody>
       </p:sp>
@@ -18071,11 +18071,11 @@
         <p:spPr>
           <a:xfrm>
             <a:off x="548640" y="4041648"/>
-            <a:ext cx="11064240" cy="960120"/>
+            <a:ext cx="11064240" cy="1078992"/>
           </a:xfrm>
           <a:prstGeom prst="roundRect">
             <a:avLst>
-              <a:gd name="adj" fmla="val 5714"/>
+              <a:gd name="adj" fmla="val 5085"/>
             </a:avLst>
           </a:prstGeom>
           <a:solidFill>
@@ -18122,7 +18122,7 @@
                 <a:ea typeface="Calibri" pitchFamily="34" charset="-122"/>
                 <a:cs typeface="Calibri" pitchFamily="34" charset="-120"/>
               </a:rPr>
-              <a:t>RQ4. Practitioner value</a:t>
+              <a:t>RQ4. Practitioner experience: not conducted</a:t>
             </a:r>
             <a:endParaRPr lang="en-US" sz="1450" dirty="0"/>
           </a:p>
@@ -18137,7 +18137,7 @@
         <p:spPr>
           <a:xfrm>
             <a:off x="713232" y="4425696"/>
-            <a:ext cx="10735056" cy="466344"/>
+            <a:ext cx="10735056" cy="585216"/>
           </a:xfrm>
           <a:prstGeom prst="rect">
             <a:avLst/>
@@ -18153,7 +18153,7 @@
               <a:buNone/>
             </a:pPr>
             <a:r>
-              <a:rPr lang="en-US" sz="1300" dirty="0">
+              <a:rPr lang="en-US" sz="1200" dirty="0">
                 <a:solidFill>
                   <a:srgbClr val="1A1A2E"/>
                 </a:solidFill>
@@ -18161,9 +18161,9 @@
                 <a:ea typeface="Calibri" pitchFamily="34" charset="-122"/>
                 <a:cs typeface="Calibri" pitchFamily="34" charset="-120"/>
               </a:rPr>
-              <a:t>How do practitioners judge usefulness, usability and trust? Twelve to fifteen interviews and task sessions with SUS and TAM, plus an anonymous survey for breadth. Not started, and it is the critical path.</a:t>
-            </a:r>
-            <a:endParaRPr lang="en-US" sz="1300" dirty="0"/>
+              <a:t>How do practitioners assess the artifact's usefulness, usability and trustworthiness? Not conducted at the time of writing; the protocol, instruments and pre-registered tiers are retained (Appendix A; §5B). Interviews: reported as designed at twelve or more, as descriptive ranges at six to eleven, as a walkthrough below six. Survey: verdicts only at n ≥ 40, descriptive at 10 to 39, a count below 10.</a:t>
+            </a:r>
+            <a:endParaRPr lang="en-US" sz="1200" dirty="0"/>
           </a:p>
         </p:txBody>
       </p:sp>
@@ -19069,7 +19069,7 @@
                 <a:ea typeface="Calibri" pitchFamily="34" charset="-122"/>
                 <a:cs typeface="Calibri" pitchFamily="34" charset="-120"/>
               </a:rPr>
-              <a:t>Every count on this page comes from one shared status function, so the numbers reconcile by construction rather than by discipline. That is the same commitment the thesis makes about closure: an outcome contract is a foreign key at creation, not a status flag someone remembers to set. The Chapter 4 diagrams were re-rendered in September from the deployed build; the screenshots are from the 16 July build, before this redesign landed on 13 August.</a:t>
+              <a:t>Every count on this page comes from one shared status function, so the numbers reconcile by construction rather than by discipline. That is the same commitment the thesis makes about closure: an outcome contract is a foreign key at creation, not a status flag someone remembers to set. The Chapter 4 diagrams draw the build at the September commits, which the serving image predates (§4.1); the screenshots are from the 16 July build.</a:t>
             </a:r>
             <a:endParaRPr lang="en-US" sz="1350" dirty="0"/>
           </a:p>
@@ -19308,7 +19308,7 @@
               <a:buNone/>
             </a:pPr>
             <a:r>
-              <a:rPr lang="en-US" sz="1300" dirty="0">
+              <a:rPr lang="en-US" sz="1200" dirty="0">
                 <a:solidFill>
                   <a:srgbClr val="1A1A2E"/>
                 </a:solidFill>
@@ -19316,9 +19316,9 @@
                 <a:ea typeface="Calibri" pitchFamily="34" charset="-122"/>
                 <a:cs typeface="Calibri" pitchFamily="34" charset="-120"/>
               </a:rPr>
-              <a:t>Every consequential action is a draft until a person approves it: the graph's approval node is a LangGraph interrupt, and no code path reaches an external effect without a recorded approval. Authority is graduated by consequence class, from draft to single approval to four-eyes. Designed past the Article requirement, because awareness alone does not de-bias an overseer (Laux and Ruschemeier, 2025; Siebert et al., 2023).</a:t>
-            </a:r>
-            <a:endParaRPr lang="en-US" sz="1300" dirty="0"/>
+              <a:t>Every action is a draft until a person approves it: the approval node is a LangGraph interrupt, and no code path reaches an external effect without a recorded approval. Authority is graduated by consequence class, up to four-eyes. The gate controls false positives; it cannot recover escalation-worthy signals ranked too low (22 of 50 on the production rubric). Awareness alone does not de-bias an overseer (Laux and Ruschemeier, 2025).</a:t>
+            </a:r>
+            <a:endParaRPr lang="en-US" sz="1200" dirty="0"/>
           </a:p>
         </p:txBody>
       </p:sp>
@@ -19413,7 +19413,7 @@
               <a:buNone/>
             </a:pPr>
             <a:r>
-              <a:rPr lang="en-US" sz="1300" dirty="0">
+              <a:rPr lang="en-US" sz="1200" dirty="0">
                 <a:solidFill>
                   <a:srgbClr val="1A1A2E"/>
                 </a:solidFill>
@@ -19423,7 +19423,7 @@
               </a:rPr>
               <a:t>Every action records the rule, the parameters, the executor and the result. The evidence pack is hashed at decision time, so evidence that changed afterwards is provable rather than arguable. Four-eyes approval is available for consequential actions.</a:t>
             </a:r>
-            <a:endParaRPr lang="en-US" sz="1300" dirty="0"/>
+            <a:endParaRPr lang="en-US" sz="1200" dirty="0"/>
           </a:p>
         </p:txBody>
       </p:sp>
@@ -19518,7 +19518,7 @@
               <a:buNone/>
             </a:pPr>
             <a:r>
-              <a:rPr lang="en-US" sz="1300" dirty="0">
+              <a:rPr lang="en-US" sz="1200" dirty="0">
                 <a:solidFill>
                   <a:srgbClr val="1A1A2E"/>
                 </a:solidFill>
@@ -19528,7 +19528,7 @@
               </a:rPr>
               <a:t>AI output carries its provenance, and human editorial review is the exemption mechanism, which makes the approval gate itself the compliance artefact. The 2026 Digital Omnibus moved the Annex III high-risk duties to December 2027 and left Article 50 on its August 2026 schedule.</a:t>
             </a:r>
-            <a:endParaRPr lang="en-US" sz="1300" dirty="0"/>
+            <a:endParaRPr lang="en-US" sz="1200" dirty="0"/>
           </a:p>
         </p:txBody>
       </p:sp>
@@ -19623,7 +19623,7 @@
               <a:buNone/>
             </a:pPr>
             <a:r>
-              <a:rPr lang="en-US" sz="1300" dirty="0">
+              <a:rPr lang="en-US" sz="1200" dirty="0">
                 <a:solidFill>
                   <a:srgbClr val="1A1A2E"/>
                 </a:solidFill>
@@ -19633,7 +19633,7 @@
               </a:rPr>
               <a:t>The model layer is provider agnostic, so it runs hosted, behind an EU gateway, or self-hosted. Direct identifiers are redacted before any text reaches a model; retention limits and workspace isolation are enforced in Postgres below the application. Sentiment on text is not emotion recognition under Article 3(39), which is biometric.</a:t>
             </a:r>
-            <a:endParaRPr lang="en-US" sz="1300" dirty="0"/>
+            <a:endParaRPr lang="en-US" sz="1200" dirty="0"/>
           </a:p>
         </p:txBody>
       </p:sp>
@@ -19645,8 +19645,8 @@
         </p:nvSpPr>
         <p:spPr>
           <a:xfrm>
-            <a:off x="548640" y="5715000"/>
-            <a:ext cx="11064240" cy="411480"/>
+            <a:off x="548640" y="5596128"/>
+            <a:ext cx="11064240" cy="713232"/>
           </a:xfrm>
           <a:prstGeom prst="rect">
             <a:avLst/>
@@ -19670,7 +19670,7 @@
                 <a:ea typeface="Calibri" pitchFamily="34" charset="-122"/>
                 <a:cs typeface="Calibri" pitchFamily="34" charset="-120"/>
               </a:rPr>
-              <a:t>Closure has three levels. The ticket is done, the reporter is told, the metric moved. Closed means the third.</a:t>
+              <a:t>Closure has three meanings: delivery, target attainment measured against a contract, attributed improvement. The loop verdict is issued on attainment; attribution is never asserted.</a:t>
             </a:r>
             <a:endParaRPr lang="en-US" sz="1500" dirty="0"/>
           </a:p>
@@ -19886,7 +19886,7 @@
               <a:buChar char="•"/>
             </a:pPr>
             <a:r>
-              <a:rPr lang="en-US" sz="1350" dirty="0">
+              <a:rPr lang="en-US" sz="1300" dirty="0">
                 <a:solidFill>
                   <a:srgbClr val="1A1A2E"/>
                 </a:solidFill>
@@ -19894,9 +19894,9 @@
                 <a:ea typeface="Calibri" pitchFamily="34" charset="-122"/>
                 <a:cs typeface="Calibri" pitchFamily="34" charset="-120"/>
               </a:rPr>
-              <a:t>Paired McNemar tests between all three predictors on identical items. The contextual path leads the learned model on sentiment (p = 0.029) and does not separate from it on severity (p = 0.644).</a:t>
-            </a:r>
-            <a:endParaRPr lang="en-US" sz="1350" dirty="0"/>
+              <a:t>Paired McNemar tests on identical items, one retrospective Holm family per task. The generic prompt's sentiment lead over TF-IDF is stable across repeated runs on the same items and not significant after the correction (0.174); on risk the two are not distinguishable (0.644).</a:t>
+            </a:r>
+            <a:endParaRPr lang="en-US" sz="1300" dirty="0"/>
           </a:p>
           <a:p>
             <a:pPr marL="342900" indent="-342900">
@@ -19907,7 +19907,7 @@
               <a:buChar char="•"/>
             </a:pPr>
             <a:r>
-              <a:rPr lang="en-US" sz="1350" dirty="0">
+              <a:rPr lang="en-US" sz="1300" dirty="0">
                 <a:solidFill>
                   <a:srgbClr val="1A1A2E"/>
                 </a:solidFill>
@@ -19915,9 +19915,9 @@
                 <a:ea typeface="Calibri" pitchFamily="34" charset="-122"/>
                 <a:cs typeface="Calibri" pitchFamily="34" charset="-120"/>
               </a:rPr>
-              <a:t>The learned model joined the escalation equity table: 62.5% against 95.1% across the two strata, a 32.6-point gap on eight German-source items; descriptive, no ranking.</a:t>
-            </a:r>
-            <a:endParaRPr lang="en-US" sz="1350" dirty="0"/>
+              <a:t>The learned model joined the escalation equity table: 5 of 8 German-source against 39 of 41 English-source positives; descriptive, no ranking.</a:t>
+            </a:r>
+            <a:endParaRPr lang="en-US" sz="1300" dirty="0"/>
           </a:p>
           <a:p>
             <a:pPr marL="342900" indent="-342900">
@@ -19928,7 +19928,7 @@
               <a:buChar char="•"/>
             </a:pPr>
             <a:r>
-              <a:rPr lang="en-US" sz="1350" dirty="0">
+              <a:rPr lang="en-US" sz="1300" dirty="0">
                 <a:solidFill>
                   <a:srgbClr val="1A1A2E"/>
                 </a:solidFill>
@@ -19938,7 +19938,7 @@
               </a:rPr>
               <a:t>Three more datasets collected and run on 21 August, held outside the frozen 188-signal corpus: Vodafone Germany, Delivery Hero across eight EU markets, German consumer banks.</a:t>
             </a:r>
-            <a:endParaRPr lang="en-US" sz="1350" dirty="0"/>
+            <a:endParaRPr lang="en-US" sz="1300" dirty="0"/>
           </a:p>
           <a:p>
             <a:pPr marL="342900" indent="-342900">
@@ -19949,7 +19949,7 @@
               <a:buChar char="•"/>
             </a:pPr>
             <a:r>
-              <a:rPr lang="en-US" sz="1350" dirty="0">
+              <a:rPr lang="en-US" sz="1300" dirty="0">
                 <a:solidFill>
                   <a:srgbClr val="1A1A2E"/>
                 </a:solidFill>
@@ -19957,9 +19957,9 @@
                 <a:ea typeface="Calibri" pitchFamily="34" charset="-122"/>
                 <a:cs typeface="Calibri" pitchFamily="34" charset="-120"/>
               </a:rPr>
-              <a:t>An AI-verbatim detector measured on 6,740 real texts and then refused, because it flags 15% of genuine reviews and 3x more in some languages than others.</a:t>
-            </a:r>
-            <a:endParaRPr lang="en-US" sz="1350" dirty="0"/>
+              <a:t>An AI-verbatim detector measured on 6,740 real texts and refused: it flags 15% of genuine reviews, 3x more in some languages than others.</a:t>
+            </a:r>
+            <a:endParaRPr lang="en-US" sz="1300" dirty="0"/>
           </a:p>
         </p:txBody>
       </p:sp>
@@ -20163,7 +20163,7 @@
                 <a:ea typeface="Calibri" pitchFamily="34" charset="-122"/>
                 <a:cs typeface="Calibri" pitchFamily="34" charset="-120"/>
               </a:rPr>
-              <a:t>One thing did not move. RQ4 is still at zero interviews, zero survey responses and no ethics sign-off, and that is what I most need from this meeting.</a:t>
+              <a:t>One thing did not move. RQ4 was not conducted: no interview, task session or survey response, and no ethics sign-off. That is what I most need from this meeting.</a:t>
             </a:r>
             <a:endParaRPr lang="en-US" sz="1550" dirty="0"/>
           </a:p>
@@ -21030,7 +21030,7 @@
                 <a:ea typeface="Calibri" pitchFamily="34" charset="-122"/>
                 <a:cs typeface="Calibri" pitchFamily="34" charset="-120"/>
               </a:rPr>
-              <a:t>Three predictors, one gold standard, paired tests on identical items</a:t>
+              <a:t>Five predictors, one gold standard, paired tests on identical items, one retrospective Holm family per task</a:t>
             </a:r>
             <a:endParaRPr lang="en-US" sz="1500" dirty="0"/>
           </a:p>
@@ -21217,7 +21217,7 @@
                           <a:ea typeface="Calibri" pitchFamily="34" charset="-122"/>
                           <a:cs typeface="Calibri" pitchFamily="34" charset="-120"/>
                         </a:rPr>
-                        <a:t>Severity macro-F1 (n = 106)</a:t>
+                        <a:t>Risk macro-F1 (n = 106)</a:t>
                       </a:r>
                       <a:endParaRPr lang="en-US" sz="1400" dirty="0">
                         <a:latin typeface="Calibri" charset="0"/>
@@ -21484,7 +21484,7 @@
                           <a:ea typeface="Calibri" pitchFamily="34" charset="-122"/>
                           <a:cs typeface="Calibri" pitchFamily="34" charset="-120"/>
                         </a:rPr>
-                        <a:t>TF-IDF and logistic regression</a:t>
+                        <a:t>TF-IDF + logistic regression (5-fold CV)</a:t>
                       </a:r>
                       <a:endParaRPr lang="en-US" sz="1400" dirty="0">
                         <a:latin typeface="Calibri" charset="0"/>
@@ -21681,7 +21681,7 @@
                           <a:ea typeface="Calibri" pitchFamily="34" charset="-122"/>
                           <a:cs typeface="Calibri" pitchFamily="34" charset="-120"/>
                         </a:rPr>
-                        <a:t>Contextual model path (generic prompt)</a:t>
+                        <a:t>Generic prompt, GLM-5.2 (run 0)</a:t>
                       </a:r>
                       <a:endParaRPr lang="en-US" sz="1400" dirty="0">
                         <a:latin typeface="Calibri" charset="0"/>
@@ -21878,7 +21878,7 @@
                           <a:ea typeface="Calibri" pitchFamily="34" charset="-122"/>
                           <a:cs typeface="Calibri" pitchFamily="34" charset="-120"/>
                         </a:rPr>
-                        <a:t>Production enrichment stage, same model</a:t>
+                        <a:t>Production stage, GLM-5.2</a:t>
                       </a:r>
                       <a:endParaRPr lang="en-US" sz="1400" dirty="0">
                         <a:latin typeface="Calibri" charset="0"/>
@@ -22075,7 +22075,7 @@
                           <a:ea typeface="Calibri" pitchFamily="34" charset="-122"/>
                           <a:cs typeface="Calibri" pitchFamily="34" charset="-120"/>
                         </a:rPr>
-                        <a:t>Production enrichment stage, production default</a:t>
+                        <a:t>Production stage, Mistral Small 4 (the production default)</a:t>
                       </a:r>
                       <a:endParaRPr lang="en-US" sz="1400" dirty="0">
                         <a:latin typeface="Calibri" charset="0"/>
@@ -22267,11 +22267,11 @@
         <p:spPr>
           <a:xfrm>
             <a:off x="548640" y="3310128"/>
-            <a:ext cx="6766560" cy="1188720"/>
+            <a:ext cx="6766560" cy="1463040"/>
           </a:xfrm>
           <a:prstGeom prst="roundRect">
             <a:avLst>
-              <a:gd name="adj" fmla="val 4615"/>
+              <a:gd name="adj" fmla="val 3750"/>
             </a:avLst>
           </a:prstGeom>
           <a:solidFill>
@@ -22318,7 +22318,7 @@
                 <a:ea typeface="Calibri" pitchFamily="34" charset="-122"/>
                 <a:cs typeface="Calibri" pitchFamily="34" charset="-120"/>
               </a:rPr>
-              <a:t>Paired McNemar on the same items, testing accuracy</a:t>
+              <a:t>Paired McNemar on the same items, Holm-corrected (m = 10)</a:t>
             </a:r>
             <a:endParaRPr lang="en-US" sz="1450" dirty="0"/>
           </a:p>
@@ -22333,7 +22333,7 @@
         <p:spPr>
           <a:xfrm>
             <a:off x="713232" y="3694176"/>
-            <a:ext cx="6437376" cy="694944"/>
+            <a:ext cx="6437376" cy="969264"/>
           </a:xfrm>
           <a:prstGeom prst="rect">
             <a:avLst/>
@@ -22357,7 +22357,7 @@
                 <a:ea typeface="Calibri" pitchFamily="34" charset="-122"/>
                 <a:cs typeface="Calibri" pitchFamily="34" charset="-120"/>
               </a:rPr>
-              <a:t>Both learned methods beat the floor (p &lt; 0.0001). The contextual path leads the learned model on sentiment in all four runs (p = 0.02–0.03; 0.09 Holm-corrected, so exploratory) and ties it on severity. The production stage is within three points on sentiment (p = 0.23), one severity level below the seeds, and compares configurations, not the model alone.</a:t>
+              <a:t>All four floor comparisons survive on sentiment (Holm &lt; 0.001). The generic prompt's sentiment lead over TF-IDF is stable across repeated runs on the same items and not significant after the retrospective correction (0.174); on risk the two are not distinguishable (0.644). The production stage sits three points below the generic prompt on sentiment (0.906) and one risk level below the seeds: a prompt/pipeline × run date contrast, not the model alone.</a:t>
             </a:r>
             <a:endParaRPr lang="en-US" sz="1050" dirty="0"/>
           </a:p>
@@ -22371,8 +22371,8 @@
         </p:nvSpPr>
         <p:spPr>
           <a:xfrm>
-            <a:off x="548640" y="4663440"/>
-            <a:ext cx="6766560" cy="1371600"/>
+            <a:off x="548640" y="4846320"/>
+            <a:ext cx="6766560" cy="1280160"/>
           </a:xfrm>
           <a:prstGeom prst="rect">
             <a:avLst/>
@@ -22388,7 +22388,7 @@
               <a:buNone/>
             </a:pPr>
             <a:r>
-              <a:rPr lang="en-US" sz="1400" dirty="0">
+              <a:rPr lang="en-US" sz="1250" dirty="0">
                 <a:solidFill>
                   <a:srgbClr val="1A1A2E"/>
                 </a:solidFill>
@@ -22396,9 +22396,9 @@
                 <a:ea typeface="Calibri" pitchFamily="34" charset="-122"/>
                 <a:cs typeface="Calibri" pitchFamily="34" charset="-120"/>
               </a:rPr>
-              <a:t>Contextual reasoning buys a great deal on sentiment and nothing demonstrable on severity, which lexical markers already carry. The production stage's severity shift is partly the seed labels' own calibration: a second rating, of unverified independent provenance, put seven of ten seed-critical items at high (kappa 0.55, weighted 0.70). The precondition can be met by more than one method; a deployer has a choice, not an instruction.</a:t>
-            </a:r>
-            <a:endParaRPr lang="en-US" sz="1400" dirty="0"/>
+              <a:t>Which learned or contextual predictor is better is not decided on this corpus. The production stage's risk shift is partly the seed labels' own calibration: a second rating, reported as second-rating agreement with independent human provenance unverified, put seven of ten seed-critical items at high (kappa 0.55, weighted 0.70). Escalation recall under the seed labels falls to 28 of 50 on either production model. A deployer has a choice, not an instruction.</a:t>
+            </a:r>
+            <a:endParaRPr lang="en-US" sz="1250" dirty="0"/>
           </a:p>
         </p:txBody>
       </p:sp>

</xml_diff>